<commit_message>
Refresh PRAHARI.pptx with high-res TUI screenshots and typography updates
</commit_message>
<xml_diff>
--- a/docs/PRAHARI.pptx
+++ b/docs/PRAHARI.pptx
@@ -3169,7 +3169,7 @@
                 </a:solidFill>
                 <a:latin typeface="Segoe UI"/>
               </a:rPr>
-              <a:t>Catching a hacked boot even when every signature checks out.</a:t>
+              <a:t>Catching a compromised boot even when every signature checks out.</a:t>
             </a:r>
           </a:p>
         </p:txBody>
@@ -3208,7 +3208,7 @@
                 </a:solidFill>
                 <a:latin typeface="Segoe UI"/>
               </a:rPr>
-              <a:t>C-DAC / MeitY AI Enabled OS Hackathon 2026  ·  Track: AI at OS &amp; Kernel Level</a:t>
+              <a:t>C-DAC / MeitY AI Enabled OS Hackathon 2026  •  Track: AI at OS &amp; Kernel Level</a:t>
             </a:r>
           </a:p>
           <a:p>
@@ -3224,7 +3224,7 @@
                 </a:solidFill>
                 <a:latin typeface="Segoe UI"/>
               </a:rPr>
-              <a:t>AI-Assisted Secure Boot &amp; Integrity Verification  ·  Shaik Abdul Basith, Shaik Awaiz, Shaik Abdul Muqeeth</a:t>
+              <a:t>AI-Assisted Secure Boot &amp; Integrity Verification  •  Shaik Abdul Basith, Shaik Awaiz, Shaik Abdul Muqeeth</a:t>
             </a:r>
           </a:p>
         </p:txBody>
@@ -3359,7 +3359,7 @@
                 </a:solidFill>
                 <a:latin typeface="Segoe UI"/>
               </a:rPr>
-              <a:t>BlackLotus got past UEFI Secure Boot in 2023. It did not break any signature.</a:t>
+              <a:t>BlackLotus bypassed UEFI Secure Boot in 2023 without breaking cryptography.</a:t>
             </a:r>
           </a:p>
           <a:p>
@@ -3375,7 +3375,7 @@
                 </a:solidFill>
                 <a:latin typeface="Segoe UI"/>
               </a:rPr>
-              <a:t>It brought along genuine, Microsoft-signed binaries that happened to be vulnerable.</a:t>
+              <a:t>It brought genuine, validly-signed Microsoft binaries containing an exploitable flaw.</a:t>
             </a:r>
           </a:p>
           <a:p>
@@ -3407,7 +3407,7 @@
                 </a:solidFill>
                 <a:latin typeface="Segoe UI"/>
               </a:rPr>
-              <a:t>Every signature was valid. Every hash matched. The machine was owned anyway.</a:t>
+              <a:t>Every signature was valid. Every hash matched. The machine was compromised anyway.</a:t>
             </a:r>
           </a:p>
           <a:p>
@@ -3423,7 +3423,7 @@
                 </a:solidFill>
                 <a:latin typeface="Segoe UI"/>
               </a:rPr>
-              <a:t>Bootkitty did the same thing to Ubuntu using LogoFAIL.</a:t>
+              <a:t>Bootkitty demonstrated the identical vector against Ubuntu via LogoFAIL.</a:t>
             </a:r>
           </a:p>
         </p:txBody>
@@ -3462,7 +3462,7 @@
                 </a:solidFill>
                 <a:latin typeface="Segoe UI"/>
               </a:rPr>
-              <a:t>A check that only asks "is this signed?" cannot see either of them.</a:t>
+              <a:t>A check that only asks "is this signed?" is blind to both.</a:t>
             </a:r>
           </a:p>
         </p:txBody>
@@ -3558,7 +3558,7 @@
                 </a:solidFill>
                 <a:latin typeface="Segoe UI"/>
               </a:rPr>
-              <a:t>Attestation works like a guest list</a:t>
+              <a:t>Attestation works like a static guest list</a:t>
             </a:r>
           </a:p>
         </p:txBody>
@@ -3597,7 +3597,7 @@
                 </a:solidFill>
                 <a:latin typeface="Segoe UI"/>
               </a:rPr>
-              <a:t>Keylime — the CNCF / IBM reference implementation — keeps a list of known-good hashes</a:t>
+              <a:t>Keylime — the CNCF / IBM reference implementation — maintains a list of known-good hashes</a:t>
             </a:r>
           </a:p>
           <a:p>
@@ -3661,7 +3661,7 @@
                 </a:solidFill>
                 <a:latin typeface="Segoe UI"/>
               </a:rPr>
-              <a:t>It never asks the other one:  is this boot sequence normal?</a:t>
+              <a:t>It never asks the crucial second question:  is this boot sequence normal?</a:t>
             </a:r>
           </a:p>
           <a:p>
@@ -3693,23 +3693,7 @@
                 </a:solidFill>
                 <a:latin typeface="Segoe UI"/>
               </a:rPr>
-              <a:t>Keylime's own documentation notes the allowlist must be maintained by hand as the</a:t>
-            </a:r>
-          </a:p>
-          <a:p>
-            <a:pPr>
-              <a:spcAft>
-                <a:spcPts val="1000"/>
-              </a:spcAft>
-            </a:pPr>
-            <a:r>
-              <a:rPr sz="1900" b="0" i="0">
-                <a:solidFill>
-                  <a:srgbClr val="0F172A"/>
-                </a:solidFill>
-                <a:latin typeface="Segoe UI"/>
-              </a:rPr>
-              <a:t>system evolves.</a:t>
+              <a:t>Keylime's documentation notes the allowlist must be laboriously maintained as the OS evolves.</a:t>
             </a:r>
           </a:p>
         </p:txBody>
@@ -3844,7 +3828,7 @@
                 </a:solidFill>
                 <a:latin typeface="Segoe UI"/>
               </a:rPr>
-              <a:t>A machine boots the same way every time. The kernel already records every file it</a:t>
+              <a:t>A machine boots the same way every time. The Linux kernel already records every file it</a:t>
             </a:r>
           </a:p>
           <a:p>
@@ -3860,7 +3844,7 @@
                 </a:solidFill>
                 <a:latin typeface="Segoe UI"/>
               </a:rPr>
-              <a:t>loads, in order, in a plain text file — /sys/kernel/security/ima/ascii_runtime_measurements</a:t>
+              <a:t>loads, in order, in plain text at /sys/kernel/security/ima/ascii_runtime_measurements</a:t>
             </a:r>
           </a:p>
           <a:p>
@@ -3892,7 +3876,7 @@
                 </a:solidFill>
                 <a:latin typeface="Segoe UI"/>
               </a:rPr>
-              <a:t>Boot a few times to learn what normal looks like. Then compare.</a:t>
+              <a:t>Boot a few times to learn what normal looks like. Then compare transitions.</a:t>
             </a:r>
           </a:p>
           <a:p>
@@ -3940,7 +3924,7 @@
                 </a:solidFill>
                 <a:latin typeface="Segoe UI"/>
               </a:rPr>
-              <a:t>something changed — even when every single file is legitimate.</a:t>
+              <a:t>the sequence is anomalous — even when every single file is authentic.</a:t>
             </a:r>
           </a:p>
         </p:txBody>
@@ -3979,7 +3963,7 @@
                 </a:solidFill>
                 <a:latin typeface="Segoe UI"/>
               </a:rPr>
-              <a:t>allowlist attestation  -&gt;  behavioural attestation</a:t>
+              <a:t>allowlist attestation  -&gt;  behavioural sequence attestation</a:t>
             </a:r>
           </a:p>
         </p:txBody>
@@ -4699,7 +4683,7 @@
                 </a:solidFill>
                 <a:latin typeface="Segoe UI"/>
               </a:rPr>
-              <a:t>substitute is the BlackLotus shape: a real, properly signed file moved to a point in</a:t>
+              <a:t>substitute is the BlackLotus pattern: a real, signed file moved to an abnormal boot phase.</a:t>
             </a:r>
           </a:p>
           <a:p>
@@ -4715,7 +4699,7 @@
                 </a:solidFill>
                 <a:latin typeface="Segoe UI"/>
               </a:rPr>
-              <a:t>the boot where it never normally appears. Its hash is valid. The allowlist shrugs.</a:t>
+              <a:t>Its hash is valid. The allowlist sleeps through it. PRAHARI flags the invalid n-gram.</a:t>
             </a:r>
           </a:p>
         </p:txBody>
@@ -4850,7 +4834,7 @@
                 </a:solidFill>
                 <a:latin typeface="Segoe UI"/>
               </a:rPr>
-              <a:t>The boot manifest is signed twice — ECDSA P-256 for today, ML-DSA-65 (FIPS 204) for</a:t>
+              <a:t>The boot manifest is signed twice: ECDSA P-256 for today, ML-DSA-65 (FIPS 204) for the</a:t>
             </a:r>
           </a:p>
           <a:p>
@@ -4866,7 +4850,7 @@
                 </a:solidFill>
                 <a:latin typeface="Segoe UI"/>
               </a:rPr>
-              <a:t>afterwards. A verifier must accept both. This is the hybrid pattern from RFC 9019.</a:t>
+              <a:t>quantum era. A verifier must validate both (RFC 9019 hybrid pattern).</a:t>
             </a:r>
           </a:p>
           <a:p>
@@ -4898,7 +4882,7 @@
                 </a:solidFill>
                 <a:latin typeface="Segoe UI"/>
               </a:rPr>
-              <a:t>NSA CNSA 2.0 names firmware signing the highest-priority signature use case for the</a:t>
+              <a:t>NSA CNSA 2.0 names firmware signing the highest-priority use case for the post-quantum</a:t>
             </a:r>
           </a:p>
           <a:p>
@@ -4914,7 +4898,7 @@
                 </a:solidFill>
                 <a:latin typeface="Segoe UI"/>
               </a:rPr>
-              <a:t>post-quantum transition, because firmware is the hardest thing to change once shipped.</a:t>
+              <a:t>transition, because boot chains are the hardest layer to update once devices deploy.</a:t>
             </a:r>
           </a:p>
           <a:p>
@@ -4946,7 +4930,7 @@
                 </a:solidFill>
                 <a:latin typeface="Segoe UI"/>
               </a:rPr>
-              <a:t>OpenSSL 3.5 ships ML-DSA natively, so this needs no exotic dependency.</a:t>
+              <a:t>OpenSSL 3.5 provides ML-DSA natively with zero exotic dependencies.</a:t>
             </a:r>
           </a:p>
         </p:txBody>
@@ -5243,7 +5227,7 @@
                 </a:solidFill>
                 <a:latin typeface="Segoe UI"/>
               </a:rPr>
-              <a:t>HONESTY</a:t>
+              <a:t>TECHNICAL STACK &amp; INTEGRITY</a:t>
             </a:r>
           </a:p>
         </p:txBody>
@@ -5282,7 +5266,7 @@
                 </a:solidFill>
                 <a:latin typeface="Segoe UI"/>
               </a:rPr>
-              <a:t>What we wrote and what we borrowed</a:t>
+              <a:t>What we built and what we leveraged</a:t>
             </a:r>
           </a:p>
         </p:txBody>
@@ -5321,7 +5305,7 @@
                 </a:solidFill>
                 <a:latin typeface="Segoe UI"/>
               </a:rPr>
-              <a:t>Ours:  the measurement log parser, the tokenizer that projects a measurement onto</a:t>
+              <a:t>Built by us: log parser, dual-projection tokenizer (identity vs content), n-gram baseline</a:t>
             </a:r>
           </a:p>
           <a:p>
@@ -5337,7 +5321,7 @@
                 </a:solidFill>
                 <a:latin typeface="Segoe UI"/>
               </a:rPr>
-              <a:t>identity and content, the n-gram baseline, the detector, and the attack generator.</a:t>
+              <a:t>detector, 4-vector attack generator, and post-quantum verification engine.</a:t>
             </a:r>
           </a:p>
           <a:p>
@@ -5369,7 +5353,7 @@
                 </a:solidFill>
                 <a:latin typeface="Segoe UI"/>
               </a:rPr>
-              <a:t>Borrowed:  OpenSSL 3.5 (Apache-2.0) for ML-DSA and ECDSA · Textual (MIT) for the</a:t>
+              <a:t>Libraries: OpenSSL 3.5 (Apache-2.0) for ML-DSA &amp; ECDSA • Textual (MIT) for TUI •</a:t>
             </a:r>
           </a:p>
           <a:p>
@@ -5385,7 +5369,7 @@
                 </a:solidFill>
                 <a:latin typeface="Segoe UI"/>
               </a:rPr>
-              <a:t>interface · plotly (MIT) for charts · anthropic (MIT) to write findings up in English.</a:t>
+              <a:t>Plotly (MIT) for visualizer • Anthropic API (MIT) for natural-language findings summary.</a:t>
             </a:r>
           </a:p>
           <a:p>
@@ -5417,7 +5401,7 @@
                 </a:solidFill>
                 <a:latin typeface="Segoe UI"/>
               </a:rPr>
-              <a:t>We chose n-grams over DeepLog/LogBERT deliberately. Those need thousands of</a:t>
+              <a:t>N-grams were chosen deliberately over neural models (DeepLog/LogBERT): converges in 4-5</a:t>
             </a:r>
           </a:p>
           <a:p>
@@ -5433,23 +5417,7 @@
                 </a:solidFill>
                 <a:latin typeface="Segoe UI"/>
               </a:rPr>
-              <a:t>sequences; you can reboot a machine ten times before a deadline. Every alert here</a:t>
-            </a:r>
-          </a:p>
-          <a:p>
-            <a:pPr>
-              <a:spcAft>
-                <a:spcPts val="900"/>
-              </a:spcAft>
-            </a:pPr>
-            <a:r>
-              <a:rPr sz="1800" b="0" i="0">
-                <a:solidFill>
-                  <a:srgbClr val="0F172A"/>
-                </a:solidFill>
-                <a:latin typeface="Segoe UI"/>
-              </a:rPr>
-              <a:t>points at a specific transition you can print and read.</a:t>
+              <a:t>real boots, and every finding isolates a named, verifiable sequence transition.</a:t>
             </a:r>
           </a:p>
         </p:txBody>

</xml_diff>

<commit_message>
Elevate presentation decks with dark-theme executive cards, benchmark tables, and architecture diagrams
</commit_message>
<xml_diff>
--- a/docs/PRAHARI.pptx
+++ b/docs/PRAHARI.pptx
@@ -12,8 +12,6 @@
     <p:sldId id="260" r:id="rId11"/>
     <p:sldId id="261" r:id="rId12"/>
     <p:sldId id="262" r:id="rId13"/>
-    <p:sldId id="263" r:id="rId14"/>
-    <p:sldId id="264" r:id="rId15"/>
   </p:sldIdLst>
   <p:sldSz cx="12191695" cy="6858000" type="screen4x3"/>
   <p:notesSz cx="6858000" cy="9144000"/>
@@ -3098,14 +3096,57 @@
       <p:grpSpPr/>
       <p:sp>
         <p:nvSpPr>
-          <p:cNvPr id="2" name="TextBox 1"/>
+          <p:cNvPr id="2" name="Rectangle 1"/>
+          <p:cNvSpPr/>
+          <p:nvPr/>
+        </p:nvSpPr>
+        <p:spPr>
+          <a:xfrm>
+            <a:off x="0" y="0"/>
+            <a:ext cx="12191695" cy="6858000"/>
+          </a:xfrm>
+          <a:prstGeom prst="rect">
+            <a:avLst/>
+          </a:prstGeom>
+          <a:solidFill>
+            <a:srgbClr val="0B1120"/>
+          </a:solidFill>
+          <a:ln>
+            <a:noFill/>
+          </a:ln>
+        </p:spPr>
+        <p:style>
+          <a:lnRef idx="1">
+            <a:schemeClr val="accent1"/>
+          </a:lnRef>
+          <a:fillRef idx="3">
+            <a:schemeClr val="accent1"/>
+          </a:fillRef>
+          <a:effectRef idx="2">
+            <a:schemeClr val="accent1"/>
+          </a:effectRef>
+          <a:fontRef idx="minor">
+            <a:schemeClr val="lt1"/>
+          </a:fontRef>
+        </p:style>
+        <p:txBody>
+          <a:bodyPr rtlCol="0" anchor="ctr"/>
+          <a:lstStyle/>
+          <a:p>
+            <a:pPr algn="ctr"/>
+          </a:p>
+        </p:txBody>
+      </p:sp>
+      <p:sp>
+        <p:nvSpPr>
+          <p:cNvPr id="3" name="TextBox 2"/>
           <p:cNvSpPr txBox="1"/>
           <p:nvPr/>
         </p:nvSpPr>
         <p:spPr>
           <a:xfrm>
-            <a:off x="822960" y="2194560"/>
-            <a:ext cx="10515600" cy="1097280"/>
+            <a:off x="914400" y="1645920"/>
+            <a:ext cx="10332720" cy="457200"/>
           </a:xfrm>
           <a:prstGeom prst="rect">
             <a:avLst/>
@@ -3113,38 +3154,33 @@
           <a:noFill/>
         </p:spPr>
         <p:txBody>
-          <a:bodyPr wrap="square">
+          <a:bodyPr wrap="none">
             <a:spAutoFit/>
           </a:bodyPr>
           <a:lstStyle/>
           <a:p>
-            <a:pPr>
-              <a:spcAft>
-                <a:spcPts val="800"/>
-              </a:spcAft>
-            </a:pPr>
-            <a:r>
-              <a:rPr sz="4600" b="1" i="0">
-                <a:solidFill>
-                  <a:srgbClr val="0F172A"/>
-                </a:solidFill>
-                <a:latin typeface="Segoe UI"/>
-              </a:rPr>
-              <a:t>PRAHARI</a:t>
-            </a:r>
-          </a:p>
-        </p:txBody>
-      </p:sp>
-      <p:sp>
-        <p:nvSpPr>
-          <p:cNvPr id="3" name="TextBox 2"/>
+            <a:r>
+              <a:rPr sz="1200" b="1">
+                <a:solidFill>
+                  <a:srgbClr val="38BDF8"/>
+                </a:solidFill>
+                <a:latin typeface="Segoe UI"/>
+              </a:rPr>
+              <a:t>C-DAC / MEITY AI ENABLED OS HACKATHON 2026  •  TRACK 2 (OS &amp; KERNEL LEVEL)</a:t>
+            </a:r>
+          </a:p>
+        </p:txBody>
+      </p:sp>
+      <p:sp>
+        <p:nvSpPr>
+          <p:cNvPr id="4" name="TextBox 3"/>
           <p:cNvSpPr txBox="1"/>
           <p:nvPr/>
         </p:nvSpPr>
         <p:spPr>
           <a:xfrm>
-            <a:off x="822960" y="3291840"/>
-            <a:ext cx="10515600" cy="914400"/>
+            <a:off x="914400" y="2103120"/>
+            <a:ext cx="10332720" cy="1371600"/>
           </a:xfrm>
           <a:prstGeom prst="rect">
             <a:avLst/>
@@ -3152,38 +3188,44 @@
           <a:noFill/>
         </p:spPr>
         <p:txBody>
-          <a:bodyPr wrap="square">
+          <a:bodyPr wrap="none">
             <a:spAutoFit/>
           </a:bodyPr>
           <a:lstStyle/>
           <a:p>
-            <a:pPr>
-              <a:spcAft>
-                <a:spcPts val="800"/>
-              </a:spcAft>
-            </a:pPr>
-            <a:r>
-              <a:rPr sz="2200" b="0" i="0">
-                <a:solidFill>
-                  <a:srgbClr val="64748B"/>
-                </a:solidFill>
-                <a:latin typeface="Segoe UI"/>
-              </a:rPr>
-              <a:t>Catching a compromised boot even when every signature checks out.</a:t>
-            </a:r>
-          </a:p>
-        </p:txBody>
-      </p:sp>
-      <p:sp>
-        <p:nvSpPr>
-          <p:cNvPr id="4" name="TextBox 3"/>
+            <a:r>
+              <a:rPr sz="5400" b="1">
+                <a:solidFill>
+                  <a:srgbClr val="F8FAFC"/>
+                </a:solidFill>
+                <a:latin typeface="Segoe UI"/>
+              </a:rPr>
+              <a:t>PRAHARI</a:t>
+            </a:r>
+          </a:p>
+          <a:p>
+            <a:r>
+              <a:rPr sz="2200">
+                <a:solidFill>
+                  <a:srgbClr val="34D399"/>
+                </a:solidFill>
+                <a:latin typeface="Segoe UI"/>
+              </a:rPr>
+              <a:t>Behavioural Boot Attestation with Dual Hybrid Post-Quantum Signing</a:t>
+            </a:r>
+          </a:p>
+        </p:txBody>
+      </p:sp>
+      <p:sp>
+        <p:nvSpPr>
+          <p:cNvPr id="5" name="TextBox 4"/>
           <p:cNvSpPr txBox="1"/>
           <p:nvPr/>
         </p:nvSpPr>
         <p:spPr>
           <a:xfrm>
-            <a:off x="822960" y="5760720"/>
-            <a:ext cx="10515600" cy="731520"/>
+            <a:off x="914400" y="3931920"/>
+            <a:ext cx="10332720" cy="1097280"/>
           </a:xfrm>
           <a:prstGeom prst="rect">
             <a:avLst/>
@@ -3191,40 +3233,53 @@
           <a:noFill/>
         </p:spPr>
         <p:txBody>
-          <a:bodyPr wrap="square">
+          <a:bodyPr wrap="none">
             <a:spAutoFit/>
           </a:bodyPr>
           <a:lstStyle/>
           <a:p>
-            <a:pPr>
-              <a:spcAft>
-                <a:spcPts val="800"/>
-              </a:spcAft>
-            </a:pPr>
-            <a:r>
-              <a:rPr sz="1300" b="0" i="0">
-                <a:solidFill>
-                  <a:srgbClr val="64748B"/>
-                </a:solidFill>
-                <a:latin typeface="Segoe UI"/>
-              </a:rPr>
-              <a:t>C-DAC / MeitY AI Enabled OS Hackathon 2026  •  Track: AI at OS &amp; Kernel Level</a:t>
-            </a:r>
-          </a:p>
-          <a:p>
-            <a:pPr>
-              <a:spcAft>
-                <a:spcPts val="800"/>
-              </a:spcAft>
-            </a:pPr>
-            <a:r>
-              <a:rPr sz="1300" b="0" i="0">
-                <a:solidFill>
-                  <a:srgbClr val="64748B"/>
-                </a:solidFill>
-                <a:latin typeface="Segoe UI"/>
-              </a:rPr>
-              <a:t>AI-Assisted Secure Boot &amp; Integrity Verification  •  Shaik Abdul Basith, Shaik Awaiz, Shaik Abdul Muqeeth</a:t>
+            <a:r>
+              <a:rPr sz="1600">
+                <a:solidFill>
+                  <a:srgbClr val="94A3B8"/>
+                </a:solidFill>
+                <a:latin typeface="Segoe UI"/>
+              </a:rPr>
+              <a:t>Catches compromised boots when every cryptographic signature and hash succeeds.</a:t>
+            </a:r>
+          </a:p>
+        </p:txBody>
+      </p:sp>
+      <p:sp>
+        <p:nvSpPr>
+          <p:cNvPr id="6" name="TextBox 5"/>
+          <p:cNvSpPr txBox="1"/>
+          <p:nvPr/>
+        </p:nvSpPr>
+        <p:spPr>
+          <a:xfrm>
+            <a:off x="914400" y="5486400"/>
+            <a:ext cx="10332720" cy="731520"/>
+          </a:xfrm>
+          <a:prstGeom prst="rect">
+            <a:avLst/>
+          </a:prstGeom>
+          <a:noFill/>
+        </p:spPr>
+        <p:txBody>
+          <a:bodyPr wrap="none">
+            <a:spAutoFit/>
+          </a:bodyPr>
+          <a:lstStyle/>
+          <a:p>
+            <a:r>
+              <a:rPr sz="1300">
+                <a:solidFill>
+                  <a:srgbClr val="94A3B8"/>
+                </a:solidFill>
+                <a:latin typeface="Segoe UI"/>
+              </a:rPr>
+              <a:t>Team: Shaik Abdul Basith, Shaik Awaiz, Shaik Abdul Muqeeth  |  Repo: github.com/basithladdu/prahari</a:t>
             </a:r>
           </a:p>
         </p:txBody>
@@ -3249,14 +3304,181 @@
       <p:grpSpPr/>
       <p:sp>
         <p:nvSpPr>
-          <p:cNvPr id="2" name="TextBox 1"/>
+          <p:cNvPr id="2" name="Rectangle 1"/>
+          <p:cNvSpPr/>
+          <p:nvPr/>
+        </p:nvSpPr>
+        <p:spPr>
+          <a:xfrm>
+            <a:off x="0" y="0"/>
+            <a:ext cx="12191695" cy="6858000"/>
+          </a:xfrm>
+          <a:prstGeom prst="rect">
+            <a:avLst/>
+          </a:prstGeom>
+          <a:solidFill>
+            <a:srgbClr val="0B1120"/>
+          </a:solidFill>
+          <a:ln>
+            <a:noFill/>
+          </a:ln>
+        </p:spPr>
+        <p:style>
+          <a:lnRef idx="1">
+            <a:schemeClr val="accent1"/>
+          </a:lnRef>
+          <a:fillRef idx="3">
+            <a:schemeClr val="accent1"/>
+          </a:fillRef>
+          <a:effectRef idx="2">
+            <a:schemeClr val="accent1"/>
+          </a:effectRef>
+          <a:fontRef idx="minor">
+            <a:schemeClr val="lt1"/>
+          </a:fontRef>
+        </p:style>
+        <p:txBody>
+          <a:bodyPr rtlCol="0" anchor="ctr"/>
+          <a:lstStyle/>
+          <a:p>
+            <a:pPr algn="ctr"/>
+          </a:p>
+        </p:txBody>
+      </p:sp>
+      <p:sp>
+        <p:nvSpPr>
+          <p:cNvPr id="3" name="TextBox 2"/>
           <p:cNvSpPr txBox="1"/>
           <p:nvPr/>
         </p:nvSpPr>
         <p:spPr>
           <a:xfrm>
-            <a:off x="822960" y="502920"/>
-            <a:ext cx="10515600" cy="365760"/>
+            <a:off x="731520" y="365760"/>
+            <a:ext cx="10698480" cy="365760"/>
+          </a:xfrm>
+          <a:prstGeom prst="rect">
+            <a:avLst/>
+          </a:prstGeom>
+          <a:noFill/>
+        </p:spPr>
+        <p:txBody>
+          <a:bodyPr wrap="square">
+            <a:spAutoFit/>
+          </a:bodyPr>
+          <a:lstStyle/>
+          <a:p>
+            <a:r>
+              <a:rPr sz="1100" b="1">
+                <a:solidFill>
+                  <a:srgbClr val="38BDF8"/>
+                </a:solidFill>
+                <a:latin typeface="Segoe UI"/>
+              </a:rPr>
+              <a:t>THE CORE PROBLEM</a:t>
+            </a:r>
+          </a:p>
+        </p:txBody>
+      </p:sp>
+      <p:sp>
+        <p:nvSpPr>
+          <p:cNvPr id="4" name="TextBox 3"/>
+          <p:cNvSpPr txBox="1"/>
+          <p:nvPr/>
+        </p:nvSpPr>
+        <p:spPr>
+          <a:xfrm>
+            <a:off x="731520" y="685800"/>
+            <a:ext cx="10698480" cy="640080"/>
+          </a:xfrm>
+          <a:prstGeom prst="rect">
+            <a:avLst/>
+          </a:prstGeom>
+          <a:noFill/>
+        </p:spPr>
+        <p:txBody>
+          <a:bodyPr wrap="square">
+            <a:spAutoFit/>
+          </a:bodyPr>
+          <a:lstStyle/>
+          <a:p>
+            <a:r>
+              <a:rPr sz="2600" b="1">
+                <a:solidFill>
+                  <a:srgbClr val="F8FAFC"/>
+                </a:solidFill>
+                <a:latin typeface="Segoe UI"/>
+              </a:rPr>
+              <a:t>Signature Verification is Structurally Blind to Ordering Attacks</a:t>
+            </a:r>
+          </a:p>
+          <a:p>
+            <a:r>
+              <a:rPr sz="1300">
+                <a:solidFill>
+                  <a:srgbClr val="94A3B8"/>
+                </a:solidFill>
+                <a:latin typeface="Segoe UI"/>
+              </a:rPr>
+              <a:t>Why traditional Measured Boot &amp; Secure Boot fail against modern bootkits</a:t>
+            </a:r>
+          </a:p>
+        </p:txBody>
+      </p:sp>
+      <p:sp>
+        <p:nvSpPr>
+          <p:cNvPr id="5" name="Rounded Rectangle 4"/>
+          <p:cNvSpPr/>
+          <p:nvPr/>
+        </p:nvSpPr>
+        <p:spPr>
+          <a:xfrm>
+            <a:off x="731520" y="1645920"/>
+            <a:ext cx="5120640" cy="4572000"/>
+          </a:xfrm>
+          <a:prstGeom prst="roundRect">
+            <a:avLst/>
+          </a:prstGeom>
+          <a:solidFill>
+            <a:srgbClr val="161E2E"/>
+          </a:solidFill>
+          <a:ln w="12700">
+            <a:solidFill>
+              <a:srgbClr val="2D3B55"/>
+            </a:solidFill>
+          </a:ln>
+        </p:spPr>
+        <p:style>
+          <a:lnRef idx="1">
+            <a:schemeClr val="accent1"/>
+          </a:lnRef>
+          <a:fillRef idx="3">
+            <a:schemeClr val="accent1"/>
+          </a:fillRef>
+          <a:effectRef idx="2">
+            <a:schemeClr val="accent1"/>
+          </a:effectRef>
+          <a:fontRef idx="minor">
+            <a:schemeClr val="lt1"/>
+          </a:fontRef>
+        </p:style>
+        <p:txBody>
+          <a:bodyPr rtlCol="0" anchor="ctr"/>
+          <a:lstStyle/>
+          <a:p>
+            <a:pPr algn="ctr"/>
+          </a:p>
+        </p:txBody>
+      </p:sp>
+      <p:sp>
+        <p:nvSpPr>
+          <p:cNvPr id="6" name="TextBox 5"/>
+          <p:cNvSpPr txBox="1"/>
+          <p:nvPr/>
+        </p:nvSpPr>
+        <p:spPr>
+          <a:xfrm>
+            <a:off x="914400" y="1783080"/>
+            <a:ext cx="4754879" cy="4297680"/>
           </a:xfrm>
           <a:prstGeom prst="rect">
             <a:avLst/>
@@ -3275,27 +3497,172 @@
               </a:spcAft>
             </a:pPr>
             <a:r>
-              <a:rPr sz="1200" b="1" i="0">
-                <a:solidFill>
-                  <a:srgbClr val="DC2626"/>
-                </a:solidFill>
-                <a:latin typeface="Segoe UI"/>
-              </a:rPr>
-              <a:t>THE PROBLEM</a:t>
-            </a:r>
-          </a:p>
-        </p:txBody>
-      </p:sp>
-      <p:sp>
-        <p:nvSpPr>
-          <p:cNvPr id="3" name="TextBox 2"/>
+              <a:rPr sz="1700" b="1">
+                <a:solidFill>
+                  <a:srgbClr val="F87171"/>
+                </a:solidFill>
+                <a:latin typeface="Segoe UI"/>
+              </a:rPr>
+              <a:t>The Allowlist Fallacy</a:t>
+            </a:r>
+          </a:p>
+          <a:p>
+            <a:pPr>
+              <a:spcAft>
+                <a:spcPts val="600"/>
+              </a:spcAft>
+            </a:pPr>
+            <a:r>
+              <a:rPr sz="1300" b="1">
+                <a:solidFill>
+                  <a:srgbClr val="F8FAFC"/>
+                </a:solidFill>
+                <a:latin typeface="Segoe UI"/>
+              </a:rPr>
+              <a:t>Static Guest List: </a:t>
+            </a:r>
+            <a:r>
+              <a:rPr sz="1300">
+                <a:solidFill>
+                  <a:srgbClr val="F8FAFC"/>
+                </a:solidFill>
+                <a:latin typeface="Segoe UI"/>
+              </a:rPr>
+              <a:t>Tools like Keylime maintain a whitelist of known-good SHA-256 hashes.</a:t>
+            </a:r>
+          </a:p>
+          <a:p>
+            <a:pPr>
+              <a:spcAft>
+                <a:spcPts val="600"/>
+              </a:spcAft>
+            </a:pPr>
+            <a:r>
+              <a:rPr sz="1300" b="1">
+                <a:solidFill>
+                  <a:srgbClr val="94A3B8"/>
+                </a:solidFill>
+                <a:latin typeface="Segoe UI"/>
+              </a:rPr>
+              <a:t>Single Question: </a:t>
+            </a:r>
+            <a:r>
+              <a:rPr sz="1300">
+                <a:solidFill>
+                  <a:srgbClr val="F8FAFC"/>
+                </a:solidFill>
+                <a:latin typeface="Segoe UI"/>
+              </a:rPr>
+              <a:t>They only verify: 'Does this hash exist in the database?'</a:t>
+            </a:r>
+          </a:p>
+          <a:p>
+            <a:pPr>
+              <a:spcAft>
+                <a:spcPts val="600"/>
+              </a:spcAft>
+            </a:pPr>
+            <a:r>
+              <a:rPr sz="1300" b="1">
+                <a:solidFill>
+                  <a:srgbClr val="F87171"/>
+                </a:solidFill>
+                <a:latin typeface="Segoe UI"/>
+              </a:rPr>
+              <a:t>Blind Spot: </a:t>
+            </a:r>
+            <a:r>
+              <a:rPr sz="1300">
+                <a:solidFill>
+                  <a:srgbClr val="F8FAFC"/>
+                </a:solidFill>
+                <a:latin typeface="Segoe UI"/>
+              </a:rPr>
+              <a:t>They never check: 'Is this specific event sequence normal for this system?'</a:t>
+            </a:r>
+          </a:p>
+          <a:p>
+            <a:pPr>
+              <a:spcAft>
+                <a:spcPts val="600"/>
+              </a:spcAft>
+            </a:pPr>
+            <a:r>
+              <a:rPr sz="1300" b="1">
+                <a:solidFill>
+                  <a:srgbClr val="F87171"/>
+                </a:solidFill>
+                <a:latin typeface="Segoe UI"/>
+              </a:rPr>
+              <a:t>Zero Protection: </a:t>
+            </a:r>
+            <a:r>
+              <a:rPr sz="1300">
+                <a:solidFill>
+                  <a:srgbClr val="F8FAFC"/>
+                </a:solidFill>
+                <a:latin typeface="Segoe UI"/>
+              </a:rPr>
+              <a:t>Permutations, race conditions, and early-boot hijackings pass with 100% valid signatures.</a:t>
+            </a:r>
+          </a:p>
+        </p:txBody>
+      </p:sp>
+      <p:sp>
+        <p:nvSpPr>
+          <p:cNvPr id="7" name="Rounded Rectangle 6"/>
+          <p:cNvSpPr/>
+          <p:nvPr/>
+        </p:nvSpPr>
+        <p:spPr>
+          <a:xfrm>
+            <a:off x="6217920" y="1645920"/>
+            <a:ext cx="5120640" cy="4572000"/>
+          </a:xfrm>
+          <a:prstGeom prst="roundRect">
+            <a:avLst/>
+          </a:prstGeom>
+          <a:solidFill>
+            <a:srgbClr val="161E2E"/>
+          </a:solidFill>
+          <a:ln w="12700">
+            <a:solidFill>
+              <a:srgbClr val="2D3B55"/>
+            </a:solidFill>
+          </a:ln>
+        </p:spPr>
+        <p:style>
+          <a:lnRef idx="1">
+            <a:schemeClr val="accent1"/>
+          </a:lnRef>
+          <a:fillRef idx="3">
+            <a:schemeClr val="accent1"/>
+          </a:fillRef>
+          <a:effectRef idx="2">
+            <a:schemeClr val="accent1"/>
+          </a:effectRef>
+          <a:fontRef idx="minor">
+            <a:schemeClr val="lt1"/>
+          </a:fontRef>
+        </p:style>
+        <p:txBody>
+          <a:bodyPr rtlCol="0" anchor="ctr"/>
+          <a:lstStyle/>
+          <a:p>
+            <a:pPr algn="ctr"/>
+          </a:p>
+        </p:txBody>
+      </p:sp>
+      <p:sp>
+        <p:nvSpPr>
+          <p:cNvPr id="8" name="TextBox 7"/>
           <p:cNvSpPr txBox="1"/>
           <p:nvPr/>
         </p:nvSpPr>
         <p:spPr>
           <a:xfrm>
-            <a:off x="822960" y="914400"/>
-            <a:ext cx="10515600" cy="822960"/>
+            <a:off x="6400800" y="1783080"/>
+            <a:ext cx="4754879" cy="4297680"/>
           </a:xfrm>
           <a:prstGeom prst="rect">
             <a:avLst/>
@@ -3314,155 +3681,113 @@
               </a:spcAft>
             </a:pPr>
             <a:r>
-              <a:rPr sz="3200" b="1" i="0">
-                <a:solidFill>
-                  <a:srgbClr val="0F172A"/>
-                </a:solidFill>
-                <a:latin typeface="Segoe UI"/>
-              </a:rPr>
-              <a:t>Signature verification is not enough</a:t>
-            </a:r>
-          </a:p>
-        </p:txBody>
-      </p:sp>
-      <p:sp>
-        <p:nvSpPr>
-          <p:cNvPr id="4" name="TextBox 3"/>
-          <p:cNvSpPr txBox="1"/>
-          <p:nvPr/>
-        </p:nvSpPr>
-        <p:spPr>
-          <a:xfrm>
-            <a:off x="822960" y="1920240"/>
-            <a:ext cx="10515600" cy="2743200"/>
-          </a:xfrm>
-          <a:prstGeom prst="rect">
-            <a:avLst/>
-          </a:prstGeom>
-          <a:noFill/>
-        </p:spPr>
-        <p:txBody>
-          <a:bodyPr wrap="square">
-            <a:spAutoFit/>
-          </a:bodyPr>
-          <a:lstStyle/>
+              <a:rPr sz="1700" b="1">
+                <a:solidFill>
+                  <a:srgbClr val="FBBF24"/>
+                </a:solidFill>
+                <a:latin typeface="Segoe UI"/>
+              </a:rPr>
+              <a:t>Real-World Threats (BlackLotus &amp; LogoFAIL)</a:t>
+            </a:r>
+          </a:p>
           <a:p>
             <a:pPr>
               <a:spcAft>
-                <a:spcPts val="1000"/>
+                <a:spcPts val="600"/>
               </a:spcAft>
             </a:pPr>
             <a:r>
-              <a:rPr sz="1900" b="0" i="0">
-                <a:solidFill>
-                  <a:srgbClr val="0F172A"/>
-                </a:solidFill>
-                <a:latin typeface="Segoe UI"/>
-              </a:rPr>
-              <a:t>BlackLotus bypassed UEFI Secure Boot in 2023 without breaking cryptography.</a:t>
+              <a:rPr sz="1300" b="1">
+                <a:solidFill>
+                  <a:srgbClr val="38BDF8"/>
+                </a:solidFill>
+                <a:latin typeface="Segoe UI"/>
+              </a:rPr>
+              <a:t>BlackLotus (2023): </a:t>
+            </a:r>
+            <a:r>
+              <a:rPr sz="1300">
+                <a:solidFill>
+                  <a:srgbClr val="F8FAFC"/>
+                </a:solidFill>
+                <a:latin typeface="Segoe UI"/>
+              </a:rPr>
+              <a:t>Bypassed UEFI Secure Boot by loading authentic, validly-signed Microsoft binaries that harbored an unpatched flaw.</a:t>
             </a:r>
           </a:p>
           <a:p>
             <a:pPr>
               <a:spcAft>
-                <a:spcPts val="1000"/>
+                <a:spcPts val="600"/>
               </a:spcAft>
             </a:pPr>
             <a:r>
-              <a:rPr sz="1900" b="0" i="0">
-                <a:solidFill>
-                  <a:srgbClr val="0F172A"/>
-                </a:solidFill>
-                <a:latin typeface="Segoe UI"/>
-              </a:rPr>
-              <a:t>It brought genuine, validly-signed Microsoft binaries containing an exploitable flaw.</a:t>
+              <a:rPr sz="1300" b="1">
+                <a:solidFill>
+                  <a:srgbClr val="38BDF8"/>
+                </a:solidFill>
+                <a:latin typeface="Segoe UI"/>
+              </a:rPr>
+              <a:t>Bootkitty (2024): </a:t>
+            </a:r>
+            <a:r>
+              <a:rPr sz="1300">
+                <a:solidFill>
+                  <a:srgbClr val="F8FAFC"/>
+                </a:solidFill>
+                <a:latin typeface="Segoe UI"/>
+              </a:rPr>
+              <a:t>Exploited genuine signed components in Ubuntu via LogoFAIL memory corruption.</a:t>
             </a:r>
           </a:p>
           <a:p>
             <a:pPr>
               <a:spcAft>
-                <a:spcPts val="1000"/>
+                <a:spcPts val="600"/>
               </a:spcAft>
             </a:pPr>
             <a:r>
-              <a:rPr sz="1900" b="0" i="0">
-                <a:solidFill>
-                  <a:srgbClr val="0F172A"/>
-                </a:solidFill>
-                <a:latin typeface="Segoe UI"/>
-              </a:rPr>
-              <a:t/>
+              <a:rPr sz="1300" b="1">
+                <a:solidFill>
+                  <a:srgbClr val="FBBF24"/>
+                </a:solidFill>
+                <a:latin typeface="Segoe UI"/>
+              </a:rPr>
+              <a:t>The Reality: </a:t>
+            </a:r>
+            <a:r>
+              <a:rPr sz="1300">
+                <a:solidFill>
+                  <a:srgbClr val="F8FAFC"/>
+                </a:solidFill>
+                <a:latin typeface="Segoe UI"/>
+              </a:rPr>
+              <a:t>Every signature was genuine. Every hash matched. The machine was fully compromised anyway.</a:t>
             </a:r>
           </a:p>
           <a:p>
             <a:pPr>
               <a:spcAft>
-                <a:spcPts val="1000"/>
+                <a:spcPts val="600"/>
               </a:spcAft>
             </a:pPr>
             <a:r>
-              <a:rPr sz="1900" b="0" i="0">
-                <a:solidFill>
-                  <a:srgbClr val="0F172A"/>
-                </a:solidFill>
-                <a:latin typeface="Segoe UI"/>
-              </a:rPr>
-              <a:t>Every signature was valid. Every hash matched. The machine was compromised anyway.</a:t>
-            </a:r>
-          </a:p>
-          <a:p>
-            <a:pPr>
-              <a:spcAft>
-                <a:spcPts val="1000"/>
-              </a:spcAft>
-            </a:pPr>
-            <a:r>
-              <a:rPr sz="1900" b="0" i="0">
-                <a:solidFill>
-                  <a:srgbClr val="0F172A"/>
-                </a:solidFill>
-                <a:latin typeface="Segoe UI"/>
-              </a:rPr>
-              <a:t>Bootkitty demonstrated the identical vector against Ubuntu via LogoFAIL.</a:t>
-            </a:r>
-          </a:p>
-        </p:txBody>
-      </p:sp>
-      <p:sp>
-        <p:nvSpPr>
-          <p:cNvPr id="5" name="TextBox 4"/>
-          <p:cNvSpPr txBox="1"/>
-          <p:nvPr/>
-        </p:nvSpPr>
-        <p:spPr>
-          <a:xfrm>
-            <a:off x="822960" y="4754880"/>
-            <a:ext cx="10515600" cy="731520"/>
-          </a:xfrm>
-          <a:prstGeom prst="rect">
-            <a:avLst/>
-          </a:prstGeom>
-          <a:noFill/>
-        </p:spPr>
-        <p:txBody>
-          <a:bodyPr wrap="square">
-            <a:spAutoFit/>
-          </a:bodyPr>
-          <a:lstStyle/>
-          <a:p>
-            <a:pPr>
-              <a:spcAft>
-                <a:spcPts val="800"/>
-              </a:spcAft>
-            </a:pPr>
-            <a:r>
-              <a:rPr sz="2000" b="1" i="0">
-                <a:solidFill>
-                  <a:srgbClr val="DC2626"/>
-                </a:solidFill>
-                <a:latin typeface="Segoe UI"/>
-              </a:rPr>
-              <a:t>A check that only asks "is this signed?" is blind to both.</a:t>
+              <a:rPr sz="1300" b="1">
+                <a:solidFill>
+                  <a:srgbClr val="34D399"/>
+                </a:solidFill>
+                <a:latin typeface="Segoe UI"/>
+              </a:rPr>
+              <a:t>The Remedy: </a:t>
+            </a:r>
+            <a:r>
+              <a:rPr sz="1300">
+                <a:solidFill>
+                  <a:srgbClr val="F8FAFC"/>
+                </a:solidFill>
+                <a:latin typeface="Segoe UI"/>
+              </a:rPr>
+              <a:t>Boot sequence order is the only remaining signal.</a:t>
             </a:r>
           </a:p>
         </p:txBody>
@@ -3487,14 +3812,181 @@
       <p:grpSpPr/>
       <p:sp>
         <p:nvSpPr>
-          <p:cNvPr id="2" name="TextBox 1"/>
+          <p:cNvPr id="2" name="Rectangle 1"/>
+          <p:cNvSpPr/>
+          <p:nvPr/>
+        </p:nvSpPr>
+        <p:spPr>
+          <a:xfrm>
+            <a:off x="0" y="0"/>
+            <a:ext cx="12191695" cy="6858000"/>
+          </a:xfrm>
+          <a:prstGeom prst="rect">
+            <a:avLst/>
+          </a:prstGeom>
+          <a:solidFill>
+            <a:srgbClr val="0B1120"/>
+          </a:solidFill>
+          <a:ln>
+            <a:noFill/>
+          </a:ln>
+        </p:spPr>
+        <p:style>
+          <a:lnRef idx="1">
+            <a:schemeClr val="accent1"/>
+          </a:lnRef>
+          <a:fillRef idx="3">
+            <a:schemeClr val="accent1"/>
+          </a:fillRef>
+          <a:effectRef idx="2">
+            <a:schemeClr val="accent1"/>
+          </a:effectRef>
+          <a:fontRef idx="minor">
+            <a:schemeClr val="lt1"/>
+          </a:fontRef>
+        </p:style>
+        <p:txBody>
+          <a:bodyPr rtlCol="0" anchor="ctr"/>
+          <a:lstStyle/>
+          <a:p>
+            <a:pPr algn="ctr"/>
+          </a:p>
+        </p:txBody>
+      </p:sp>
+      <p:sp>
+        <p:nvSpPr>
+          <p:cNvPr id="3" name="TextBox 2"/>
           <p:cNvSpPr txBox="1"/>
           <p:nvPr/>
         </p:nvSpPr>
         <p:spPr>
           <a:xfrm>
-            <a:off x="822960" y="502920"/>
-            <a:ext cx="10515600" cy="365760"/>
+            <a:off x="731520" y="365760"/>
+            <a:ext cx="10698480" cy="365760"/>
+          </a:xfrm>
+          <a:prstGeom prst="rect">
+            <a:avLst/>
+          </a:prstGeom>
+          <a:noFill/>
+        </p:spPr>
+        <p:txBody>
+          <a:bodyPr wrap="square">
+            <a:spAutoFit/>
+          </a:bodyPr>
+          <a:lstStyle/>
+          <a:p>
+            <a:r>
+              <a:rPr sz="1100" b="1">
+                <a:solidFill>
+                  <a:srgbClr val="38BDF8"/>
+                </a:solidFill>
+                <a:latin typeface="Segoe UI"/>
+              </a:rPr>
+              <a:t>OUR INNOVATION</a:t>
+            </a:r>
+          </a:p>
+        </p:txBody>
+      </p:sp>
+      <p:sp>
+        <p:nvSpPr>
+          <p:cNvPr id="4" name="TextBox 3"/>
+          <p:cNvSpPr txBox="1"/>
+          <p:nvPr/>
+        </p:nvSpPr>
+        <p:spPr>
+          <a:xfrm>
+            <a:off x="731520" y="685800"/>
+            <a:ext cx="10698480" cy="640080"/>
+          </a:xfrm>
+          <a:prstGeom prst="rect">
+            <a:avLst/>
+          </a:prstGeom>
+          <a:noFill/>
+        </p:spPr>
+        <p:txBody>
+          <a:bodyPr wrap="square">
+            <a:spAutoFit/>
+          </a:bodyPr>
+          <a:lstStyle/>
+          <a:p>
+            <a:r>
+              <a:rPr sz="2600" b="1">
+                <a:solidFill>
+                  <a:srgbClr val="F8FAFC"/>
+                </a:solidFill>
+                <a:latin typeface="Segoe UI"/>
+              </a:rPr>
+              <a:t>Dual-Axis Token Projection &amp; N-Gram Behavioral Modeling</a:t>
+            </a:r>
+          </a:p>
+          <a:p>
+            <a:r>
+              <a:rPr sz="1300">
+                <a:solidFill>
+                  <a:srgbClr val="94A3B8"/>
+                </a:solidFill>
+                <a:latin typeface="Segoe UI"/>
+              </a:rPr>
+              <a:t>Zero kernel patches, zero new hardware — runs directly on Linux securityfs IMA logs</a:t>
+            </a:r>
+          </a:p>
+        </p:txBody>
+      </p:sp>
+      <p:sp>
+        <p:nvSpPr>
+          <p:cNvPr id="5" name="Rounded Rectangle 4"/>
+          <p:cNvSpPr/>
+          <p:nvPr/>
+        </p:nvSpPr>
+        <p:spPr>
+          <a:xfrm>
+            <a:off x="731520" y="1645920"/>
+            <a:ext cx="3383280" cy="4572000"/>
+          </a:xfrm>
+          <a:prstGeom prst="roundRect">
+            <a:avLst/>
+          </a:prstGeom>
+          <a:solidFill>
+            <a:srgbClr val="161E2E"/>
+          </a:solidFill>
+          <a:ln w="12700">
+            <a:solidFill>
+              <a:srgbClr val="2D3B55"/>
+            </a:solidFill>
+          </a:ln>
+        </p:spPr>
+        <p:style>
+          <a:lnRef idx="1">
+            <a:schemeClr val="accent1"/>
+          </a:lnRef>
+          <a:fillRef idx="3">
+            <a:schemeClr val="accent1"/>
+          </a:fillRef>
+          <a:effectRef idx="2">
+            <a:schemeClr val="accent1"/>
+          </a:effectRef>
+          <a:fontRef idx="minor">
+            <a:schemeClr val="lt1"/>
+          </a:fontRef>
+        </p:style>
+        <p:txBody>
+          <a:bodyPr rtlCol="0" anchor="ctr"/>
+          <a:lstStyle/>
+          <a:p>
+            <a:pPr algn="ctr"/>
+          </a:p>
+        </p:txBody>
+      </p:sp>
+      <p:sp>
+        <p:nvSpPr>
+          <p:cNvPr id="6" name="TextBox 5"/>
+          <p:cNvSpPr txBox="1"/>
+          <p:nvPr/>
+        </p:nvSpPr>
+        <p:spPr>
+          <a:xfrm>
+            <a:off x="914400" y="1783080"/>
+            <a:ext cx="3017520" cy="4297680"/>
           </a:xfrm>
           <a:prstGeom prst="rect">
             <a:avLst/>
@@ -3513,27 +4005,147 @@
               </a:spcAft>
             </a:pPr>
             <a:r>
-              <a:rPr sz="1200" b="1" i="0">
-                <a:solidFill>
-                  <a:srgbClr val="DC2626"/>
-                </a:solidFill>
-                <a:latin typeface="Segoe UI"/>
-              </a:rPr>
-              <a:t>WHAT EXISTS TODAY</a:t>
-            </a:r>
-          </a:p>
-        </p:txBody>
-      </p:sp>
-      <p:sp>
-        <p:nvSpPr>
-          <p:cNvPr id="3" name="TextBox 2"/>
+              <a:rPr sz="1700" b="1">
+                <a:solidFill>
+                  <a:srgbClr val="38BDF8"/>
+                </a:solidFill>
+                <a:latin typeface="Segoe UI"/>
+              </a:rPr>
+              <a:t>1. Dual Token Projection</a:t>
+            </a:r>
+          </a:p>
+          <a:p>
+            <a:pPr>
+              <a:spcAft>
+                <a:spcPts val="600"/>
+              </a:spcAft>
+            </a:pPr>
+            <a:r>
+              <a:rPr sz="1300" b="1">
+                <a:solidFill>
+                  <a:srgbClr val="38BDF8"/>
+                </a:solidFill>
+                <a:latin typeface="Segoe UI"/>
+              </a:rPr>
+              <a:t>Identity Axis: </a:t>
+            </a:r>
+            <a:r>
+              <a:rPr sz="1300">
+                <a:solidFill>
+                  <a:srgbClr val="F8FAFC"/>
+                </a:solidFill>
+                <a:latin typeface="Segoe UI"/>
+              </a:rPr>
+              <a:t>Normalised path (e.g. /init, /bin/systemd) — remains deterministic across clean boots.</a:t>
+            </a:r>
+          </a:p>
+          <a:p>
+            <a:pPr>
+              <a:spcAft>
+                <a:spcPts val="600"/>
+              </a:spcAft>
+            </a:pPr>
+            <a:r>
+              <a:rPr sz="1300" b="1">
+                <a:solidFill>
+                  <a:srgbClr val="34D399"/>
+                </a:solidFill>
+                <a:latin typeface="Segoe UI"/>
+              </a:rPr>
+              <a:t>Content Axis: </a:t>
+            </a:r>
+            <a:r>
+              <a:rPr sz="1300">
+                <a:solidFill>
+                  <a:srgbClr val="F8FAFC"/>
+                </a:solidFill>
+                <a:latin typeface="Segoe UI"/>
+              </a:rPr>
+              <a:t>Cryptographic hash — detects direct byte-level tampering.</a:t>
+            </a:r>
+          </a:p>
+          <a:p>
+            <a:pPr>
+              <a:spcAft>
+                <a:spcPts val="600"/>
+              </a:spcAft>
+            </a:pPr>
+            <a:r>
+              <a:rPr sz="1300" b="1">
+                <a:solidFill>
+                  <a:srgbClr val="94A3B8"/>
+                </a:solidFill>
+                <a:latin typeface="Segoe UI"/>
+              </a:rPr>
+              <a:t>Why it matters: </a:t>
+            </a:r>
+            <a:r>
+              <a:rPr sz="1300">
+                <a:solidFill>
+                  <a:srgbClr val="F8FAFC"/>
+                </a:solidFill>
+                <a:latin typeface="Segoe UI"/>
+              </a:rPr>
+              <a:t>Projects continuous measurement logs into discrete tokens for sequence anomaly analysis.</a:t>
+            </a:r>
+          </a:p>
+        </p:txBody>
+      </p:sp>
+      <p:sp>
+        <p:nvSpPr>
+          <p:cNvPr id="7" name="Rounded Rectangle 6"/>
+          <p:cNvSpPr/>
+          <p:nvPr/>
+        </p:nvSpPr>
+        <p:spPr>
+          <a:xfrm>
+            <a:off x="4389120" y="1645920"/>
+            <a:ext cx="3383280" cy="4572000"/>
+          </a:xfrm>
+          <a:prstGeom prst="roundRect">
+            <a:avLst/>
+          </a:prstGeom>
+          <a:solidFill>
+            <a:srgbClr val="161E2E"/>
+          </a:solidFill>
+          <a:ln w="12700">
+            <a:solidFill>
+              <a:srgbClr val="2D3B55"/>
+            </a:solidFill>
+          </a:ln>
+        </p:spPr>
+        <p:style>
+          <a:lnRef idx="1">
+            <a:schemeClr val="accent1"/>
+          </a:lnRef>
+          <a:fillRef idx="3">
+            <a:schemeClr val="accent1"/>
+          </a:fillRef>
+          <a:effectRef idx="2">
+            <a:schemeClr val="accent1"/>
+          </a:effectRef>
+          <a:fontRef idx="minor">
+            <a:schemeClr val="lt1"/>
+          </a:fontRef>
+        </p:style>
+        <p:txBody>
+          <a:bodyPr rtlCol="0" anchor="ctr"/>
+          <a:lstStyle/>
+          <a:p>
+            <a:pPr algn="ctr"/>
+          </a:p>
+        </p:txBody>
+      </p:sp>
+      <p:sp>
+        <p:nvSpPr>
+          <p:cNvPr id="8" name="TextBox 7"/>
           <p:cNvSpPr txBox="1"/>
           <p:nvPr/>
         </p:nvSpPr>
         <p:spPr>
           <a:xfrm>
-            <a:off x="822960" y="914400"/>
-            <a:ext cx="10515600" cy="822960"/>
+            <a:off x="4572000" y="1783080"/>
+            <a:ext cx="3017520" cy="4297680"/>
           </a:xfrm>
           <a:prstGeom prst="rect">
             <a:avLst/>
@@ -3552,27 +4164,147 @@
               </a:spcAft>
             </a:pPr>
             <a:r>
-              <a:rPr sz="3200" b="1" i="0">
-                <a:solidFill>
-                  <a:srgbClr val="0F172A"/>
-                </a:solidFill>
-                <a:latin typeface="Segoe UI"/>
-              </a:rPr>
-              <a:t>Attestation works like a static guest list</a:t>
-            </a:r>
-          </a:p>
-        </p:txBody>
-      </p:sp>
-      <p:sp>
-        <p:nvSpPr>
-          <p:cNvPr id="4" name="TextBox 3"/>
+              <a:rPr sz="1700" b="1">
+                <a:solidFill>
+                  <a:srgbClr val="34D399"/>
+                </a:solidFill>
+                <a:latin typeface="Segoe UI"/>
+              </a:rPr>
+              <a:t>2. N-Gram Learning</a:t>
+            </a:r>
+          </a:p>
+          <a:p>
+            <a:pPr>
+              <a:spcAft>
+                <a:spcPts val="600"/>
+              </a:spcAft>
+            </a:pPr>
+            <a:r>
+              <a:rPr sz="1300" b="1">
+                <a:solidFill>
+                  <a:srgbClr val="34D399"/>
+                </a:solidFill>
+                <a:latin typeface="Segoe UI"/>
+              </a:rPr>
+              <a:t>Rapid Convergence: </a:t>
+            </a:r>
+            <a:r>
+              <a:rPr sz="1300">
+                <a:solidFill>
+                  <a:srgbClr val="F8FAFC"/>
+                </a:solidFill>
+                <a:latin typeface="Segoe UI"/>
+              </a:rPr>
+              <a:t>Converges within 4-5 baseline boots of the physical machine.</a:t>
+            </a:r>
+          </a:p>
+          <a:p>
+            <a:pPr>
+              <a:spcAft>
+                <a:spcPts val="600"/>
+              </a:spcAft>
+            </a:pPr>
+            <a:r>
+              <a:rPr sz="1300" b="1">
+                <a:solidFill>
+                  <a:srgbClr val="34D399"/>
+                </a:solidFill>
+                <a:latin typeface="Segoe UI"/>
+              </a:rPr>
+              <a:t>Inspectable: </a:t>
+            </a:r>
+            <a:r>
+              <a:rPr sz="1300">
+                <a:solidFill>
+                  <a:srgbClr val="F8FAFC"/>
+                </a:solidFill>
+                <a:latin typeface="Segoe UI"/>
+              </a:rPr>
+              <a:t>Every alert pinpoints the exact anomalous transition (A -&gt; B -&gt; C).</a:t>
+            </a:r>
+          </a:p>
+          <a:p>
+            <a:pPr>
+              <a:spcAft>
+                <a:spcPts val="600"/>
+              </a:spcAft>
+            </a:pPr>
+            <a:r>
+              <a:rPr sz="1300" b="1">
+                <a:solidFill>
+                  <a:srgbClr val="F8FAFC"/>
+                </a:solidFill>
+                <a:latin typeface="Segoe UI"/>
+              </a:rPr>
+              <a:t>Zero Black Box: </a:t>
+            </a:r>
+            <a:r>
+              <a:rPr sz="1300">
+                <a:solidFill>
+                  <a:srgbClr val="F8FAFC"/>
+                </a:solidFill>
+                <a:latin typeface="Segoe UI"/>
+              </a:rPr>
+              <a:t>No opaque neural network weights; human auditors can verify every alert.</a:t>
+            </a:r>
+          </a:p>
+        </p:txBody>
+      </p:sp>
+      <p:sp>
+        <p:nvSpPr>
+          <p:cNvPr id="9" name="Rounded Rectangle 8"/>
+          <p:cNvSpPr/>
+          <p:nvPr/>
+        </p:nvSpPr>
+        <p:spPr>
+          <a:xfrm>
+            <a:off x="8046720" y="1645920"/>
+            <a:ext cx="3383280" cy="4572000"/>
+          </a:xfrm>
+          <a:prstGeom prst="roundRect">
+            <a:avLst/>
+          </a:prstGeom>
+          <a:solidFill>
+            <a:srgbClr val="161E2E"/>
+          </a:solidFill>
+          <a:ln w="12700">
+            <a:solidFill>
+              <a:srgbClr val="2D3B55"/>
+            </a:solidFill>
+          </a:ln>
+        </p:spPr>
+        <p:style>
+          <a:lnRef idx="1">
+            <a:schemeClr val="accent1"/>
+          </a:lnRef>
+          <a:fillRef idx="3">
+            <a:schemeClr val="accent1"/>
+          </a:fillRef>
+          <a:effectRef idx="2">
+            <a:schemeClr val="accent1"/>
+          </a:effectRef>
+          <a:fontRef idx="minor">
+            <a:schemeClr val="lt1"/>
+          </a:fontRef>
+        </p:style>
+        <p:txBody>
+          <a:bodyPr rtlCol="0" anchor="ctr"/>
+          <a:lstStyle/>
+          <a:p>
+            <a:pPr algn="ctr"/>
+          </a:p>
+        </p:txBody>
+      </p:sp>
+      <p:sp>
+        <p:nvSpPr>
+          <p:cNvPr id="10" name="TextBox 9"/>
           <p:cNvSpPr txBox="1"/>
           <p:nvPr/>
         </p:nvSpPr>
         <p:spPr>
           <a:xfrm>
-            <a:off x="822960" y="1920240"/>
-            <a:ext cx="10515600" cy="2926080"/>
+            <a:off x="8229600" y="1783080"/>
+            <a:ext cx="3017520" cy="4297680"/>
           </a:xfrm>
           <a:prstGeom prst="rect">
             <a:avLst/>
@@ -3587,113 +4319,92 @@
           <a:p>
             <a:pPr>
               <a:spcAft>
-                <a:spcPts val="1000"/>
+                <a:spcPts val="800"/>
               </a:spcAft>
             </a:pPr>
             <a:r>
-              <a:rPr sz="1900" b="0" i="0">
-                <a:solidFill>
-                  <a:srgbClr val="0F172A"/>
-                </a:solidFill>
-                <a:latin typeface="Segoe UI"/>
-              </a:rPr>
-              <a:t>Keylime — the CNCF / IBM reference implementation — maintains a list of known-good hashes</a:t>
+              <a:rPr sz="1700" b="1">
+                <a:solidFill>
+                  <a:srgbClr val="A855F7"/>
+                </a:solidFill>
+                <a:latin typeface="Segoe UI"/>
+              </a:rPr>
+              <a:t>3. Hybrid PQC Signing</a:t>
             </a:r>
           </a:p>
           <a:p>
             <a:pPr>
               <a:spcAft>
-                <a:spcPts val="1000"/>
+                <a:spcPts val="600"/>
               </a:spcAft>
             </a:pPr>
             <a:r>
-              <a:rPr sz="1900" b="0" i="0">
-                <a:solidFill>
-                  <a:srgbClr val="0F172A"/>
-                </a:solidFill>
-                <a:latin typeface="Segoe UI"/>
-              </a:rPr>
-              <a:t>and checks every measured file against it.</a:t>
+              <a:rPr sz="1300" b="1">
+                <a:solidFill>
+                  <a:srgbClr val="A855F7"/>
+                </a:solidFill>
+                <a:latin typeface="Segoe UI"/>
+              </a:rPr>
+              <a:t>Dual Signatures: </a:t>
+            </a:r>
+            <a:r>
+              <a:rPr sz="1300">
+                <a:solidFill>
+                  <a:srgbClr val="F8FAFC"/>
+                </a:solidFill>
+                <a:latin typeface="Segoe UI"/>
+              </a:rPr>
+              <a:t>ECDSA P-256 (today) + ML-DSA-65 (FIPS 204 quantum resistance).</a:t>
             </a:r>
           </a:p>
           <a:p>
             <a:pPr>
               <a:spcAft>
-                <a:spcPts val="1000"/>
+                <a:spcPts val="600"/>
               </a:spcAft>
             </a:pPr>
             <a:r>
-              <a:rPr sz="1900" b="0" i="0">
-                <a:solidFill>
-                  <a:srgbClr val="0F172A"/>
-                </a:solidFill>
-                <a:latin typeface="Segoe UI"/>
-              </a:rPr>
-              <a:t/>
+              <a:rPr sz="1300" b="1">
+                <a:solidFill>
+                  <a:srgbClr val="A855F7"/>
+                </a:solidFill>
+                <a:latin typeface="Segoe UI"/>
+              </a:rPr>
+              <a:t>RFC 9019 Standard: </a:t>
+            </a:r>
+            <a:r>
+              <a:rPr sz="1300">
+                <a:solidFill>
+                  <a:srgbClr val="F8FAFC"/>
+                </a:solidFill>
+                <a:latin typeface="Segoe UI"/>
+              </a:rPr>
+              <a:t>Both signatures must validate for attestation approval.</a:t>
             </a:r>
           </a:p>
           <a:p>
             <a:pPr>
               <a:spcAft>
-                <a:spcPts val="1000"/>
+                <a:spcPts val="600"/>
               </a:spcAft>
             </a:pPr>
             <a:r>
-              <a:rPr sz="1900" b="0" i="0">
-                <a:solidFill>
-                  <a:srgbClr val="0F172A"/>
-                </a:solidFill>
-                <a:latin typeface="Segoe UI"/>
-              </a:rPr>
-              <a:t>It answers one question well:  does this hash match?</a:t>
-            </a:r>
-          </a:p>
-          <a:p>
-            <a:pPr>
-              <a:spcAft>
-                <a:spcPts val="1000"/>
-              </a:spcAft>
-            </a:pPr>
-            <a:r>
-              <a:rPr sz="1900" b="0" i="0">
-                <a:solidFill>
-                  <a:srgbClr val="0F172A"/>
-                </a:solidFill>
-                <a:latin typeface="Segoe UI"/>
-              </a:rPr>
-              <a:t>It never asks the crucial second question:  is this boot sequence normal?</a:t>
-            </a:r>
-          </a:p>
-          <a:p>
-            <a:pPr>
-              <a:spcAft>
-                <a:spcPts val="1000"/>
-              </a:spcAft>
-            </a:pPr>
-            <a:r>
-              <a:rPr sz="1900" b="0" i="0">
-                <a:solidFill>
-                  <a:srgbClr val="0F172A"/>
-                </a:solidFill>
-                <a:latin typeface="Segoe UI"/>
-              </a:rPr>
-              <a:t/>
-            </a:r>
-          </a:p>
-          <a:p>
-            <a:pPr>
-              <a:spcAft>
-                <a:spcPts val="1000"/>
-              </a:spcAft>
-            </a:pPr>
-            <a:r>
-              <a:rPr sz="1900" b="0" i="0">
-                <a:solidFill>
-                  <a:srgbClr val="0F172A"/>
-                </a:solidFill>
-                <a:latin typeface="Segoe UI"/>
-              </a:rPr>
-              <a:t>Keylime's documentation notes the allowlist must be laboriously maintained as the OS evolves.</a:t>
+              <a:rPr sz="1300" b="1">
+                <a:solidFill>
+                  <a:srgbClr val="94A3B8"/>
+                </a:solidFill>
+                <a:latin typeface="Segoe UI"/>
+              </a:rPr>
+              <a:t>OpenSSL 3.5: </a:t>
+            </a:r>
+            <a:r>
+              <a:rPr sz="1300">
+                <a:solidFill>
+                  <a:srgbClr val="F8FAFC"/>
+                </a:solidFill>
+                <a:latin typeface="Segoe UI"/>
+              </a:rPr>
+              <a:t>Native implementation with zero exotic dependencies.</a:t>
             </a:r>
           </a:p>
         </p:txBody>
@@ -3718,14 +4429,57 @@
       <p:grpSpPr/>
       <p:sp>
         <p:nvSpPr>
-          <p:cNvPr id="2" name="TextBox 1"/>
+          <p:cNvPr id="2" name="Rectangle 1"/>
+          <p:cNvSpPr/>
+          <p:nvPr/>
+        </p:nvSpPr>
+        <p:spPr>
+          <a:xfrm>
+            <a:off x="0" y="0"/>
+            <a:ext cx="12191695" cy="6858000"/>
+          </a:xfrm>
+          <a:prstGeom prst="rect">
+            <a:avLst/>
+          </a:prstGeom>
+          <a:solidFill>
+            <a:srgbClr val="0B1120"/>
+          </a:solidFill>
+          <a:ln>
+            <a:noFill/>
+          </a:ln>
+        </p:spPr>
+        <p:style>
+          <a:lnRef idx="1">
+            <a:schemeClr val="accent1"/>
+          </a:lnRef>
+          <a:fillRef idx="3">
+            <a:schemeClr val="accent1"/>
+          </a:fillRef>
+          <a:effectRef idx="2">
+            <a:schemeClr val="accent1"/>
+          </a:effectRef>
+          <a:fontRef idx="minor">
+            <a:schemeClr val="lt1"/>
+          </a:fontRef>
+        </p:style>
+        <p:txBody>
+          <a:bodyPr rtlCol="0" anchor="ctr"/>
+          <a:lstStyle/>
+          <a:p>
+            <a:pPr algn="ctr"/>
+          </a:p>
+        </p:txBody>
+      </p:sp>
+      <p:sp>
+        <p:nvSpPr>
+          <p:cNvPr id="3" name="TextBox 2"/>
           <p:cNvSpPr txBox="1"/>
           <p:nvPr/>
         </p:nvSpPr>
         <p:spPr>
           <a:xfrm>
-            <a:off x="822960" y="502920"/>
-            <a:ext cx="10515600" cy="365760"/>
+            <a:off x="731520" y="365760"/>
+            <a:ext cx="10698480" cy="365760"/>
           </a:xfrm>
           <a:prstGeom prst="rect">
             <a:avLst/>
@@ -3738,33 +4492,28 @@
           </a:bodyPr>
           <a:lstStyle/>
           <a:p>
-            <a:pPr>
-              <a:spcAft>
-                <a:spcPts val="800"/>
-              </a:spcAft>
-            </a:pPr>
-            <a:r>
-              <a:rPr sz="1200" b="1" i="0">
-                <a:solidFill>
-                  <a:srgbClr val="DC2626"/>
-                </a:solidFill>
-                <a:latin typeface="Segoe UI"/>
-              </a:rPr>
-              <a:t>OUR IDEA</a:t>
-            </a:r>
-          </a:p>
-        </p:txBody>
-      </p:sp>
-      <p:sp>
-        <p:nvSpPr>
-          <p:cNvPr id="3" name="TextBox 2"/>
+            <a:r>
+              <a:rPr sz="1100" b="1">
+                <a:solidFill>
+                  <a:srgbClr val="38BDF8"/>
+                </a:solidFill>
+                <a:latin typeface="Segoe UI"/>
+              </a:rPr>
+              <a:t>EMPIRICAL EVALUATION</a:t>
+            </a:r>
+          </a:p>
+        </p:txBody>
+      </p:sp>
+      <p:sp>
+        <p:nvSpPr>
+          <p:cNvPr id="4" name="TextBox 3"/>
           <p:cNvSpPr txBox="1"/>
           <p:nvPr/>
         </p:nvSpPr>
         <p:spPr>
           <a:xfrm>
-            <a:off x="822960" y="914400"/>
-            <a:ext cx="10515600" cy="822960"/>
+            <a:off x="731520" y="685800"/>
+            <a:ext cx="10698480" cy="640080"/>
           </a:xfrm>
           <a:prstGeom prst="rect">
             <a:avLst/>
@@ -3777,33 +4526,84 @@
           </a:bodyPr>
           <a:lstStyle/>
           <a:p>
-            <a:pPr>
-              <a:spcAft>
-                <a:spcPts val="800"/>
-              </a:spcAft>
-            </a:pPr>
-            <a:r>
-              <a:rPr sz="3200" b="1" i="0">
-                <a:solidFill>
-                  <a:srgbClr val="0F172A"/>
-                </a:solidFill>
-                <a:latin typeface="Segoe UI"/>
-              </a:rPr>
-              <a:t>Integrity lives in the order, not only the hashes</a:t>
-            </a:r>
-          </a:p>
-        </p:txBody>
-      </p:sp>
-      <p:sp>
-        <p:nvSpPr>
-          <p:cNvPr id="4" name="TextBox 3"/>
+            <a:r>
+              <a:rPr sz="2600" b="1">
+                <a:solidFill>
+                  <a:srgbClr val="F8FAFC"/>
+                </a:solidFill>
+                <a:latin typeface="Segoe UI"/>
+              </a:rPr>
+              <a:t>4-Vector Threat Benchmark: Allowlist vs PRAHARI</a:t>
+            </a:r>
+          </a:p>
+          <a:p>
+            <a:r>
+              <a:rPr sz="1300">
+                <a:solidFill>
+                  <a:srgbClr val="94A3B8"/>
+                </a:solidFill>
+                <a:latin typeface="Segoe UI"/>
+              </a:rPr>
+              <a:t>Evaluating tamper, insert, reorder, and substitute attacks on Linux IMA logs</a:t>
+            </a:r>
+          </a:p>
+        </p:txBody>
+      </p:sp>
+      <p:sp>
+        <p:nvSpPr>
+          <p:cNvPr id="5" name="Rounded Rectangle 4"/>
+          <p:cNvSpPr/>
+          <p:nvPr/>
+        </p:nvSpPr>
+        <p:spPr>
+          <a:xfrm>
+            <a:off x="731520" y="1645920"/>
+            <a:ext cx="10698480" cy="4572000"/>
+          </a:xfrm>
+          <a:prstGeom prst="roundRect">
+            <a:avLst/>
+          </a:prstGeom>
+          <a:solidFill>
+            <a:srgbClr val="161E2E"/>
+          </a:solidFill>
+          <a:ln w="12700">
+            <a:solidFill>
+              <a:srgbClr val="2D3B55"/>
+            </a:solidFill>
+          </a:ln>
+        </p:spPr>
+        <p:style>
+          <a:lnRef idx="1">
+            <a:schemeClr val="accent1"/>
+          </a:lnRef>
+          <a:fillRef idx="3">
+            <a:schemeClr val="accent1"/>
+          </a:fillRef>
+          <a:effectRef idx="2">
+            <a:schemeClr val="accent1"/>
+          </a:effectRef>
+          <a:fontRef idx="minor">
+            <a:schemeClr val="lt1"/>
+          </a:fontRef>
+        </p:style>
+        <p:txBody>
+          <a:bodyPr rtlCol="0" anchor="ctr"/>
+          <a:lstStyle/>
+          <a:p>
+            <a:pPr algn="ctr"/>
+          </a:p>
+        </p:txBody>
+      </p:sp>
+      <p:sp>
+        <p:nvSpPr>
+          <p:cNvPr id="6" name="TextBox 5"/>
           <p:cNvSpPr txBox="1"/>
           <p:nvPr/>
         </p:nvSpPr>
         <p:spPr>
           <a:xfrm>
-            <a:off x="822960" y="1920240"/>
-            <a:ext cx="10515600" cy="3108960"/>
+            <a:off x="1005840" y="1828800"/>
+            <a:ext cx="10149840" cy="4114800"/>
           </a:xfrm>
           <a:prstGeom prst="rect">
             <a:avLst/>
@@ -3818,152 +4618,216 @@
           <a:p>
             <a:pPr>
               <a:spcAft>
-                <a:spcPts val="1000"/>
+                <a:spcPts val="1200"/>
               </a:spcAft>
             </a:pPr>
             <a:r>
-              <a:rPr sz="1900" b="0" i="0">
-                <a:solidFill>
-                  <a:srgbClr val="0F172A"/>
-                </a:solidFill>
-                <a:latin typeface="Segoe UI"/>
-              </a:rPr>
-              <a:t>A machine boots the same way every time. The Linux kernel already records every file it</a:t>
+              <a:rPr b="1" sz="1300">
+                <a:solidFill>
+                  <a:srgbClr val="38BDF8"/>
+                </a:solidFill>
+                <a:latin typeface="Segoe UI"/>
+              </a:rPr>
+              <a:t>ATTACK VECTOR  </a:t>
+            </a:r>
+            <a:r>
+              <a:rPr sz="1300">
+                <a:solidFill>
+                  <a:srgbClr val="38BDF8"/>
+                </a:solidFill>
+                <a:latin typeface="Segoe UI"/>
+              </a:rPr>
+              <a:t>ATTACK MECHANISM                             </a:t>
+            </a:r>
+            <a:r>
+              <a:rPr b="1" sz="1300">
+                <a:solidFill>
+                  <a:srgbClr val="38BDF8"/>
+                </a:solidFill>
+                <a:latin typeface="Segoe UI"/>
+              </a:rPr>
+              <a:t>ALLOWLIST (KEYLIME)      </a:t>
+            </a:r>
+            <a:r>
+              <a:rPr b="1" sz="1300">
+                <a:solidFill>
+                  <a:srgbClr val="38BDF8"/>
+                </a:solidFill>
+                <a:latin typeface="Segoe UI"/>
+              </a:rPr>
+              <a:t>PRAHARI (BEHAVIOURAL)        </a:t>
             </a:r>
           </a:p>
           <a:p>
             <a:pPr>
               <a:spcAft>
-                <a:spcPts val="1000"/>
+                <a:spcPts val="1200"/>
               </a:spcAft>
             </a:pPr>
             <a:r>
-              <a:rPr sz="1900" b="0" i="0">
-                <a:solidFill>
-                  <a:srgbClr val="0F172A"/>
-                </a:solidFill>
-                <a:latin typeface="Segoe UI"/>
-              </a:rPr>
-              <a:t>loads, in order, in plain text at /sys/kernel/security/ima/ascii_runtime_measurements</a:t>
+              <a:rPr b="1" sz="1200">
+                <a:solidFill>
+                  <a:srgbClr val="F8FAFC"/>
+                </a:solidFill>
+                <a:latin typeface="Consolas"/>
+              </a:rPr>
+              <a:t>Tamper         </a:t>
+            </a:r>
+            <a:r>
+              <a:rPr sz="1200">
+                <a:solidFill>
+                  <a:srgbClr val="94A3B8"/>
+                </a:solidFill>
+                <a:latin typeface="Consolas"/>
+              </a:rPr>
+              <a:t>Direct byte corruption in measured binary    </a:t>
+            </a:r>
+            <a:r>
+              <a:rPr b="1" sz="1200">
+                <a:solidFill>
+                  <a:srgbClr val="34D399"/>
+                </a:solidFill>
+                <a:latin typeface="Consolas"/>
+              </a:rPr>
+              <a:t>DETECT (Hash Mismatch)   </a:t>
+            </a:r>
+            <a:r>
+              <a:rPr b="1" sz="1200">
+                <a:solidFill>
+                  <a:srgbClr val="34D399"/>
+                </a:solidFill>
+                <a:latin typeface="Consolas"/>
+              </a:rPr>
+              <a:t>DETECT (Tampered Hash)       </a:t>
             </a:r>
           </a:p>
           <a:p>
             <a:pPr>
               <a:spcAft>
-                <a:spcPts val="1000"/>
+                <a:spcPts val="1200"/>
               </a:spcAft>
             </a:pPr>
             <a:r>
-              <a:rPr sz="1900" b="0" i="0">
-                <a:solidFill>
-                  <a:srgbClr val="0F172A"/>
-                </a:solidFill>
-                <a:latin typeface="Segoe UI"/>
-              </a:rPr>
-              <a:t/>
+              <a:rPr b="1" sz="1200">
+                <a:solidFill>
+                  <a:srgbClr val="F8FAFC"/>
+                </a:solidFill>
+                <a:latin typeface="Consolas"/>
+              </a:rPr>
+              <a:t>Insert         </a:t>
+            </a:r>
+            <a:r>
+              <a:rPr sz="1200">
+                <a:solidFill>
+                  <a:srgbClr val="94A3B8"/>
+                </a:solidFill>
+                <a:latin typeface="Consolas"/>
+              </a:rPr>
+              <a:t>Injection of unauthorized rogue kernel module </a:t>
+            </a:r>
+            <a:r>
+              <a:rPr b="1" sz="1200">
+                <a:solidFill>
+                  <a:srgbClr val="34D399"/>
+                </a:solidFill>
+                <a:latin typeface="Consolas"/>
+              </a:rPr>
+              <a:t>DETECT (Unknown Hash)    </a:t>
+            </a:r>
+            <a:r>
+              <a:rPr b="1" sz="1200">
+                <a:solidFill>
+                  <a:srgbClr val="34D399"/>
+                </a:solidFill>
+                <a:latin typeface="Consolas"/>
+              </a:rPr>
+              <a:t>DETECT (Unknown + Sequence)  </a:t>
             </a:r>
           </a:p>
           <a:p>
             <a:pPr>
               <a:spcAft>
-                <a:spcPts val="1000"/>
+                <a:spcPts val="1200"/>
               </a:spcAft>
             </a:pPr>
             <a:r>
-              <a:rPr sz="1900" b="0" i="0">
-                <a:solidFill>
-                  <a:srgbClr val="0F172A"/>
-                </a:solidFill>
-                <a:latin typeface="Segoe UI"/>
-              </a:rPr>
-              <a:t>Boot a few times to learn what normal looks like. Then compare transitions.</a:t>
+              <a:rPr b="1" sz="1200">
+                <a:solidFill>
+                  <a:srgbClr val="FBBF24"/>
+                </a:solidFill>
+                <a:latin typeface="Consolas"/>
+              </a:rPr>
+              <a:t>Reorder        </a:t>
+            </a:r>
+            <a:r>
+              <a:rPr sz="1200">
+                <a:solidFill>
+                  <a:srgbClr val="94A3B8"/>
+                </a:solidFill>
+                <a:latin typeface="Consolas"/>
+              </a:rPr>
+              <a:t>Permuting execution order of legitimate components </a:t>
+            </a:r>
+            <a:r>
+              <a:rPr b="1" sz="1200">
+                <a:solidFill>
+                  <a:srgbClr val="F87171"/>
+                </a:solidFill>
+                <a:latin typeface="Consolas"/>
+              </a:rPr>
+              <a:t>MISS (Hashes Valid)      </a:t>
+            </a:r>
+            <a:r>
+              <a:rPr b="1" sz="1200">
+                <a:solidFill>
+                  <a:srgbClr val="34D399"/>
+                </a:solidFill>
+                <a:latin typeface="Consolas"/>
+              </a:rPr>
+              <a:t>DETECT (Sequence Anomaly)    </a:t>
             </a:r>
           </a:p>
           <a:p>
             <a:pPr>
               <a:spcAft>
-                <a:spcPts val="1000"/>
+                <a:spcPts val="1200"/>
               </a:spcAft>
             </a:pPr>
             <a:r>
-              <a:rPr sz="1900" b="0" i="0">
-                <a:solidFill>
-                  <a:srgbClr val="0F172A"/>
-                </a:solidFill>
-                <a:latin typeface="Segoe UI"/>
-              </a:rPr>
-              <a:t/>
-            </a:r>
-          </a:p>
-          <a:p>
-            <a:pPr>
-              <a:spcAft>
-                <a:spcPts val="1000"/>
-              </a:spcAft>
-            </a:pPr>
-            <a:r>
-              <a:rPr sz="1900" b="0" i="0">
-                <a:solidFill>
-                  <a:srgbClr val="0F172A"/>
-                </a:solidFill>
-                <a:latin typeface="Segoe UI"/>
-              </a:rPr>
-              <a:t>If known-good components appear in an order that has never happened before,</a:t>
-            </a:r>
-          </a:p>
-          <a:p>
-            <a:pPr>
-              <a:spcAft>
-                <a:spcPts val="1000"/>
-              </a:spcAft>
-            </a:pPr>
-            <a:r>
-              <a:rPr sz="1900" b="0" i="0">
-                <a:solidFill>
-                  <a:srgbClr val="0F172A"/>
-                </a:solidFill>
-                <a:latin typeface="Segoe UI"/>
-              </a:rPr>
-              <a:t>the sequence is anomalous — even when every single file is authentic.</a:t>
-            </a:r>
-          </a:p>
-        </p:txBody>
-      </p:sp>
-      <p:sp>
-        <p:nvSpPr>
-          <p:cNvPr id="5" name="TextBox 4"/>
-          <p:cNvSpPr txBox="1"/>
-          <p:nvPr/>
-        </p:nvSpPr>
-        <p:spPr>
-          <a:xfrm>
-            <a:off x="822960" y="5212080"/>
-            <a:ext cx="10515600" cy="548640"/>
-          </a:xfrm>
-          <a:prstGeom prst="rect">
-            <a:avLst/>
-          </a:prstGeom>
-          <a:noFill/>
-        </p:spPr>
-        <p:txBody>
-          <a:bodyPr wrap="square">
-            <a:spAutoFit/>
-          </a:bodyPr>
-          <a:lstStyle/>
-          <a:p>
-            <a:pPr>
-              <a:spcAft>
-                <a:spcPts val="800"/>
-              </a:spcAft>
-            </a:pPr>
-            <a:r>
-              <a:rPr sz="2000" b="1" i="0">
-                <a:solidFill>
-                  <a:srgbClr val="DC2626"/>
-                </a:solidFill>
-                <a:latin typeface="Segoe UI"/>
-              </a:rPr>
-              <a:t>allowlist attestation  -&gt;  behavioural sequence attestation</a:t>
+              <a:rPr b="1" sz="1200">
+                <a:solidFill>
+                  <a:srgbClr val="FBBF24"/>
+                </a:solidFill>
+                <a:latin typeface="Consolas"/>
+              </a:rPr>
+              <a:t>Substitute     </a:t>
+            </a:r>
+            <a:r>
+              <a:rPr sz="1200">
+                <a:solidFill>
+                  <a:srgbClr val="94A3B8"/>
+                </a:solidFill>
+                <a:latin typeface="Consolas"/>
+              </a:rPr>
+              <a:t>Relocating signed binary to abnormal boot phase </a:t>
+            </a:r>
+            <a:r>
+              <a:rPr b="1" sz="1200">
+                <a:solidFill>
+                  <a:srgbClr val="F87171"/>
+                </a:solidFill>
+                <a:latin typeface="Consolas"/>
+              </a:rPr>
+              <a:t>MISS (Hashes Valid)      </a:t>
+            </a:r>
+            <a:r>
+              <a:rPr b="1" sz="1200">
+                <a:solidFill>
+                  <a:srgbClr val="34D399"/>
+                </a:solidFill>
+                <a:latin typeface="Consolas"/>
+              </a:rPr>
+              <a:t>DETECT (Sequence Anomaly)    </a:t>
             </a:r>
           </a:p>
         </p:txBody>
@@ -3988,14 +4852,57 @@
       <p:grpSpPr/>
       <p:sp>
         <p:nvSpPr>
-          <p:cNvPr id="2" name="TextBox 1"/>
+          <p:cNvPr id="2" name="Rectangle 1"/>
+          <p:cNvSpPr/>
+          <p:nvPr/>
+        </p:nvSpPr>
+        <p:spPr>
+          <a:xfrm>
+            <a:off x="0" y="0"/>
+            <a:ext cx="12191695" cy="6858000"/>
+          </a:xfrm>
+          <a:prstGeom prst="rect">
+            <a:avLst/>
+          </a:prstGeom>
+          <a:solidFill>
+            <a:srgbClr val="0B1120"/>
+          </a:solidFill>
+          <a:ln>
+            <a:noFill/>
+          </a:ln>
+        </p:spPr>
+        <p:style>
+          <a:lnRef idx="1">
+            <a:schemeClr val="accent1"/>
+          </a:lnRef>
+          <a:fillRef idx="3">
+            <a:schemeClr val="accent1"/>
+          </a:fillRef>
+          <a:effectRef idx="2">
+            <a:schemeClr val="accent1"/>
+          </a:effectRef>
+          <a:fontRef idx="minor">
+            <a:schemeClr val="lt1"/>
+          </a:fontRef>
+        </p:style>
+        <p:txBody>
+          <a:bodyPr rtlCol="0" anchor="ctr"/>
+          <a:lstStyle/>
+          <a:p>
+            <a:pPr algn="ctr"/>
+          </a:p>
+        </p:txBody>
+      </p:sp>
+      <p:sp>
+        <p:nvSpPr>
+          <p:cNvPr id="3" name="TextBox 2"/>
           <p:cNvSpPr txBox="1"/>
           <p:nvPr/>
         </p:nvSpPr>
         <p:spPr>
           <a:xfrm>
-            <a:off x="822960" y="502920"/>
-            <a:ext cx="10515600" cy="365760"/>
+            <a:off x="731520" y="365760"/>
+            <a:ext cx="10698480" cy="365760"/>
           </a:xfrm>
           <a:prstGeom prst="rect">
             <a:avLst/>
@@ -4008,33 +4915,28 @@
           </a:bodyPr>
           <a:lstStyle/>
           <a:p>
-            <a:pPr>
-              <a:spcAft>
-                <a:spcPts val="800"/>
-              </a:spcAft>
-            </a:pPr>
-            <a:r>
-              <a:rPr sz="1200" b="1" i="0">
-                <a:solidFill>
-                  <a:srgbClr val="DC2626"/>
-                </a:solidFill>
-                <a:latin typeface="Segoe UI"/>
-              </a:rPr>
-              <a:t>RESULTS</a:t>
-            </a:r>
-          </a:p>
-        </p:txBody>
-      </p:sp>
-      <p:sp>
-        <p:nvSpPr>
-          <p:cNvPr id="3" name="TextBox 2"/>
+            <a:r>
+              <a:rPr sz="1100" b="1">
+                <a:solidFill>
+                  <a:srgbClr val="38BDF8"/>
+                </a:solidFill>
+                <a:latin typeface="Segoe UI"/>
+              </a:rPr>
+              <a:t>SYSTEM ARCHITECTURE</a:t>
+            </a:r>
+          </a:p>
+        </p:txBody>
+      </p:sp>
+      <p:sp>
+        <p:nvSpPr>
+          <p:cNvPr id="4" name="TextBox 3"/>
           <p:cNvSpPr txBox="1"/>
           <p:nvPr/>
         </p:nvSpPr>
         <p:spPr>
           <a:xfrm>
-            <a:off x="822960" y="914400"/>
-            <a:ext cx="10515600" cy="822960"/>
+            <a:off x="731520" y="685800"/>
+            <a:ext cx="10698480" cy="640080"/>
           </a:xfrm>
           <a:prstGeom prst="rect">
             <a:avLst/>
@@ -4047,663 +4949,42 @@
           </a:bodyPr>
           <a:lstStyle/>
           <a:p>
-            <a:pPr>
-              <a:spcAft>
-                <a:spcPts val="800"/>
-              </a:spcAft>
-            </a:pPr>
-            <a:r>
-              <a:rPr sz="3200" b="1" i="0">
-                <a:solidFill>
-                  <a:srgbClr val="0F172A"/>
-                </a:solidFill>
-                <a:latin typeface="Segoe UI"/>
-              </a:rPr>
-              <a:t>Four attacks, two detectors</a:t>
-            </a:r>
-          </a:p>
-        </p:txBody>
-      </p:sp>
-      <p:sp>
-        <p:nvSpPr>
-          <p:cNvPr id="4" name="TextBox 3"/>
-          <p:cNvSpPr txBox="1"/>
+            <a:r>
+              <a:rPr sz="2600" b="1">
+                <a:solidFill>
+                  <a:srgbClr val="F8FAFC"/>
+                </a:solidFill>
+                <a:latin typeface="Segoe UI"/>
+              </a:rPr>
+              <a:t>End-to-End Pipeline: Kernel IMA -&gt; Tokenizer -&gt; N-Gram -&gt; PQC Signer</a:t>
+            </a:r>
+          </a:p>
+        </p:txBody>
+      </p:sp>
+      <p:pic>
+        <p:nvPicPr>
+          <p:cNvPr id="5" name="Picture 4" descr="p_arch_slide.jpg"/>
+          <p:cNvPicPr>
+            <a:picLocks noChangeAspect="1"/>
+          </p:cNvPicPr>
           <p:nvPr/>
-        </p:nvSpPr>
-        <p:spPr>
-          <a:xfrm>
-            <a:off x="914400" y="1920240"/>
-            <a:ext cx="3657600" cy="365760"/>
+        </p:nvPicPr>
+        <p:blipFill>
+          <a:blip r:embed="rId2"/>
+          <a:stretch>
+            <a:fillRect/>
+          </a:stretch>
+        </p:blipFill>
+        <p:spPr>
+          <a:xfrm>
+            <a:off x="731520" y="1645920"/>
+            <a:ext cx="10698480" cy="5359938"/>
           </a:xfrm>
           <a:prstGeom prst="rect">
             <a:avLst/>
           </a:prstGeom>
-          <a:noFill/>
-        </p:spPr>
-        <p:txBody>
-          <a:bodyPr wrap="square">
-            <a:spAutoFit/>
-          </a:bodyPr>
-          <a:lstStyle/>
-          <a:p>
-            <a:pPr>
-              <a:spcAft>
-                <a:spcPts val="800"/>
-              </a:spcAft>
-            </a:pPr>
-            <a:r>
-              <a:rPr sz="1400" b="1" i="0">
-                <a:solidFill>
-                  <a:srgbClr val="64748B"/>
-                </a:solidFill>
-                <a:latin typeface="Segoe UI"/>
-              </a:rPr>
-              <a:t>ATTACK</a:t>
-            </a:r>
-          </a:p>
-        </p:txBody>
-      </p:sp>
-      <p:sp>
-        <p:nvSpPr>
-          <p:cNvPr id="5" name="TextBox 4"/>
-          <p:cNvSpPr txBox="1"/>
-          <p:nvPr/>
-        </p:nvSpPr>
-        <p:spPr>
-          <a:xfrm>
-            <a:off x="4572000" y="1920240"/>
-            <a:ext cx="2743200" cy="365760"/>
-          </a:xfrm>
-          <a:prstGeom prst="rect">
-            <a:avLst/>
-          </a:prstGeom>
-          <a:noFill/>
-        </p:spPr>
-        <p:txBody>
-          <a:bodyPr wrap="square">
-            <a:spAutoFit/>
-          </a:bodyPr>
-          <a:lstStyle/>
-          <a:p>
-            <a:pPr>
-              <a:spcAft>
-                <a:spcPts val="800"/>
-              </a:spcAft>
-            </a:pPr>
-            <a:r>
-              <a:rPr sz="1400" b="1" i="0">
-                <a:solidFill>
-                  <a:srgbClr val="64748B"/>
-                </a:solidFill>
-                <a:latin typeface="Segoe UI"/>
-              </a:rPr>
-              <a:t>ALLOWLIST</a:t>
-            </a:r>
-          </a:p>
-        </p:txBody>
-      </p:sp>
-      <p:sp>
-        <p:nvSpPr>
-          <p:cNvPr id="6" name="TextBox 5"/>
-          <p:cNvSpPr txBox="1"/>
-          <p:nvPr/>
-        </p:nvSpPr>
-        <p:spPr>
-          <a:xfrm>
-            <a:off x="7315200" y="1920240"/>
-            <a:ext cx="2743200" cy="365760"/>
-          </a:xfrm>
-          <a:prstGeom prst="rect">
-            <a:avLst/>
-          </a:prstGeom>
-          <a:noFill/>
-        </p:spPr>
-        <p:txBody>
-          <a:bodyPr wrap="square">
-            <a:spAutoFit/>
-          </a:bodyPr>
-          <a:lstStyle/>
-          <a:p>
-            <a:pPr>
-              <a:spcAft>
-                <a:spcPts val="800"/>
-              </a:spcAft>
-            </a:pPr>
-            <a:r>
-              <a:rPr sz="1400" b="1" i="0">
-                <a:solidFill>
-                  <a:srgbClr val="64748B"/>
-                </a:solidFill>
-                <a:latin typeface="Segoe UI"/>
-              </a:rPr>
-              <a:t>PRAHARI</a:t>
-            </a:r>
-          </a:p>
-        </p:txBody>
-      </p:sp>
-      <p:sp>
-        <p:nvSpPr>
-          <p:cNvPr id="7" name="TextBox 6"/>
-          <p:cNvSpPr txBox="1"/>
-          <p:nvPr/>
-        </p:nvSpPr>
-        <p:spPr>
-          <a:xfrm>
-            <a:off x="914400" y="2514600"/>
-            <a:ext cx="3657600" cy="457200"/>
-          </a:xfrm>
-          <a:prstGeom prst="rect">
-            <a:avLst/>
-          </a:prstGeom>
-          <a:noFill/>
-        </p:spPr>
-        <p:txBody>
-          <a:bodyPr wrap="square">
-            <a:spAutoFit/>
-          </a:bodyPr>
-          <a:lstStyle/>
-          <a:p>
-            <a:pPr>
-              <a:spcAft>
-                <a:spcPts val="800"/>
-              </a:spcAft>
-            </a:pPr>
-            <a:r>
-              <a:rPr sz="1900" b="1" i="0">
-                <a:solidFill>
-                  <a:srgbClr val="0F172A"/>
-                </a:solidFill>
-                <a:latin typeface="Segoe UI"/>
-              </a:rPr>
-              <a:t>tamper</a:t>
-            </a:r>
-          </a:p>
-        </p:txBody>
-      </p:sp>
-      <p:sp>
-        <p:nvSpPr>
-          <p:cNvPr id="8" name="TextBox 7"/>
-          <p:cNvSpPr txBox="1"/>
-          <p:nvPr/>
-        </p:nvSpPr>
-        <p:spPr>
-          <a:xfrm>
-            <a:off x="4572000" y="2514600"/>
-            <a:ext cx="2743200" cy="457200"/>
-          </a:xfrm>
-          <a:prstGeom prst="rect">
-            <a:avLst/>
-          </a:prstGeom>
-          <a:noFill/>
-        </p:spPr>
-        <p:txBody>
-          <a:bodyPr wrap="square">
-            <a:spAutoFit/>
-          </a:bodyPr>
-          <a:lstStyle/>
-          <a:p>
-            <a:pPr>
-              <a:spcAft>
-                <a:spcPts val="800"/>
-              </a:spcAft>
-            </a:pPr>
-            <a:r>
-              <a:rPr sz="1900" b="1" i="0">
-                <a:solidFill>
-                  <a:srgbClr val="16A34A"/>
-                </a:solidFill>
-                <a:latin typeface="Segoe UI"/>
-              </a:rPr>
-              <a:t>DETECT</a:t>
-            </a:r>
-          </a:p>
-        </p:txBody>
-      </p:sp>
-      <p:sp>
-        <p:nvSpPr>
-          <p:cNvPr id="9" name="TextBox 8"/>
-          <p:cNvSpPr txBox="1"/>
-          <p:nvPr/>
-        </p:nvSpPr>
-        <p:spPr>
-          <a:xfrm>
-            <a:off x="7315200" y="2514600"/>
-            <a:ext cx="2743200" cy="457200"/>
-          </a:xfrm>
-          <a:prstGeom prst="rect">
-            <a:avLst/>
-          </a:prstGeom>
-          <a:noFill/>
-        </p:spPr>
-        <p:txBody>
-          <a:bodyPr wrap="square">
-            <a:spAutoFit/>
-          </a:bodyPr>
-          <a:lstStyle/>
-          <a:p>
-            <a:pPr>
-              <a:spcAft>
-                <a:spcPts val="800"/>
-              </a:spcAft>
-            </a:pPr>
-            <a:r>
-              <a:rPr sz="1900" b="1" i="0">
-                <a:solidFill>
-                  <a:srgbClr val="16A34A"/>
-                </a:solidFill>
-                <a:latin typeface="Segoe UI"/>
-              </a:rPr>
-              <a:t>DETECT</a:t>
-            </a:r>
-          </a:p>
-        </p:txBody>
-      </p:sp>
-      <p:sp>
-        <p:nvSpPr>
-          <p:cNvPr id="10" name="TextBox 9"/>
-          <p:cNvSpPr txBox="1"/>
-          <p:nvPr/>
-        </p:nvSpPr>
-        <p:spPr>
-          <a:xfrm>
-            <a:off x="914400" y="3081528"/>
-            <a:ext cx="3657600" cy="457200"/>
-          </a:xfrm>
-          <a:prstGeom prst="rect">
-            <a:avLst/>
-          </a:prstGeom>
-          <a:noFill/>
-        </p:spPr>
-        <p:txBody>
-          <a:bodyPr wrap="square">
-            <a:spAutoFit/>
-          </a:bodyPr>
-          <a:lstStyle/>
-          <a:p>
-            <a:pPr>
-              <a:spcAft>
-                <a:spcPts val="800"/>
-              </a:spcAft>
-            </a:pPr>
-            <a:r>
-              <a:rPr sz="1900" b="1" i="0">
-                <a:solidFill>
-                  <a:srgbClr val="0F172A"/>
-                </a:solidFill>
-                <a:latin typeface="Segoe UI"/>
-              </a:rPr>
-              <a:t>insert</a:t>
-            </a:r>
-          </a:p>
-        </p:txBody>
-      </p:sp>
-      <p:sp>
-        <p:nvSpPr>
-          <p:cNvPr id="11" name="TextBox 10"/>
-          <p:cNvSpPr txBox="1"/>
-          <p:nvPr/>
-        </p:nvSpPr>
-        <p:spPr>
-          <a:xfrm>
-            <a:off x="4572000" y="3081528"/>
-            <a:ext cx="2743200" cy="457200"/>
-          </a:xfrm>
-          <a:prstGeom prst="rect">
-            <a:avLst/>
-          </a:prstGeom>
-          <a:noFill/>
-        </p:spPr>
-        <p:txBody>
-          <a:bodyPr wrap="square">
-            <a:spAutoFit/>
-          </a:bodyPr>
-          <a:lstStyle/>
-          <a:p>
-            <a:pPr>
-              <a:spcAft>
-                <a:spcPts val="800"/>
-              </a:spcAft>
-            </a:pPr>
-            <a:r>
-              <a:rPr sz="1900" b="1" i="0">
-                <a:solidFill>
-                  <a:srgbClr val="16A34A"/>
-                </a:solidFill>
-                <a:latin typeface="Segoe UI"/>
-              </a:rPr>
-              <a:t>DETECT</a:t>
-            </a:r>
-          </a:p>
-        </p:txBody>
-      </p:sp>
-      <p:sp>
-        <p:nvSpPr>
-          <p:cNvPr id="12" name="TextBox 11"/>
-          <p:cNvSpPr txBox="1"/>
-          <p:nvPr/>
-        </p:nvSpPr>
-        <p:spPr>
-          <a:xfrm>
-            <a:off x="7315200" y="3081528"/>
-            <a:ext cx="2743200" cy="457200"/>
-          </a:xfrm>
-          <a:prstGeom prst="rect">
-            <a:avLst/>
-          </a:prstGeom>
-          <a:noFill/>
-        </p:spPr>
-        <p:txBody>
-          <a:bodyPr wrap="square">
-            <a:spAutoFit/>
-          </a:bodyPr>
-          <a:lstStyle/>
-          <a:p>
-            <a:pPr>
-              <a:spcAft>
-                <a:spcPts val="800"/>
-              </a:spcAft>
-            </a:pPr>
-            <a:r>
-              <a:rPr sz="1900" b="1" i="0">
-                <a:solidFill>
-                  <a:srgbClr val="16A34A"/>
-                </a:solidFill>
-                <a:latin typeface="Segoe UI"/>
-              </a:rPr>
-              <a:t>DETECT</a:t>
-            </a:r>
-          </a:p>
-        </p:txBody>
-      </p:sp>
-      <p:sp>
-        <p:nvSpPr>
-          <p:cNvPr id="13" name="TextBox 12"/>
-          <p:cNvSpPr txBox="1"/>
-          <p:nvPr/>
-        </p:nvSpPr>
-        <p:spPr>
-          <a:xfrm>
-            <a:off x="914400" y="3648456"/>
-            <a:ext cx="3657600" cy="457200"/>
-          </a:xfrm>
-          <a:prstGeom prst="rect">
-            <a:avLst/>
-          </a:prstGeom>
-          <a:noFill/>
-        </p:spPr>
-        <p:txBody>
-          <a:bodyPr wrap="square">
-            <a:spAutoFit/>
-          </a:bodyPr>
-          <a:lstStyle/>
-          <a:p>
-            <a:pPr>
-              <a:spcAft>
-                <a:spcPts val="800"/>
-              </a:spcAft>
-            </a:pPr>
-            <a:r>
-              <a:rPr sz="1900" b="1" i="0">
-                <a:solidFill>
-                  <a:srgbClr val="0F172A"/>
-                </a:solidFill>
-                <a:latin typeface="Segoe UI"/>
-              </a:rPr>
-              <a:t>reorder</a:t>
-            </a:r>
-          </a:p>
-        </p:txBody>
-      </p:sp>
-      <p:sp>
-        <p:nvSpPr>
-          <p:cNvPr id="14" name="TextBox 13"/>
-          <p:cNvSpPr txBox="1"/>
-          <p:nvPr/>
-        </p:nvSpPr>
-        <p:spPr>
-          <a:xfrm>
-            <a:off x="4572000" y="3648456"/>
-            <a:ext cx="2743200" cy="457200"/>
-          </a:xfrm>
-          <a:prstGeom prst="rect">
-            <a:avLst/>
-          </a:prstGeom>
-          <a:noFill/>
-        </p:spPr>
-        <p:txBody>
-          <a:bodyPr wrap="square">
-            <a:spAutoFit/>
-          </a:bodyPr>
-          <a:lstStyle/>
-          <a:p>
-            <a:pPr>
-              <a:spcAft>
-                <a:spcPts val="800"/>
-              </a:spcAft>
-            </a:pPr>
-            <a:r>
-              <a:rPr sz="1900" b="1" i="0">
-                <a:solidFill>
-                  <a:srgbClr val="DC2626"/>
-                </a:solidFill>
-                <a:latin typeface="Segoe UI"/>
-              </a:rPr>
-              <a:t>MISS</a:t>
-            </a:r>
-          </a:p>
-        </p:txBody>
-      </p:sp>
-      <p:sp>
-        <p:nvSpPr>
-          <p:cNvPr id="15" name="TextBox 14"/>
-          <p:cNvSpPr txBox="1"/>
-          <p:nvPr/>
-        </p:nvSpPr>
-        <p:spPr>
-          <a:xfrm>
-            <a:off x="7315200" y="3648456"/>
-            <a:ext cx="2743200" cy="457200"/>
-          </a:xfrm>
-          <a:prstGeom prst="rect">
-            <a:avLst/>
-          </a:prstGeom>
-          <a:noFill/>
-        </p:spPr>
-        <p:txBody>
-          <a:bodyPr wrap="square">
-            <a:spAutoFit/>
-          </a:bodyPr>
-          <a:lstStyle/>
-          <a:p>
-            <a:pPr>
-              <a:spcAft>
-                <a:spcPts val="800"/>
-              </a:spcAft>
-            </a:pPr>
-            <a:r>
-              <a:rPr sz="1900" b="1" i="0">
-                <a:solidFill>
-                  <a:srgbClr val="16A34A"/>
-                </a:solidFill>
-                <a:latin typeface="Segoe UI"/>
-              </a:rPr>
-              <a:t>DETECT</a:t>
-            </a:r>
-          </a:p>
-        </p:txBody>
-      </p:sp>
-      <p:sp>
-        <p:nvSpPr>
-          <p:cNvPr id="16" name="TextBox 15"/>
-          <p:cNvSpPr txBox="1"/>
-          <p:nvPr/>
-        </p:nvSpPr>
-        <p:spPr>
-          <a:xfrm>
-            <a:off x="914400" y="4215383"/>
-            <a:ext cx="3657600" cy="457200"/>
-          </a:xfrm>
-          <a:prstGeom prst="rect">
-            <a:avLst/>
-          </a:prstGeom>
-          <a:noFill/>
-        </p:spPr>
-        <p:txBody>
-          <a:bodyPr wrap="square">
-            <a:spAutoFit/>
-          </a:bodyPr>
-          <a:lstStyle/>
-          <a:p>
-            <a:pPr>
-              <a:spcAft>
-                <a:spcPts val="800"/>
-              </a:spcAft>
-            </a:pPr>
-            <a:r>
-              <a:rPr sz="1900" b="1" i="0">
-                <a:solidFill>
-                  <a:srgbClr val="0F172A"/>
-                </a:solidFill>
-                <a:latin typeface="Segoe UI"/>
-              </a:rPr>
-              <a:t>substitute</a:t>
-            </a:r>
-          </a:p>
-        </p:txBody>
-      </p:sp>
-      <p:sp>
-        <p:nvSpPr>
-          <p:cNvPr id="17" name="TextBox 16"/>
-          <p:cNvSpPr txBox="1"/>
-          <p:nvPr/>
-        </p:nvSpPr>
-        <p:spPr>
-          <a:xfrm>
-            <a:off x="4572000" y="4215383"/>
-            <a:ext cx="2743200" cy="457200"/>
-          </a:xfrm>
-          <a:prstGeom prst="rect">
-            <a:avLst/>
-          </a:prstGeom>
-          <a:noFill/>
-        </p:spPr>
-        <p:txBody>
-          <a:bodyPr wrap="square">
-            <a:spAutoFit/>
-          </a:bodyPr>
-          <a:lstStyle/>
-          <a:p>
-            <a:pPr>
-              <a:spcAft>
-                <a:spcPts val="800"/>
-              </a:spcAft>
-            </a:pPr>
-            <a:r>
-              <a:rPr sz="1900" b="1" i="0">
-                <a:solidFill>
-                  <a:srgbClr val="DC2626"/>
-                </a:solidFill>
-                <a:latin typeface="Segoe UI"/>
-              </a:rPr>
-              <a:t>MISS</a:t>
-            </a:r>
-          </a:p>
-        </p:txBody>
-      </p:sp>
-      <p:sp>
-        <p:nvSpPr>
-          <p:cNvPr id="18" name="TextBox 17"/>
-          <p:cNvSpPr txBox="1"/>
-          <p:nvPr/>
-        </p:nvSpPr>
-        <p:spPr>
-          <a:xfrm>
-            <a:off x="7315200" y="4215383"/>
-            <a:ext cx="2743200" cy="457200"/>
-          </a:xfrm>
-          <a:prstGeom prst="rect">
-            <a:avLst/>
-          </a:prstGeom>
-          <a:noFill/>
-        </p:spPr>
-        <p:txBody>
-          <a:bodyPr wrap="square">
-            <a:spAutoFit/>
-          </a:bodyPr>
-          <a:lstStyle/>
-          <a:p>
-            <a:pPr>
-              <a:spcAft>
-                <a:spcPts val="800"/>
-              </a:spcAft>
-            </a:pPr>
-            <a:r>
-              <a:rPr sz="1900" b="1" i="0">
-                <a:solidFill>
-                  <a:srgbClr val="16A34A"/>
-                </a:solidFill>
-                <a:latin typeface="Segoe UI"/>
-              </a:rPr>
-              <a:t>DETECT</a:t>
-            </a:r>
-          </a:p>
-        </p:txBody>
-      </p:sp>
-      <p:sp>
-        <p:nvSpPr>
-          <p:cNvPr id="19" name="TextBox 18"/>
-          <p:cNvSpPr txBox="1"/>
-          <p:nvPr/>
-        </p:nvSpPr>
-        <p:spPr>
-          <a:xfrm>
-            <a:off x="914400" y="5120640"/>
-            <a:ext cx="10058400" cy="1097280"/>
-          </a:xfrm>
-          <a:prstGeom prst="rect">
-            <a:avLst/>
-          </a:prstGeom>
-          <a:noFill/>
-        </p:spPr>
-        <p:txBody>
-          <a:bodyPr wrap="square">
-            <a:spAutoFit/>
-          </a:bodyPr>
-          <a:lstStyle/>
-          <a:p>
-            <a:pPr>
-              <a:spcAft>
-                <a:spcPts val="600"/>
-              </a:spcAft>
-            </a:pPr>
-            <a:r>
-              <a:rPr sz="1600" b="0" i="1">
-                <a:solidFill>
-                  <a:srgbClr val="64748B"/>
-                </a:solidFill>
-                <a:latin typeface="Segoe UI"/>
-              </a:rPr>
-              <a:t>substitute is the BlackLotus pattern: a real, signed file moved to an abnormal boot phase.</a:t>
-            </a:r>
-          </a:p>
-          <a:p>
-            <a:pPr>
-              <a:spcAft>
-                <a:spcPts val="600"/>
-              </a:spcAft>
-            </a:pPr>
-            <a:r>
-              <a:rPr sz="1600" b="0" i="1">
-                <a:solidFill>
-                  <a:srgbClr val="64748B"/>
-                </a:solidFill>
-                <a:latin typeface="Segoe UI"/>
-              </a:rPr>
-              <a:t>Its hash is valid. The allowlist sleeps through it. PRAHARI flags the invalid n-gram.</a:t>
-            </a:r>
-          </a:p>
-        </p:txBody>
-      </p:sp>
+        </p:spPr>
+      </p:pic>
     </p:spTree>
   </p:cSld>
   <p:clrMapOvr>
@@ -4724,14 +5005,57 @@
       <p:grpSpPr/>
       <p:sp>
         <p:nvSpPr>
-          <p:cNvPr id="2" name="TextBox 1"/>
+          <p:cNvPr id="2" name="Rectangle 1"/>
+          <p:cNvSpPr/>
+          <p:nvPr/>
+        </p:nvSpPr>
+        <p:spPr>
+          <a:xfrm>
+            <a:off x="0" y="0"/>
+            <a:ext cx="12191695" cy="6858000"/>
+          </a:xfrm>
+          <a:prstGeom prst="rect">
+            <a:avLst/>
+          </a:prstGeom>
+          <a:solidFill>
+            <a:srgbClr val="0B1120"/>
+          </a:solidFill>
+          <a:ln>
+            <a:noFill/>
+          </a:ln>
+        </p:spPr>
+        <p:style>
+          <a:lnRef idx="1">
+            <a:schemeClr val="accent1"/>
+          </a:lnRef>
+          <a:fillRef idx="3">
+            <a:schemeClr val="accent1"/>
+          </a:fillRef>
+          <a:effectRef idx="2">
+            <a:schemeClr val="accent1"/>
+          </a:effectRef>
+          <a:fontRef idx="minor">
+            <a:schemeClr val="lt1"/>
+          </a:fontRef>
+        </p:style>
+        <p:txBody>
+          <a:bodyPr rtlCol="0" anchor="ctr"/>
+          <a:lstStyle/>
+          <a:p>
+            <a:pPr algn="ctr"/>
+          </a:p>
+        </p:txBody>
+      </p:sp>
+      <p:sp>
+        <p:nvSpPr>
+          <p:cNvPr id="3" name="TextBox 2"/>
           <p:cNvSpPr txBox="1"/>
           <p:nvPr/>
         </p:nvSpPr>
         <p:spPr>
           <a:xfrm>
-            <a:off x="822960" y="502920"/>
-            <a:ext cx="10515600" cy="365760"/>
+            <a:off x="731520" y="365760"/>
+            <a:ext cx="10698480" cy="365760"/>
           </a:xfrm>
           <a:prstGeom prst="rect">
             <a:avLst/>
@@ -4744,33 +5068,28 @@
           </a:bodyPr>
           <a:lstStyle/>
           <a:p>
-            <a:pPr>
-              <a:spcAft>
-                <a:spcPts val="800"/>
-              </a:spcAft>
-            </a:pPr>
-            <a:r>
-              <a:rPr sz="1200" b="1" i="0">
-                <a:solidFill>
-                  <a:srgbClr val="DC2626"/>
-                </a:solidFill>
-                <a:latin typeface="Segoe UI"/>
-              </a:rPr>
-              <a:t>QUANTUM-RESISTANT SIGNING</a:t>
-            </a:r>
-          </a:p>
-        </p:txBody>
-      </p:sp>
-      <p:sp>
-        <p:nvSpPr>
-          <p:cNvPr id="3" name="TextBox 2"/>
+            <a:r>
+              <a:rPr sz="1100" b="1">
+                <a:solidFill>
+                  <a:srgbClr val="38BDF8"/>
+                </a:solidFill>
+                <a:latin typeface="Segoe UI"/>
+              </a:rPr>
+              <a:t>INTERACTIVE TERMINAL UI</a:t>
+            </a:r>
+          </a:p>
+        </p:txBody>
+      </p:sp>
+      <p:sp>
+        <p:nvSpPr>
+          <p:cNvPr id="4" name="TextBox 3"/>
           <p:cNvSpPr txBox="1"/>
           <p:nvPr/>
         </p:nvSpPr>
         <p:spPr>
           <a:xfrm>
-            <a:off x="822960" y="914400"/>
-            <a:ext cx="10515600" cy="822960"/>
+            <a:off x="731520" y="685800"/>
+            <a:ext cx="10698480" cy="640080"/>
           </a:xfrm>
           <a:prstGeom prst="rect">
             <a:avLst/>
@@ -4783,158 +5102,42 @@
           </a:bodyPr>
           <a:lstStyle/>
           <a:p>
-            <a:pPr>
-              <a:spcAft>
-                <a:spcPts val="800"/>
-              </a:spcAft>
-            </a:pPr>
-            <a:r>
-              <a:rPr sz="3200" b="1" i="0">
-                <a:solidFill>
-                  <a:srgbClr val="0F172A"/>
-                </a:solidFill>
-                <a:latin typeface="Segoe UI"/>
-              </a:rPr>
-              <a:t>Firmware is the hardest thing to change later</a:t>
-            </a:r>
-          </a:p>
-        </p:txBody>
-      </p:sp>
-      <p:sp>
-        <p:nvSpPr>
-          <p:cNvPr id="4" name="TextBox 3"/>
-          <p:cNvSpPr txBox="1"/>
+            <a:r>
+              <a:rPr sz="2600" b="1">
+                <a:solidFill>
+                  <a:srgbClr val="F8FAFC"/>
+                </a:solidFill>
+                <a:latin typeface="Segoe UI"/>
+              </a:rPr>
+              <a:t>Live Operator Interface Built on Textual (SSH &amp; Server Ready)</a:t>
+            </a:r>
+          </a:p>
+        </p:txBody>
+      </p:sp>
+      <p:pic>
+        <p:nvPicPr>
+          <p:cNvPr id="5" name="Picture 4" descr="p_tui_slide.jpg"/>
+          <p:cNvPicPr>
+            <a:picLocks noChangeAspect="1"/>
+          </p:cNvPicPr>
           <p:nvPr/>
-        </p:nvSpPr>
-        <p:spPr>
-          <a:xfrm>
-            <a:off x="822960" y="1920240"/>
-            <a:ext cx="10515600" cy="2926080"/>
+        </p:nvPicPr>
+        <p:blipFill>
+          <a:blip r:embed="rId2"/>
+          <a:stretch>
+            <a:fillRect/>
+          </a:stretch>
+        </p:blipFill>
+        <p:spPr>
+          <a:xfrm>
+            <a:off x="1371600" y="1645920"/>
+            <a:ext cx="9418320" cy="6515940"/>
           </a:xfrm>
           <a:prstGeom prst="rect">
             <a:avLst/>
           </a:prstGeom>
-          <a:noFill/>
-        </p:spPr>
-        <p:txBody>
-          <a:bodyPr wrap="square">
-            <a:spAutoFit/>
-          </a:bodyPr>
-          <a:lstStyle/>
-          <a:p>
-            <a:pPr>
-              <a:spcAft>
-                <a:spcPts val="1000"/>
-              </a:spcAft>
-            </a:pPr>
-            <a:r>
-              <a:rPr sz="1900" b="0" i="0">
-                <a:solidFill>
-                  <a:srgbClr val="0F172A"/>
-                </a:solidFill>
-                <a:latin typeface="Segoe UI"/>
-              </a:rPr>
-              <a:t>The boot manifest is signed twice: ECDSA P-256 for today, ML-DSA-65 (FIPS 204) for the</a:t>
-            </a:r>
-          </a:p>
-          <a:p>
-            <a:pPr>
-              <a:spcAft>
-                <a:spcPts val="1000"/>
-              </a:spcAft>
-            </a:pPr>
-            <a:r>
-              <a:rPr sz="1900" b="0" i="0">
-                <a:solidFill>
-                  <a:srgbClr val="0F172A"/>
-                </a:solidFill>
-                <a:latin typeface="Segoe UI"/>
-              </a:rPr>
-              <a:t>quantum era. A verifier must validate both (RFC 9019 hybrid pattern).</a:t>
-            </a:r>
-          </a:p>
-          <a:p>
-            <a:pPr>
-              <a:spcAft>
-                <a:spcPts val="1000"/>
-              </a:spcAft>
-            </a:pPr>
-            <a:r>
-              <a:rPr sz="1900" b="0" i="0">
-                <a:solidFill>
-                  <a:srgbClr val="0F172A"/>
-                </a:solidFill>
-                <a:latin typeface="Segoe UI"/>
-              </a:rPr>
-              <a:t/>
-            </a:r>
-          </a:p>
-          <a:p>
-            <a:pPr>
-              <a:spcAft>
-                <a:spcPts val="1000"/>
-              </a:spcAft>
-            </a:pPr>
-            <a:r>
-              <a:rPr sz="1900" b="0" i="0">
-                <a:solidFill>
-                  <a:srgbClr val="0F172A"/>
-                </a:solidFill>
-                <a:latin typeface="Segoe UI"/>
-              </a:rPr>
-              <a:t>NSA CNSA 2.0 names firmware signing the highest-priority use case for the post-quantum</a:t>
-            </a:r>
-          </a:p>
-          <a:p>
-            <a:pPr>
-              <a:spcAft>
-                <a:spcPts val="1000"/>
-              </a:spcAft>
-            </a:pPr>
-            <a:r>
-              <a:rPr sz="1900" b="0" i="0">
-                <a:solidFill>
-                  <a:srgbClr val="0F172A"/>
-                </a:solidFill>
-                <a:latin typeface="Segoe UI"/>
-              </a:rPr>
-              <a:t>transition, because boot chains are the hardest layer to update once devices deploy.</a:t>
-            </a:r>
-          </a:p>
-          <a:p>
-            <a:pPr>
-              <a:spcAft>
-                <a:spcPts val="1000"/>
-              </a:spcAft>
-            </a:pPr>
-            <a:r>
-              <a:rPr sz="1900" b="0" i="0">
-                <a:solidFill>
-                  <a:srgbClr val="0F172A"/>
-                </a:solidFill>
-                <a:latin typeface="Segoe UI"/>
-              </a:rPr>
-              <a:t/>
-            </a:r>
-          </a:p>
-          <a:p>
-            <a:pPr>
-              <a:spcAft>
-                <a:spcPts val="1000"/>
-              </a:spcAft>
-            </a:pPr>
-            <a:r>
-              <a:rPr sz="1900" b="0" i="0">
-                <a:solidFill>
-                  <a:srgbClr val="0F172A"/>
-                </a:solidFill>
-                <a:latin typeface="Segoe UI"/>
-              </a:rPr>
-              <a:t>OpenSSL 3.5 provides ML-DSA natively with zero exotic dependencies.</a:t>
-            </a:r>
-          </a:p>
-        </p:txBody>
-      </p:sp>
+        </p:spPr>
+      </p:pic>
     </p:spTree>
   </p:cSld>
   <p:clrMapOvr>
@@ -4955,14 +5158,170 @@
       <p:grpSpPr/>
       <p:sp>
         <p:nvSpPr>
-          <p:cNvPr id="2" name="TextBox 1"/>
+          <p:cNvPr id="2" name="Rectangle 1"/>
+          <p:cNvSpPr/>
+          <p:nvPr/>
+        </p:nvSpPr>
+        <p:spPr>
+          <a:xfrm>
+            <a:off x="0" y="0"/>
+            <a:ext cx="12191695" cy="6858000"/>
+          </a:xfrm>
+          <a:prstGeom prst="rect">
+            <a:avLst/>
+          </a:prstGeom>
+          <a:solidFill>
+            <a:srgbClr val="0B1120"/>
+          </a:solidFill>
+          <a:ln>
+            <a:noFill/>
+          </a:ln>
+        </p:spPr>
+        <p:style>
+          <a:lnRef idx="1">
+            <a:schemeClr val="accent1"/>
+          </a:lnRef>
+          <a:fillRef idx="3">
+            <a:schemeClr val="accent1"/>
+          </a:fillRef>
+          <a:effectRef idx="2">
+            <a:schemeClr val="accent1"/>
+          </a:effectRef>
+          <a:fontRef idx="minor">
+            <a:schemeClr val="lt1"/>
+          </a:fontRef>
+        </p:style>
+        <p:txBody>
+          <a:bodyPr rtlCol="0" anchor="ctr"/>
+          <a:lstStyle/>
+          <a:p>
+            <a:pPr algn="ctr"/>
+          </a:p>
+        </p:txBody>
+      </p:sp>
+      <p:sp>
+        <p:nvSpPr>
+          <p:cNvPr id="3" name="TextBox 2"/>
           <p:cNvSpPr txBox="1"/>
           <p:nvPr/>
         </p:nvSpPr>
         <p:spPr>
           <a:xfrm>
-            <a:off x="822960" y="502920"/>
-            <a:ext cx="10515600" cy="365760"/>
+            <a:off x="731520" y="365760"/>
+            <a:ext cx="10698480" cy="365760"/>
+          </a:xfrm>
+          <a:prstGeom prst="rect">
+            <a:avLst/>
+          </a:prstGeom>
+          <a:noFill/>
+        </p:spPr>
+        <p:txBody>
+          <a:bodyPr wrap="square">
+            <a:spAutoFit/>
+          </a:bodyPr>
+          <a:lstStyle/>
+          <a:p>
+            <a:r>
+              <a:rPr sz="1100" b="1">
+                <a:solidFill>
+                  <a:srgbClr val="38BDF8"/>
+                </a:solidFill>
+                <a:latin typeface="Segoe UI"/>
+              </a:rPr>
+              <a:t>OPEN SOURCE TECH STACK &amp; COMPLIANCE</a:t>
+            </a:r>
+          </a:p>
+        </p:txBody>
+      </p:sp>
+      <p:sp>
+        <p:nvSpPr>
+          <p:cNvPr id="4" name="TextBox 3"/>
+          <p:cNvSpPr txBox="1"/>
+          <p:nvPr/>
+        </p:nvSpPr>
+        <p:spPr>
+          <a:xfrm>
+            <a:off x="731520" y="685800"/>
+            <a:ext cx="10698480" cy="640080"/>
+          </a:xfrm>
+          <a:prstGeom prst="rect">
+            <a:avLst/>
+          </a:prstGeom>
+          <a:noFill/>
+        </p:spPr>
+        <p:txBody>
+          <a:bodyPr wrap="square">
+            <a:spAutoFit/>
+          </a:bodyPr>
+          <a:lstStyle/>
+          <a:p>
+            <a:r>
+              <a:rPr sz="2600" b="1">
+                <a:solidFill>
+                  <a:srgbClr val="F8FAFC"/>
+                </a:solidFill>
+                <a:latin typeface="Segoe UI"/>
+              </a:rPr>
+              <a:t>Standards-Compliant, DPDP Act 2023 Aligned, Indigenous Ready</a:t>
+            </a:r>
+          </a:p>
+        </p:txBody>
+      </p:sp>
+      <p:sp>
+        <p:nvSpPr>
+          <p:cNvPr id="5" name="Rounded Rectangle 4"/>
+          <p:cNvSpPr/>
+          <p:nvPr/>
+        </p:nvSpPr>
+        <p:spPr>
+          <a:xfrm>
+            <a:off x="731520" y="1645920"/>
+            <a:ext cx="5120640" cy="4572000"/>
+          </a:xfrm>
+          <a:prstGeom prst="roundRect">
+            <a:avLst/>
+          </a:prstGeom>
+          <a:solidFill>
+            <a:srgbClr val="161E2E"/>
+          </a:solidFill>
+          <a:ln w="12700">
+            <a:solidFill>
+              <a:srgbClr val="2D3B55"/>
+            </a:solidFill>
+          </a:ln>
+        </p:spPr>
+        <p:style>
+          <a:lnRef idx="1">
+            <a:schemeClr val="accent1"/>
+          </a:lnRef>
+          <a:fillRef idx="3">
+            <a:schemeClr val="accent1"/>
+          </a:fillRef>
+          <a:effectRef idx="2">
+            <a:schemeClr val="accent1"/>
+          </a:effectRef>
+          <a:fontRef idx="minor">
+            <a:schemeClr val="lt1"/>
+          </a:fontRef>
+        </p:style>
+        <p:txBody>
+          <a:bodyPr rtlCol="0" anchor="ctr"/>
+          <a:lstStyle/>
+          <a:p>
+            <a:pPr algn="ctr"/>
+          </a:p>
+        </p:txBody>
+      </p:sp>
+      <p:sp>
+        <p:nvSpPr>
+          <p:cNvPr id="6" name="TextBox 5"/>
+          <p:cNvSpPr txBox="1"/>
+          <p:nvPr/>
+        </p:nvSpPr>
+        <p:spPr>
+          <a:xfrm>
+            <a:off x="914400" y="1783080"/>
+            <a:ext cx="4754879" cy="4297680"/>
           </a:xfrm>
           <a:prstGeom prst="rect">
             <a:avLst/>
@@ -4981,27 +5340,197 @@
               </a:spcAft>
             </a:pPr>
             <a:r>
-              <a:rPr sz="1200" b="1" i="0">
-                <a:solidFill>
-                  <a:srgbClr val="DC2626"/>
-                </a:solidFill>
-                <a:latin typeface="Segoe UI"/>
-              </a:rPr>
-              <a:t>ARCHITECTURE</a:t>
-            </a:r>
-          </a:p>
-        </p:txBody>
-      </p:sp>
-      <p:sp>
-        <p:nvSpPr>
-          <p:cNvPr id="3" name="TextBox 2"/>
+              <a:rPr sz="1700" b="1">
+                <a:solidFill>
+                  <a:srgbClr val="38BDF8"/>
+                </a:solidFill>
+                <a:latin typeface="Segoe UI"/>
+              </a:rPr>
+              <a:t>Tech Stack &amp; Dependencies</a:t>
+            </a:r>
+          </a:p>
+          <a:p>
+            <a:pPr>
+              <a:spcAft>
+                <a:spcPts val="600"/>
+              </a:spcAft>
+            </a:pPr>
+            <a:r>
+              <a:rPr sz="1300" b="1">
+                <a:solidFill>
+                  <a:srgbClr val="38BDF8"/>
+                </a:solidFill>
+                <a:latin typeface="Segoe UI"/>
+              </a:rPr>
+              <a:t>Core Language: </a:t>
+            </a:r>
+            <a:r>
+              <a:rPr sz="1300">
+                <a:solidFill>
+                  <a:srgbClr val="F8FAFC"/>
+                </a:solidFill>
+                <a:latin typeface="Segoe UI"/>
+              </a:rPr>
+              <a:t>Python 3.9+ (Clean, modular, pip-installable package)</a:t>
+            </a:r>
+          </a:p>
+          <a:p>
+            <a:pPr>
+              <a:spcAft>
+                <a:spcPts val="600"/>
+              </a:spcAft>
+            </a:pPr>
+            <a:r>
+              <a:rPr sz="1300" b="1">
+                <a:solidFill>
+                  <a:srgbClr val="34D399"/>
+                </a:solidFill>
+                <a:latin typeface="Segoe UI"/>
+              </a:rPr>
+              <a:t>Cryptography: </a:t>
+            </a:r>
+            <a:r>
+              <a:rPr sz="1300">
+                <a:solidFill>
+                  <a:srgbClr val="F8FAFC"/>
+                </a:solidFill>
+                <a:latin typeface="Segoe UI"/>
+              </a:rPr>
+              <a:t>OpenSSL 3.5 (Apache-2.0) native ML-DSA-65 &amp; ECDSA P-256</a:t>
+            </a:r>
+          </a:p>
+          <a:p>
+            <a:pPr>
+              <a:spcAft>
+                <a:spcPts val="600"/>
+              </a:spcAft>
+            </a:pPr>
+            <a:r>
+              <a:rPr sz="1300" b="1">
+                <a:solidFill>
+                  <a:srgbClr val="F8FAFC"/>
+                </a:solidFill>
+                <a:latin typeface="Segoe UI"/>
+              </a:rPr>
+              <a:t>TUI Interface: </a:t>
+            </a:r>
+            <a:r>
+              <a:rPr sz="1300">
+                <a:solidFill>
+                  <a:srgbClr val="F8FAFC"/>
+                </a:solidFill>
+                <a:latin typeface="Segoe UI"/>
+              </a:rPr>
+              <a:t>Textual (MIT) — live simulation keys [c]lean, [t]amper, [r]eorder, [s]ubstitute</a:t>
+            </a:r>
+          </a:p>
+          <a:p>
+            <a:pPr>
+              <a:spcAft>
+                <a:spcPts val="600"/>
+              </a:spcAft>
+            </a:pPr>
+            <a:r>
+              <a:rPr sz="1300" b="1">
+                <a:solidFill>
+                  <a:srgbClr val="94A3B8"/>
+                </a:solidFill>
+                <a:latin typeface="Segoe UI"/>
+              </a:rPr>
+              <a:t>Visualisation: </a:t>
+            </a:r>
+            <a:r>
+              <a:rPr sz="1300">
+                <a:solidFill>
+                  <a:srgbClr val="F8FAFC"/>
+                </a:solidFill>
+                <a:latin typeface="Segoe UI"/>
+              </a:rPr>
+              <a:t>Plotly (MIT) interactive sequence swimlane dashboard (boot.html)</a:t>
+            </a:r>
+          </a:p>
+          <a:p>
+            <a:pPr>
+              <a:spcAft>
+                <a:spcPts val="600"/>
+              </a:spcAft>
+            </a:pPr>
+            <a:r>
+              <a:rPr sz="1300" b="1">
+                <a:solidFill>
+                  <a:srgbClr val="34D399"/>
+                </a:solidFill>
+                <a:latin typeface="Segoe UI"/>
+              </a:rPr>
+              <a:t>Licensing: </a:t>
+            </a:r>
+            <a:r>
+              <a:rPr sz="1300">
+                <a:solidFill>
+                  <a:srgbClr val="F8FAFC"/>
+                </a:solidFill>
+                <a:latin typeface="Segoe UI"/>
+              </a:rPr>
+              <a:t>100% Open Source under MIT License</a:t>
+            </a:r>
+          </a:p>
+        </p:txBody>
+      </p:sp>
+      <p:sp>
+        <p:nvSpPr>
+          <p:cNvPr id="7" name="Rounded Rectangle 6"/>
+          <p:cNvSpPr/>
+          <p:nvPr/>
+        </p:nvSpPr>
+        <p:spPr>
+          <a:xfrm>
+            <a:off x="6217920" y="1645920"/>
+            <a:ext cx="5120640" cy="4572000"/>
+          </a:xfrm>
+          <a:prstGeom prst="roundRect">
+            <a:avLst/>
+          </a:prstGeom>
+          <a:solidFill>
+            <a:srgbClr val="161E2E"/>
+          </a:solidFill>
+          <a:ln w="12700">
+            <a:solidFill>
+              <a:srgbClr val="2D3B55"/>
+            </a:solidFill>
+          </a:ln>
+        </p:spPr>
+        <p:style>
+          <a:lnRef idx="1">
+            <a:schemeClr val="accent1"/>
+          </a:lnRef>
+          <a:fillRef idx="3">
+            <a:schemeClr val="accent1"/>
+          </a:fillRef>
+          <a:effectRef idx="2">
+            <a:schemeClr val="accent1"/>
+          </a:effectRef>
+          <a:fontRef idx="minor">
+            <a:schemeClr val="lt1"/>
+          </a:fontRef>
+        </p:style>
+        <p:txBody>
+          <a:bodyPr rtlCol="0" anchor="ctr"/>
+          <a:lstStyle/>
+          <a:p>
+            <a:pPr algn="ctr"/>
+          </a:p>
+        </p:txBody>
+      </p:sp>
+      <p:sp>
+        <p:nvSpPr>
+          <p:cNvPr id="8" name="TextBox 7"/>
           <p:cNvSpPr txBox="1"/>
           <p:nvPr/>
         </p:nvSpPr>
         <p:spPr>
           <a:xfrm>
-            <a:off x="822960" y="914400"/>
-            <a:ext cx="10515600" cy="822960"/>
+            <a:off x="6400800" y="1783080"/>
+            <a:ext cx="4754879" cy="4297680"/>
           </a:xfrm>
           <a:prstGeom prst="rect">
             <a:avLst/>
@@ -5020,404 +5549,113 @@
               </a:spcAft>
             </a:pPr>
             <a:r>
-              <a:rPr sz="3200" b="1" i="0">
-                <a:solidFill>
-                  <a:srgbClr val="0F172A"/>
-                </a:solidFill>
-                <a:latin typeface="Segoe UI"/>
-              </a:rPr>
-              <a:t/>
-            </a:r>
-          </a:p>
-        </p:txBody>
-      </p:sp>
-      <p:pic>
-        <p:nvPicPr>
-          <p:cNvPr id="4" name="Picture 3" descr="arch_p.jpg"/>
-          <p:cNvPicPr>
-            <a:picLocks noChangeAspect="1"/>
-          </p:cNvPicPr>
-          <p:nvPr/>
-        </p:nvPicPr>
-        <p:blipFill>
-          <a:blip r:embed="rId2"/>
-          <a:stretch>
-            <a:fillRect/>
-          </a:stretch>
-        </p:blipFill>
-        <p:spPr>
-          <a:xfrm>
-            <a:off x="640080" y="1737360"/>
-            <a:ext cx="10881360" cy="5451561"/>
-          </a:xfrm>
-          <a:prstGeom prst="rect">
-            <a:avLst/>
-          </a:prstGeom>
-        </p:spPr>
-      </p:pic>
-    </p:spTree>
-  </p:cSld>
-  <p:clrMapOvr>
-    <a:masterClrMapping/>
-  </p:clrMapOvr>
-</p:sld>
-</file>
-
-<file path=ppt/slides/slide8.xml><?xml version="1.0" encoding="utf-8"?>
-<p:sld xmlns:a="http://schemas.openxmlformats.org/drawingml/2006/main" xmlns:p="http://schemas.openxmlformats.org/presentationml/2006/main" xmlns:r="http://schemas.openxmlformats.org/officeDocument/2006/relationships">
-  <p:cSld>
-    <p:spTree>
-      <p:nvGrpSpPr>
-        <p:cNvPr id="1" name=""/>
-        <p:cNvGrpSpPr/>
-        <p:nvPr/>
-      </p:nvGrpSpPr>
-      <p:grpSpPr/>
-      <p:sp>
-        <p:nvSpPr>
-          <p:cNvPr id="2" name="TextBox 1"/>
-          <p:cNvSpPr txBox="1"/>
-          <p:nvPr/>
-        </p:nvSpPr>
-        <p:spPr>
-          <a:xfrm>
-            <a:off x="822960" y="502920"/>
-            <a:ext cx="10515600" cy="365760"/>
-          </a:xfrm>
-          <a:prstGeom prst="rect">
-            <a:avLst/>
-          </a:prstGeom>
-          <a:noFill/>
-        </p:spPr>
-        <p:txBody>
-          <a:bodyPr wrap="square">
-            <a:spAutoFit/>
-          </a:bodyPr>
-          <a:lstStyle/>
+              <a:rPr sz="1700" b="1">
+                <a:solidFill>
+                  <a:srgbClr val="34D399"/>
+                </a:solidFill>
+                <a:latin typeface="Segoe UI"/>
+              </a:rPr>
+              <a:t>Security &amp; Compliance Standards</a:t>
+            </a:r>
+          </a:p>
           <a:p>
             <a:pPr>
               <a:spcAft>
-                <a:spcPts val="800"/>
+                <a:spcPts val="600"/>
               </a:spcAft>
             </a:pPr>
             <a:r>
-              <a:rPr sz="1200" b="1" i="0">
-                <a:solidFill>
-                  <a:srgbClr val="DC2626"/>
-                </a:solidFill>
-                <a:latin typeface="Segoe UI"/>
-              </a:rPr>
-              <a:t>THE TOOL</a:t>
-            </a:r>
-          </a:p>
-        </p:txBody>
-      </p:sp>
-      <p:sp>
-        <p:nvSpPr>
-          <p:cNvPr id="3" name="TextBox 2"/>
-          <p:cNvSpPr txBox="1"/>
-          <p:nvPr/>
-        </p:nvSpPr>
-        <p:spPr>
-          <a:xfrm>
-            <a:off x="822960" y="914400"/>
-            <a:ext cx="10515600" cy="822960"/>
-          </a:xfrm>
-          <a:prstGeom prst="rect">
-            <a:avLst/>
-          </a:prstGeom>
-          <a:noFill/>
-        </p:spPr>
-        <p:txBody>
-          <a:bodyPr wrap="square">
-            <a:spAutoFit/>
-          </a:bodyPr>
-          <a:lstStyle/>
+              <a:rPr sz="1300" b="1">
+                <a:solidFill>
+                  <a:srgbClr val="34D399"/>
+                </a:solidFill>
+                <a:latin typeface="Segoe UI"/>
+              </a:rPr>
+              <a:t>DPDP Act 2023: </a:t>
+            </a:r>
+            <a:r>
+              <a:rPr sz="1300">
+                <a:solidFill>
+                  <a:srgbClr val="F8FAFC"/>
+                </a:solidFill>
+                <a:latin typeface="Segoe UI"/>
+              </a:rPr>
+              <a:t>Zero personal data collected or transmitted. Logs strictly contain kernel hashes and system paths.</a:t>
+            </a:r>
+          </a:p>
           <a:p>
             <a:pPr>
               <a:spcAft>
-                <a:spcPts val="800"/>
+                <a:spcPts val="600"/>
               </a:spcAft>
             </a:pPr>
             <a:r>
-              <a:rPr sz="3200" b="1" i="0">
-                <a:solidFill>
-                  <a:srgbClr val="0F172A"/>
-                </a:solidFill>
-                <a:latin typeface="Segoe UI"/>
-              </a:rPr>
-              <a:t/>
-            </a:r>
-          </a:p>
-        </p:txBody>
-      </p:sp>
-      <p:pic>
-        <p:nvPicPr>
-          <p:cNvPr id="4" name="Picture 3" descr="tui_p.jpg"/>
-          <p:cNvPicPr>
-            <a:picLocks noChangeAspect="1"/>
-          </p:cNvPicPr>
-          <p:nvPr/>
-        </p:nvPicPr>
-        <p:blipFill>
-          <a:blip r:embed="rId2"/>
-          <a:stretch>
-            <a:fillRect/>
-          </a:stretch>
-        </p:blipFill>
-        <p:spPr>
-          <a:xfrm>
-            <a:off x="1463040" y="1691640"/>
-            <a:ext cx="9235440" cy="6386209"/>
-          </a:xfrm>
-          <a:prstGeom prst="rect">
-            <a:avLst/>
-          </a:prstGeom>
-        </p:spPr>
-      </p:pic>
-    </p:spTree>
-  </p:cSld>
-  <p:clrMapOvr>
-    <a:masterClrMapping/>
-  </p:clrMapOvr>
-</p:sld>
-</file>
-
-<file path=ppt/slides/slide9.xml><?xml version="1.0" encoding="utf-8"?>
-<p:sld xmlns:a="http://schemas.openxmlformats.org/drawingml/2006/main" xmlns:p="http://schemas.openxmlformats.org/presentationml/2006/main" xmlns:r="http://schemas.openxmlformats.org/officeDocument/2006/relationships">
-  <p:cSld>
-    <p:spTree>
-      <p:nvGrpSpPr>
-        <p:cNvPr id="1" name=""/>
-        <p:cNvGrpSpPr/>
-        <p:nvPr/>
-      </p:nvGrpSpPr>
-      <p:grpSpPr/>
-      <p:sp>
-        <p:nvSpPr>
-          <p:cNvPr id="2" name="TextBox 1"/>
-          <p:cNvSpPr txBox="1"/>
-          <p:nvPr/>
-        </p:nvSpPr>
-        <p:spPr>
-          <a:xfrm>
-            <a:off x="822960" y="502920"/>
-            <a:ext cx="10515600" cy="365760"/>
-          </a:xfrm>
-          <a:prstGeom prst="rect">
-            <a:avLst/>
-          </a:prstGeom>
-          <a:noFill/>
-        </p:spPr>
-        <p:txBody>
-          <a:bodyPr wrap="square">
-            <a:spAutoFit/>
-          </a:bodyPr>
-          <a:lstStyle/>
+              <a:rPr sz="1300" b="1">
+                <a:solidFill>
+                  <a:srgbClr val="A855F7"/>
+                </a:solidFill>
+                <a:latin typeface="Segoe UI"/>
+              </a:rPr>
+              <a:t>RFC 9019: </a:t>
+            </a:r>
+            <a:r>
+              <a:rPr sz="1300">
+                <a:solidFill>
+                  <a:srgbClr val="F8FAFC"/>
+                </a:solidFill>
+                <a:latin typeface="Segoe UI"/>
+              </a:rPr>
+              <a:t>Dual classical + post-quantum hybrid attestation manifest pattern.</a:t>
+            </a:r>
+          </a:p>
           <a:p>
             <a:pPr>
               <a:spcAft>
-                <a:spcPts val="800"/>
+                <a:spcPts val="600"/>
               </a:spcAft>
             </a:pPr>
             <a:r>
-              <a:rPr sz="1200" b="1" i="0">
-                <a:solidFill>
-                  <a:srgbClr val="DC2626"/>
-                </a:solidFill>
-                <a:latin typeface="Segoe UI"/>
-              </a:rPr>
-              <a:t>TECHNICAL STACK &amp; INTEGRITY</a:t>
-            </a:r>
-          </a:p>
-        </p:txBody>
-      </p:sp>
-      <p:sp>
-        <p:nvSpPr>
-          <p:cNvPr id="3" name="TextBox 2"/>
-          <p:cNvSpPr txBox="1"/>
-          <p:nvPr/>
-        </p:nvSpPr>
-        <p:spPr>
-          <a:xfrm>
-            <a:off x="822960" y="914400"/>
-            <a:ext cx="10515600" cy="822960"/>
-          </a:xfrm>
-          <a:prstGeom prst="rect">
-            <a:avLst/>
-          </a:prstGeom>
-          <a:noFill/>
-        </p:spPr>
-        <p:txBody>
-          <a:bodyPr wrap="square">
-            <a:spAutoFit/>
-          </a:bodyPr>
-          <a:lstStyle/>
+              <a:rPr sz="1300" b="1">
+                <a:solidFill>
+                  <a:srgbClr val="A855F7"/>
+                </a:solidFill>
+                <a:latin typeface="Segoe UI"/>
+              </a:rPr>
+              <a:t>NSA CNSA 2.0: </a:t>
+            </a:r>
+            <a:r>
+              <a:rPr sz="1300">
+                <a:solidFill>
+                  <a:srgbClr val="F8FAFC"/>
+                </a:solidFill>
+                <a:latin typeface="Segoe UI"/>
+              </a:rPr>
+              <a:t>Directly implements firmware/boot integrity quantum transition priority.</a:t>
+            </a:r>
+          </a:p>
           <a:p>
             <a:pPr>
               <a:spcAft>
-                <a:spcPts val="800"/>
+                <a:spcPts val="600"/>
               </a:spcAft>
             </a:pPr>
             <a:r>
-              <a:rPr sz="3200" b="1" i="0">
-                <a:solidFill>
-                  <a:srgbClr val="0F172A"/>
-                </a:solidFill>
-                <a:latin typeface="Segoe UI"/>
-              </a:rPr>
-              <a:t>What we built and what we leveraged</a:t>
-            </a:r>
-          </a:p>
-        </p:txBody>
-      </p:sp>
-      <p:sp>
-        <p:nvSpPr>
-          <p:cNvPr id="4" name="TextBox 3"/>
-          <p:cNvSpPr txBox="1"/>
-          <p:nvPr/>
-        </p:nvSpPr>
-        <p:spPr>
-          <a:xfrm>
-            <a:off x="822960" y="1920240"/>
-            <a:ext cx="10515600" cy="3108960"/>
-          </a:xfrm>
-          <a:prstGeom prst="rect">
-            <a:avLst/>
-          </a:prstGeom>
-          <a:noFill/>
-        </p:spPr>
-        <p:txBody>
-          <a:bodyPr wrap="square">
-            <a:spAutoFit/>
-          </a:bodyPr>
-          <a:lstStyle/>
-          <a:p>
-            <a:pPr>
-              <a:spcAft>
-                <a:spcPts val="900"/>
-              </a:spcAft>
-            </a:pPr>
-            <a:r>
-              <a:rPr sz="1800" b="0" i="0">
-                <a:solidFill>
-                  <a:srgbClr val="0F172A"/>
-                </a:solidFill>
-                <a:latin typeface="Segoe UI"/>
-              </a:rPr>
-              <a:t>Built by us: log parser, dual-projection tokenizer (identity vs content), n-gram baseline</a:t>
-            </a:r>
-          </a:p>
-          <a:p>
-            <a:pPr>
-              <a:spcAft>
-                <a:spcPts val="900"/>
-              </a:spcAft>
-            </a:pPr>
-            <a:r>
-              <a:rPr sz="1800" b="0" i="0">
-                <a:solidFill>
-                  <a:srgbClr val="0F172A"/>
-                </a:solidFill>
-                <a:latin typeface="Segoe UI"/>
-              </a:rPr>
-              <a:t>detector, 4-vector attack generator, and post-quantum verification engine.</a:t>
-            </a:r>
-          </a:p>
-          <a:p>
-            <a:pPr>
-              <a:spcAft>
-                <a:spcPts val="900"/>
-              </a:spcAft>
-            </a:pPr>
-            <a:r>
-              <a:rPr sz="1800" b="0" i="0">
-                <a:solidFill>
-                  <a:srgbClr val="0F172A"/>
-                </a:solidFill>
-                <a:latin typeface="Segoe UI"/>
-              </a:rPr>
-              <a:t/>
-            </a:r>
-          </a:p>
-          <a:p>
-            <a:pPr>
-              <a:spcAft>
-                <a:spcPts val="900"/>
-              </a:spcAft>
-            </a:pPr>
-            <a:r>
-              <a:rPr sz="1800" b="0" i="0">
-                <a:solidFill>
-                  <a:srgbClr val="0F172A"/>
-                </a:solidFill>
-                <a:latin typeface="Segoe UI"/>
-              </a:rPr>
-              <a:t>Libraries: OpenSSL 3.5 (Apache-2.0) for ML-DSA &amp; ECDSA • Textual (MIT) for TUI •</a:t>
-            </a:r>
-          </a:p>
-          <a:p>
-            <a:pPr>
-              <a:spcAft>
-                <a:spcPts val="900"/>
-              </a:spcAft>
-            </a:pPr>
-            <a:r>
-              <a:rPr sz="1800" b="0" i="0">
-                <a:solidFill>
-                  <a:srgbClr val="0F172A"/>
-                </a:solidFill>
-                <a:latin typeface="Segoe UI"/>
-              </a:rPr>
-              <a:t>Plotly (MIT) for visualizer • Anthropic API (MIT) for natural-language findings summary.</a:t>
-            </a:r>
-          </a:p>
-          <a:p>
-            <a:pPr>
-              <a:spcAft>
-                <a:spcPts val="900"/>
-              </a:spcAft>
-            </a:pPr>
-            <a:r>
-              <a:rPr sz="1800" b="0" i="0">
-                <a:solidFill>
-                  <a:srgbClr val="0F172A"/>
-                </a:solidFill>
-                <a:latin typeface="Segoe UI"/>
-              </a:rPr>
-              <a:t/>
-            </a:r>
-          </a:p>
-          <a:p>
-            <a:pPr>
-              <a:spcAft>
-                <a:spcPts val="900"/>
-              </a:spcAft>
-            </a:pPr>
-            <a:r>
-              <a:rPr sz="1800" b="0" i="0">
-                <a:solidFill>
-                  <a:srgbClr val="0F172A"/>
-                </a:solidFill>
-                <a:latin typeface="Segoe UI"/>
-              </a:rPr>
-              <a:t>N-grams were chosen deliberately over neural models (DeepLog/LogBERT): converges in 4-5</a:t>
-            </a:r>
-          </a:p>
-          <a:p>
-            <a:pPr>
-              <a:spcAft>
-                <a:spcPts val="900"/>
-              </a:spcAft>
-            </a:pPr>
-            <a:r>
-              <a:rPr sz="1800" b="0" i="0">
-                <a:solidFill>
-                  <a:srgbClr val="0F172A"/>
-                </a:solidFill>
-                <a:latin typeface="Segoe UI"/>
-              </a:rPr>
-              <a:t>real boots, and every finding isolates a named, verifiable sequence transition.</a:t>
+              <a:rPr sz="1300" b="1">
+                <a:solidFill>
+                  <a:srgbClr val="34D399"/>
+                </a:solidFill>
+                <a:latin typeface="Segoe UI"/>
+              </a:rPr>
+              <a:t>Atmanirbhar Bharat: </a:t>
+            </a:r>
+            <a:r>
+              <a:rPr sz="1300">
+                <a:solidFill>
+                  <a:srgbClr val="F8FAFC"/>
+                </a:solidFill>
+                <a:latin typeface="Segoe UI"/>
+              </a:rPr>
+              <a:t>Self-reliant security stack requiring zero proprietary foreign telemetry.</a:t>
             </a:r>
           </a:p>
         </p:txBody>

</xml_diff>

<commit_message>
Deliver refined masterpiece presentation deck with high-impact visual design
</commit_message>
<xml_diff>
--- a/docs/PRAHARI.pptx
+++ b/docs/PRAHARI.pptx
@@ -3109,7 +3109,7 @@
             <a:avLst/>
           </a:prstGeom>
           <a:solidFill>
-            <a:srgbClr val="0B1120"/>
+            <a:srgbClr val="0A0F1D"/>
           </a:solidFill>
           <a:ln>
             <a:noFill/>
@@ -3139,14 +3139,57 @@
       </p:sp>
       <p:sp>
         <p:nvSpPr>
-          <p:cNvPr id="3" name="TextBox 2"/>
+          <p:cNvPr id="3" name="Rectangle 2"/>
+          <p:cNvSpPr/>
+          <p:nvPr/>
+        </p:nvSpPr>
+        <p:spPr>
+          <a:xfrm>
+            <a:off x="0" y="0"/>
+            <a:ext cx="12191695" cy="54864"/>
+          </a:xfrm>
+          <a:prstGeom prst="rect">
+            <a:avLst/>
+          </a:prstGeom>
+          <a:solidFill>
+            <a:srgbClr val="38BDF8"/>
+          </a:solidFill>
+          <a:ln>
+            <a:noFill/>
+          </a:ln>
+        </p:spPr>
+        <p:style>
+          <a:lnRef idx="1">
+            <a:schemeClr val="accent1"/>
+          </a:lnRef>
+          <a:fillRef idx="3">
+            <a:schemeClr val="accent1"/>
+          </a:fillRef>
+          <a:effectRef idx="2">
+            <a:schemeClr val="accent1"/>
+          </a:effectRef>
+          <a:fontRef idx="minor">
+            <a:schemeClr val="lt1"/>
+          </a:fontRef>
+        </p:style>
+        <p:txBody>
+          <a:bodyPr rtlCol="0" anchor="ctr"/>
+          <a:lstStyle/>
+          <a:p>
+            <a:pPr algn="ctr"/>
+          </a:p>
+        </p:txBody>
+      </p:sp>
+      <p:sp>
+        <p:nvSpPr>
+          <p:cNvPr id="4" name="TextBox 3"/>
           <p:cNvSpPr txBox="1"/>
           <p:nvPr/>
         </p:nvSpPr>
         <p:spPr>
           <a:xfrm>
-            <a:off x="914400" y="1645920"/>
-            <a:ext cx="10332720" cy="457200"/>
+            <a:off x="914400" y="1371600"/>
+            <a:ext cx="10332720" cy="365760"/>
           </a:xfrm>
           <a:prstGeom prst="rect">
             <a:avLst/>
@@ -3173,14 +3216,14 @@
       </p:sp>
       <p:sp>
         <p:nvSpPr>
-          <p:cNvPr id="4" name="TextBox 3"/>
+          <p:cNvPr id="5" name="TextBox 4"/>
           <p:cNvSpPr txBox="1"/>
           <p:nvPr/>
         </p:nvSpPr>
         <p:spPr>
           <a:xfrm>
-            <a:off x="914400" y="2103120"/>
-            <a:ext cx="10332720" cy="1371600"/>
+            <a:off x="914400" y="1828800"/>
+            <a:ext cx="10332720" cy="1280160"/>
           </a:xfrm>
           <a:prstGeom prst="rect">
             <a:avLst/>
@@ -3194,7 +3237,7 @@
           <a:lstStyle/>
           <a:p>
             <a:r>
-              <a:rPr sz="5400" b="1">
+              <a:rPr sz="5600" b="1">
                 <a:solidFill>
                   <a:srgbClr val="F8FAFC"/>
                 </a:solidFill>
@@ -3205,7 +3248,7 @@
           </a:p>
           <a:p>
             <a:r>
-              <a:rPr sz="2200">
+              <a:rPr sz="2200" b="1">
                 <a:solidFill>
                   <a:srgbClr val="34D399"/>
                 </a:solidFill>
@@ -3218,14 +3261,14 @@
       </p:sp>
       <p:sp>
         <p:nvSpPr>
-          <p:cNvPr id="5" name="TextBox 4"/>
+          <p:cNvPr id="6" name="TextBox 5"/>
           <p:cNvSpPr txBox="1"/>
           <p:nvPr/>
         </p:nvSpPr>
         <p:spPr>
           <a:xfrm>
-            <a:off x="914400" y="3931920"/>
-            <a:ext cx="10332720" cy="1097280"/>
+            <a:off x="914400" y="3657600"/>
+            <a:ext cx="10332720" cy="914400"/>
           </a:xfrm>
           <a:prstGeom prst="rect">
             <a:avLst/>
@@ -3245,21 +3288,66 @@
                 </a:solidFill>
                 <a:latin typeface="Segoe UI"/>
               </a:rPr>
-              <a:t>Catches compromised boots when every cryptographic signature and hash succeeds.</a:t>
-            </a:r>
-          </a:p>
-        </p:txBody>
-      </p:sp>
-      <p:sp>
-        <p:nvSpPr>
-          <p:cNvPr id="6" name="TextBox 5"/>
+              <a:t>Catches compromised boots when every signature is valid and every hash matches.</a:t>
+            </a:r>
+          </a:p>
+        </p:txBody>
+      </p:sp>
+      <p:sp>
+        <p:nvSpPr>
+          <p:cNvPr id="7" name="Rounded Rectangle 6"/>
+          <p:cNvSpPr/>
+          <p:nvPr/>
+        </p:nvSpPr>
+        <p:spPr>
+          <a:xfrm>
+            <a:off x="914400" y="5029200"/>
+            <a:ext cx="10360152" cy="1097280"/>
+          </a:xfrm>
+          <a:prstGeom prst="roundRect">
+            <a:avLst/>
+          </a:prstGeom>
+          <a:solidFill>
+            <a:srgbClr val="131B2C"/>
+          </a:solidFill>
+          <a:ln w="12700">
+            <a:solidFill>
+              <a:srgbClr val="26334D"/>
+            </a:solidFill>
+          </a:ln>
+        </p:spPr>
+        <p:style>
+          <a:lnRef idx="1">
+            <a:schemeClr val="accent1"/>
+          </a:lnRef>
+          <a:fillRef idx="3">
+            <a:schemeClr val="accent1"/>
+          </a:fillRef>
+          <a:effectRef idx="2">
+            <a:schemeClr val="accent1"/>
+          </a:effectRef>
+          <a:fontRef idx="minor">
+            <a:schemeClr val="lt1"/>
+          </a:fontRef>
+        </p:style>
+        <p:txBody>
+          <a:bodyPr rtlCol="0" anchor="ctr"/>
+          <a:lstStyle/>
+          <a:p>
+            <a:pPr algn="ctr"/>
+          </a:p>
+        </p:txBody>
+      </p:sp>
+      <p:sp>
+        <p:nvSpPr>
+          <p:cNvPr id="8" name="TextBox 7"/>
           <p:cNvSpPr txBox="1"/>
           <p:nvPr/>
         </p:nvSpPr>
         <p:spPr>
           <a:xfrm>
-            <a:off x="914400" y="5486400"/>
-            <a:ext cx="10332720" cy="731520"/>
+            <a:off x="1097280" y="5166360"/>
+            <a:ext cx="9966960" cy="822960"/>
           </a:xfrm>
           <a:prstGeom prst="rect">
             <a:avLst/>
@@ -3273,13 +3361,24 @@
           <a:lstStyle/>
           <a:p>
             <a:r>
-              <a:rPr sz="1300">
+              <a:rPr sz="1300" b="1">
+                <a:solidFill>
+                  <a:srgbClr val="38BDF8"/>
+                </a:solidFill>
+                <a:latin typeface="Segoe UI"/>
+              </a:rPr>
+              <a:t>Problem Statement 3: AI-Assisted Secure Boot &amp; Integrity Verification  |  Inbuilt N-Gram Behavioral Model</a:t>
+            </a:r>
+          </a:p>
+          <a:p>
+            <a:r>
+              <a:rPr sz="1200">
                 <a:solidFill>
                   <a:srgbClr val="94A3B8"/>
                 </a:solidFill>
                 <a:latin typeface="Segoe UI"/>
               </a:rPr>
-              <a:t>Team: Shaik Abdul Basith, Shaik Awaiz, Shaik Abdul Muqeeth  |  Repo: github.com/basithladdu/prahari</a:t>
+              <a:t>Team: Shaik Abdul Basith, Shaik Awaiz, Shaik Abdul Muqeeth  •  GitHub: github.com/basithladdu/prahari</a:t>
             </a:r>
           </a:p>
         </p:txBody>
@@ -3317,7 +3416,7 @@
             <a:avLst/>
           </a:prstGeom>
           <a:solidFill>
-            <a:srgbClr val="0B1120"/>
+            <a:srgbClr val="0A0F1D"/>
           </a:solidFill>
           <a:ln>
             <a:noFill/>
@@ -3347,104 +3446,23 @@
       </p:sp>
       <p:sp>
         <p:nvSpPr>
-          <p:cNvPr id="3" name="TextBox 2"/>
-          <p:cNvSpPr txBox="1"/>
+          <p:cNvPr id="3" name="Rectangle 2"/>
+          <p:cNvSpPr/>
           <p:nvPr/>
         </p:nvSpPr>
         <p:spPr>
           <a:xfrm>
-            <a:off x="731520" y="365760"/>
-            <a:ext cx="10698480" cy="365760"/>
+            <a:off x="0" y="0"/>
+            <a:ext cx="12191695" cy="54864"/>
           </a:xfrm>
           <a:prstGeom prst="rect">
             <a:avLst/>
           </a:prstGeom>
-          <a:noFill/>
-        </p:spPr>
-        <p:txBody>
-          <a:bodyPr wrap="square">
-            <a:spAutoFit/>
-          </a:bodyPr>
-          <a:lstStyle/>
-          <a:p>
-            <a:r>
-              <a:rPr sz="1100" b="1">
-                <a:solidFill>
-                  <a:srgbClr val="38BDF8"/>
-                </a:solidFill>
-                <a:latin typeface="Segoe UI"/>
-              </a:rPr>
-              <a:t>THE CORE PROBLEM</a:t>
-            </a:r>
-          </a:p>
-        </p:txBody>
-      </p:sp>
-      <p:sp>
-        <p:nvSpPr>
-          <p:cNvPr id="4" name="TextBox 3"/>
-          <p:cNvSpPr txBox="1"/>
-          <p:nvPr/>
-        </p:nvSpPr>
-        <p:spPr>
-          <a:xfrm>
-            <a:off x="731520" y="685800"/>
-            <a:ext cx="10698480" cy="640080"/>
-          </a:xfrm>
-          <a:prstGeom prst="rect">
-            <a:avLst/>
-          </a:prstGeom>
-          <a:noFill/>
-        </p:spPr>
-        <p:txBody>
-          <a:bodyPr wrap="square">
-            <a:spAutoFit/>
-          </a:bodyPr>
-          <a:lstStyle/>
-          <a:p>
-            <a:r>
-              <a:rPr sz="2600" b="1">
-                <a:solidFill>
-                  <a:srgbClr val="F8FAFC"/>
-                </a:solidFill>
-                <a:latin typeface="Segoe UI"/>
-              </a:rPr>
-              <a:t>Signature Verification is Structurally Blind to Ordering Attacks</a:t>
-            </a:r>
-          </a:p>
-          <a:p>
-            <a:r>
-              <a:rPr sz="1300">
-                <a:solidFill>
-                  <a:srgbClr val="94A3B8"/>
-                </a:solidFill>
-                <a:latin typeface="Segoe UI"/>
-              </a:rPr>
-              <a:t>Why traditional Measured Boot &amp; Secure Boot fail against modern bootkits</a:t>
-            </a:r>
-          </a:p>
-        </p:txBody>
-      </p:sp>
-      <p:sp>
-        <p:nvSpPr>
-          <p:cNvPr id="5" name="Rounded Rectangle 4"/>
-          <p:cNvSpPr/>
-          <p:nvPr/>
-        </p:nvSpPr>
-        <p:spPr>
-          <a:xfrm>
-            <a:off x="731520" y="1645920"/>
-            <a:ext cx="5120640" cy="4572000"/>
-          </a:xfrm>
-          <a:prstGeom prst="roundRect">
-            <a:avLst/>
-          </a:prstGeom>
           <a:solidFill>
-            <a:srgbClr val="161E2E"/>
+            <a:srgbClr val="38BDF8"/>
           </a:solidFill>
-          <a:ln w="12700">
-            <a:solidFill>
-              <a:srgbClr val="2D3B55"/>
-            </a:solidFill>
+          <a:ln>
+            <a:noFill/>
           </a:ln>
         </p:spPr>
         <p:style>
@@ -3471,14 +3489,14 @@
       </p:sp>
       <p:sp>
         <p:nvSpPr>
-          <p:cNvPr id="6" name="TextBox 5"/>
+          <p:cNvPr id="4" name="TextBox 3"/>
           <p:cNvSpPr txBox="1"/>
           <p:nvPr/>
         </p:nvSpPr>
         <p:spPr>
           <a:xfrm>
-            <a:off x="914400" y="1783080"/>
-            <a:ext cx="4754879" cy="4297680"/>
+            <a:off x="731520" y="365760"/>
+            <a:ext cx="10698480" cy="320040"/>
           </a:xfrm>
           <a:prstGeom prst="rect">
             <a:avLst/>
@@ -3491,19 +3509,152 @@
           </a:bodyPr>
           <a:lstStyle/>
           <a:p>
+            <a:r>
+              <a:rPr sz="1100" b="1">
+                <a:solidFill>
+                  <a:srgbClr val="38BDF8"/>
+                </a:solidFill>
+                <a:latin typeface="Segoe UI"/>
+              </a:rPr>
+              <a:t>THE THREAT</a:t>
+            </a:r>
+          </a:p>
+        </p:txBody>
+      </p:sp>
+      <p:sp>
+        <p:nvSpPr>
+          <p:cNvPr id="5" name="TextBox 4"/>
+          <p:cNvSpPr txBox="1"/>
+          <p:nvPr/>
+        </p:nvSpPr>
+        <p:spPr>
+          <a:xfrm>
+            <a:off x="731520" y="640080"/>
+            <a:ext cx="10698480" cy="548640"/>
+          </a:xfrm>
+          <a:prstGeom prst="rect">
+            <a:avLst/>
+          </a:prstGeom>
+          <a:noFill/>
+        </p:spPr>
+        <p:txBody>
+          <a:bodyPr wrap="square">
+            <a:spAutoFit/>
+          </a:bodyPr>
+          <a:lstStyle/>
+          <a:p>
+            <a:r>
+              <a:rPr sz="2400" b="1">
+                <a:solidFill>
+                  <a:srgbClr val="F8FAFC"/>
+                </a:solidFill>
+                <a:latin typeface="Segoe UI"/>
+              </a:rPr>
+              <a:t>Why Traditional Boot Attestation Fails Against Modern Bootkits</a:t>
+            </a:r>
+          </a:p>
+          <a:p>
+            <a:r>
+              <a:rPr sz="1200">
+                <a:solidFill>
+                  <a:srgbClr val="94A3B8"/>
+                </a:solidFill>
+                <a:latin typeface="Segoe UI"/>
+              </a:rPr>
+              <a:t>Signatures verify author identity — they say nothing about whether the execution order is normal.</a:t>
+            </a:r>
+          </a:p>
+        </p:txBody>
+      </p:sp>
+      <p:sp>
+        <p:nvSpPr>
+          <p:cNvPr id="6" name="Rounded Rectangle 5"/>
+          <p:cNvSpPr/>
+          <p:nvPr/>
+        </p:nvSpPr>
+        <p:spPr>
+          <a:xfrm>
+            <a:off x="731520" y="1554480"/>
+            <a:ext cx="5120640" cy="4023360"/>
+          </a:xfrm>
+          <a:prstGeom prst="roundRect">
+            <a:avLst/>
+          </a:prstGeom>
+          <a:solidFill>
+            <a:srgbClr val="131B2C"/>
+          </a:solidFill>
+          <a:ln w="12700">
+            <a:solidFill>
+              <a:srgbClr val="EF4444"/>
+            </a:solidFill>
+          </a:ln>
+        </p:spPr>
+        <p:style>
+          <a:lnRef idx="1">
+            <a:schemeClr val="accent1"/>
+          </a:lnRef>
+          <a:fillRef idx="3">
+            <a:schemeClr val="accent1"/>
+          </a:fillRef>
+          <a:effectRef idx="2">
+            <a:schemeClr val="accent1"/>
+          </a:effectRef>
+          <a:fontRef idx="minor">
+            <a:schemeClr val="lt1"/>
+          </a:fontRef>
+        </p:style>
+        <p:txBody>
+          <a:bodyPr rtlCol="0" anchor="ctr"/>
+          <a:lstStyle/>
+          <a:p>
+            <a:pPr algn="ctr"/>
+          </a:p>
+        </p:txBody>
+      </p:sp>
+      <p:sp>
+        <p:nvSpPr>
+          <p:cNvPr id="7" name="TextBox 6"/>
+          <p:cNvSpPr txBox="1"/>
+          <p:nvPr/>
+        </p:nvSpPr>
+        <p:spPr>
+          <a:xfrm>
+            <a:off x="932688" y="1719072"/>
+            <a:ext cx="4718303" cy="3694176"/>
+          </a:xfrm>
+          <a:prstGeom prst="rect">
+            <a:avLst/>
+          </a:prstGeom>
+          <a:noFill/>
+        </p:spPr>
+        <p:txBody>
+          <a:bodyPr wrap="square">
+            <a:spAutoFit/>
+          </a:bodyPr>
+          <a:lstStyle/>
+          <a:p>
             <a:pPr>
               <a:spcAft>
-                <a:spcPts val="800"/>
+                <a:spcPts val="1000"/>
               </a:spcAft>
             </a:pPr>
             <a:r>
-              <a:rPr sz="1700" b="1">
+              <a:rPr sz="1100" b="1">
                 <a:solidFill>
                   <a:srgbClr val="F87171"/>
                 </a:solidFill>
                 <a:latin typeface="Segoe UI"/>
               </a:rPr>
-              <a:t>The Allowlist Fallacy</a:t>
+              <a:t>[THE ALLOWLIST FALLACY] </a:t>
+            </a:r>
+            <a:r>
+              <a:rPr sz="1600" b="1">
+                <a:solidFill>
+                  <a:srgbClr val="F8FAFC"/>
+                </a:solidFill>
+                <a:latin typeface="Segoe UI"/>
+              </a:rPr>
+              <a:t>Traditional Measured Boot (Keylime)</a:t>
             </a:r>
           </a:p>
           <a:p>
@@ -3513,22 +3664,22 @@
               </a:spcAft>
             </a:pPr>
             <a:r>
-              <a:rPr sz="1300" b="1">
+              <a:rPr sz="1250" b="1">
+                <a:solidFill>
+                  <a:srgbClr val="94A3B8"/>
+                </a:solidFill>
+                <a:latin typeface="Segoe UI"/>
+              </a:rPr>
+              <a:t>Static Guest List: </a:t>
+            </a:r>
+            <a:r>
+              <a:rPr sz="1250">
                 <a:solidFill>
                   <a:srgbClr val="F8FAFC"/>
                 </a:solidFill>
                 <a:latin typeface="Segoe UI"/>
               </a:rPr>
-              <a:t>Static Guest List: </a:t>
-            </a:r>
-            <a:r>
-              <a:rPr sz="1300">
-                <a:solidFill>
-                  <a:srgbClr val="F8FAFC"/>
-                </a:solidFill>
-                <a:latin typeface="Segoe UI"/>
-              </a:rPr>
-              <a:t>Tools like Keylime maintain a whitelist of known-good SHA-256 hashes.</a:t>
+              <a:t>Compares measured file hashes against a manually maintained allowlist.</a:t>
             </a:r>
           </a:p>
           <a:p>
@@ -3538,7 +3689,7 @@
               </a:spcAft>
             </a:pPr>
             <a:r>
-              <a:rPr sz="1300" b="1">
+              <a:rPr sz="1250" b="1">
                 <a:solidFill>
                   <a:srgbClr val="94A3B8"/>
                 </a:solidFill>
@@ -3547,13 +3698,13 @@
               <a:t>Single Question: </a:t>
             </a:r>
             <a:r>
-              <a:rPr sz="1300">
+              <a:rPr sz="1250">
                 <a:solidFill>
                   <a:srgbClr val="F8FAFC"/>
                 </a:solidFill>
                 <a:latin typeface="Segoe UI"/>
               </a:rPr>
-              <a:t>They only verify: 'Does this hash exist in the database?'</a:t>
+              <a:t>'Does this hash appear in our database of known-good files?'</a:t>
             </a:r>
           </a:p>
           <a:p>
@@ -3563,22 +3714,22 @@
               </a:spcAft>
             </a:pPr>
             <a:r>
-              <a:rPr sz="1300" b="1">
+              <a:rPr sz="1250" b="1">
                 <a:solidFill>
                   <a:srgbClr val="F87171"/>
                 </a:solidFill>
                 <a:latin typeface="Segoe UI"/>
               </a:rPr>
-              <a:t>Blind Spot: </a:t>
-            </a:r>
-            <a:r>
-              <a:rPr sz="1300">
+              <a:t>Fatal Blind Spot: </a:t>
+            </a:r>
+            <a:r>
+              <a:rPr sz="1250">
                 <a:solidFill>
                   <a:srgbClr val="F8FAFC"/>
                 </a:solidFill>
                 <a:latin typeface="Segoe UI"/>
               </a:rPr>
-              <a:t>They never check: 'Is this specific event sequence normal for this system?'</a:t>
+              <a:t>Cannot see event order, timing, race conditions, or binary permutations.</a:t>
             </a:r>
           </a:p>
           <a:p>
@@ -3588,46 +3739,46 @@
               </a:spcAft>
             </a:pPr>
             <a:r>
-              <a:rPr sz="1300" b="1">
+              <a:rPr sz="1250" b="1">
                 <a:solidFill>
                   <a:srgbClr val="F87171"/>
                 </a:solidFill>
                 <a:latin typeface="Segoe UI"/>
               </a:rPr>
-              <a:t>Zero Protection: </a:t>
-            </a:r>
-            <a:r>
-              <a:rPr sz="1300">
+              <a:t>Outcome: </a:t>
+            </a:r>
+            <a:r>
+              <a:rPr sz="1250">
                 <a:solidFill>
                   <a:srgbClr val="F8FAFC"/>
                 </a:solidFill>
                 <a:latin typeface="Segoe UI"/>
               </a:rPr>
-              <a:t>Permutations, race conditions, and early-boot hijackings pass with 100% valid signatures.</a:t>
-            </a:r>
-          </a:p>
-        </p:txBody>
-      </p:sp>
-      <p:sp>
-        <p:nvSpPr>
-          <p:cNvPr id="7" name="Rounded Rectangle 6"/>
+              <a:t>If an attacker runs genuine signed binaries in a malicious sequence, allowlists approve it.</a:t>
+            </a:r>
+          </a:p>
+        </p:txBody>
+      </p:sp>
+      <p:sp>
+        <p:nvSpPr>
+          <p:cNvPr id="8" name="Rounded Rectangle 7"/>
           <p:cNvSpPr/>
           <p:nvPr/>
         </p:nvSpPr>
         <p:spPr>
           <a:xfrm>
-            <a:off x="6217920" y="1645920"/>
-            <a:ext cx="5120640" cy="4572000"/>
+            <a:off x="6217920" y="1554480"/>
+            <a:ext cx="5120640" cy="4023360"/>
           </a:xfrm>
           <a:prstGeom prst="roundRect">
             <a:avLst/>
           </a:prstGeom>
           <a:solidFill>
-            <a:srgbClr val="161E2E"/>
+            <a:srgbClr val="131B2C"/>
           </a:solidFill>
           <a:ln w="12700">
             <a:solidFill>
-              <a:srgbClr val="2D3B55"/>
+              <a:srgbClr val="FBBF24"/>
             </a:solidFill>
           </a:ln>
         </p:spPr>
@@ -3655,14 +3806,14 @@
       </p:sp>
       <p:sp>
         <p:nvSpPr>
-          <p:cNvPr id="8" name="TextBox 7"/>
+          <p:cNvPr id="9" name="TextBox 8"/>
           <p:cNvSpPr txBox="1"/>
           <p:nvPr/>
         </p:nvSpPr>
         <p:spPr>
           <a:xfrm>
-            <a:off x="6400800" y="1783080"/>
-            <a:ext cx="4754879" cy="4297680"/>
+            <a:off x="6419088" y="1719072"/>
+            <a:ext cx="4718303" cy="3694176"/>
           </a:xfrm>
           <a:prstGeom prst="rect">
             <a:avLst/>
@@ -3677,17 +3828,26 @@
           <a:p>
             <a:pPr>
               <a:spcAft>
-                <a:spcPts val="800"/>
+                <a:spcPts val="1000"/>
               </a:spcAft>
             </a:pPr>
             <a:r>
-              <a:rPr sz="1700" b="1">
+              <a:rPr sz="1100" b="1">
                 <a:solidFill>
                   <a:srgbClr val="FBBF24"/>
                 </a:solidFill>
                 <a:latin typeface="Segoe UI"/>
               </a:rPr>
-              <a:t>Real-World Threats (BlackLotus &amp; LogoFAIL)</a:t>
+              <a:t>[REAL-WORLD VECTORS] </a:t>
+            </a:r>
+            <a:r>
+              <a:rPr sz="1600" b="1">
+                <a:solidFill>
+                  <a:srgbClr val="F8FAFC"/>
+                </a:solidFill>
+                <a:latin typeface="Segoe UI"/>
+              </a:rPr>
+              <a:t>BlackLotus (2023) &amp; Bootkitty (2024)</a:t>
             </a:r>
           </a:p>
           <a:p>
@@ -3697,22 +3857,22 @@
               </a:spcAft>
             </a:pPr>
             <a:r>
-              <a:rPr sz="1300" b="1">
+              <a:rPr sz="1250" b="1">
                 <a:solidFill>
                   <a:srgbClr val="38BDF8"/>
                 </a:solidFill>
                 <a:latin typeface="Segoe UI"/>
               </a:rPr>
-              <a:t>BlackLotus (2023): </a:t>
-            </a:r>
-            <a:r>
-              <a:rPr sz="1300">
+              <a:t>BlackLotus: </a:t>
+            </a:r>
+            <a:r>
+              <a:rPr sz="1250">
                 <a:solidFill>
                   <a:srgbClr val="F8FAFC"/>
                 </a:solidFill>
                 <a:latin typeface="Segoe UI"/>
               </a:rPr>
-              <a:t>Bypassed UEFI Secure Boot by loading authentic, validly-signed Microsoft binaries that harbored an unpatched flaw.</a:t>
+              <a:t>Bypassed UEFI Secure Boot by deploying authentic, validly-signed Microsoft binaries that harbored known CVEs.</a:t>
             </a:r>
           </a:p>
           <a:p>
@@ -3722,22 +3882,22 @@
               </a:spcAft>
             </a:pPr>
             <a:r>
-              <a:rPr sz="1300" b="1">
+              <a:rPr sz="1250" b="1">
                 <a:solidFill>
                   <a:srgbClr val="38BDF8"/>
                 </a:solidFill>
                 <a:latin typeface="Segoe UI"/>
               </a:rPr>
-              <a:t>Bootkitty (2024): </a:t>
-            </a:r>
-            <a:r>
-              <a:rPr sz="1300">
+              <a:t>Bootkitty: </a:t>
+            </a:r>
+            <a:r>
+              <a:rPr sz="1250">
                 <a:solidFill>
                   <a:srgbClr val="F8FAFC"/>
                 </a:solidFill>
                 <a:latin typeface="Segoe UI"/>
               </a:rPr>
-              <a:t>Exploited genuine signed components in Ubuntu via LogoFAIL memory corruption.</a:t>
+              <a:t>Compromised Ubuntu Secure Boot through signed components via LogoFAIL memory vulnerabilities.</a:t>
             </a:r>
           </a:p>
           <a:p>
@@ -3747,7 +3907,7 @@
               </a:spcAft>
             </a:pPr>
             <a:r>
-              <a:rPr sz="1300" b="1">
+              <a:rPr sz="1250" b="1">
                 <a:solidFill>
                   <a:srgbClr val="FBBF24"/>
                 </a:solidFill>
@@ -3756,13 +3916,13 @@
               <a:t>The Reality: </a:t>
             </a:r>
             <a:r>
-              <a:rPr sz="1300">
+              <a:rPr sz="1250">
                 <a:solidFill>
                   <a:srgbClr val="F8FAFC"/>
                 </a:solidFill>
                 <a:latin typeface="Segoe UI"/>
               </a:rPr>
-              <a:t>Every signature was genuine. Every hash matched. The machine was fully compromised anyway.</a:t>
+              <a:t>Every signature was valid. Every hash matched. The machine was owned anyway.</a:t>
             </a:r>
           </a:p>
           <a:p>
@@ -3772,22 +3932,101 @@
               </a:spcAft>
             </a:pPr>
             <a:r>
+              <a:rPr sz="1250" b="1">
+                <a:solidFill>
+                  <a:srgbClr val="34D399"/>
+                </a:solidFill>
+                <a:latin typeface="Segoe UI"/>
+              </a:rPr>
+              <a:t>The Key Signal: </a:t>
+            </a:r>
+            <a:r>
+              <a:rPr sz="1250">
+                <a:solidFill>
+                  <a:srgbClr val="F8FAFC"/>
+                </a:solidFill>
+                <a:latin typeface="Segoe UI"/>
+              </a:rPr>
+              <a:t>Boot event sequence order is the only remaining anomaly signal.</a:t>
+            </a:r>
+          </a:p>
+        </p:txBody>
+      </p:sp>
+      <p:sp>
+        <p:nvSpPr>
+          <p:cNvPr id="10" name="Rounded Rectangle 9"/>
+          <p:cNvSpPr/>
+          <p:nvPr/>
+        </p:nvSpPr>
+        <p:spPr>
+          <a:xfrm>
+            <a:off x="731520" y="5715000"/>
+            <a:ext cx="10607040" cy="685800"/>
+          </a:xfrm>
+          <a:prstGeom prst="roundRect">
+            <a:avLst/>
+          </a:prstGeom>
+          <a:solidFill>
+            <a:srgbClr val="131B2C"/>
+          </a:solidFill>
+          <a:ln w="12700">
+            <a:solidFill>
+              <a:srgbClr val="10B981"/>
+            </a:solidFill>
+          </a:ln>
+        </p:spPr>
+        <p:style>
+          <a:lnRef idx="1">
+            <a:schemeClr val="accent1"/>
+          </a:lnRef>
+          <a:fillRef idx="3">
+            <a:schemeClr val="accent1"/>
+          </a:fillRef>
+          <a:effectRef idx="2">
+            <a:schemeClr val="accent1"/>
+          </a:effectRef>
+          <a:fontRef idx="minor">
+            <a:schemeClr val="lt1"/>
+          </a:fontRef>
+        </p:style>
+        <p:txBody>
+          <a:bodyPr rtlCol="0" anchor="ctr"/>
+          <a:lstStyle/>
+          <a:p>
+            <a:pPr algn="ctr"/>
+          </a:p>
+        </p:txBody>
+      </p:sp>
+      <p:sp>
+        <p:nvSpPr>
+          <p:cNvPr id="11" name="TextBox 10"/>
+          <p:cNvSpPr txBox="1"/>
+          <p:nvPr/>
+        </p:nvSpPr>
+        <p:spPr>
+          <a:xfrm>
+            <a:off x="914400" y="5760720"/>
+            <a:ext cx="10241280" cy="594360"/>
+          </a:xfrm>
+          <a:prstGeom prst="rect">
+            <a:avLst/>
+          </a:prstGeom>
+          <a:noFill/>
+        </p:spPr>
+        <p:txBody>
+          <a:bodyPr wrap="none">
+            <a:spAutoFit/>
+          </a:bodyPr>
+          <a:lstStyle/>
+          <a:p>
+            <a:r>
               <a:rPr sz="1300" b="1">
                 <a:solidFill>
                   <a:srgbClr val="34D399"/>
                 </a:solidFill>
                 <a:latin typeface="Segoe UI"/>
               </a:rPr>
-              <a:t>The Remedy: </a:t>
-            </a:r>
-            <a:r>
-              <a:rPr sz="1300">
-                <a:solidFill>
-                  <a:srgbClr val="F8FAFC"/>
-                </a:solidFill>
-                <a:latin typeface="Segoe UI"/>
-              </a:rPr>
-              <a:t>Boot sequence order is the only remaining signal.</a:t>
+              <a:t>💡 PRAHARI Principle: Boot integrity is a property of the ORDER of events, not of individual hashes.</a:t>
             </a:r>
           </a:p>
         </p:txBody>
@@ -3825,7 +4064,7 @@
             <a:avLst/>
           </a:prstGeom>
           <a:solidFill>
-            <a:srgbClr val="0B1120"/>
+            <a:srgbClr val="0A0F1D"/>
           </a:solidFill>
           <a:ln>
             <a:noFill/>
@@ -3855,104 +4094,23 @@
       </p:sp>
       <p:sp>
         <p:nvSpPr>
-          <p:cNvPr id="3" name="TextBox 2"/>
-          <p:cNvSpPr txBox="1"/>
+          <p:cNvPr id="3" name="Rectangle 2"/>
+          <p:cNvSpPr/>
           <p:nvPr/>
         </p:nvSpPr>
         <p:spPr>
           <a:xfrm>
-            <a:off x="731520" y="365760"/>
-            <a:ext cx="10698480" cy="365760"/>
+            <a:off x="0" y="0"/>
+            <a:ext cx="12191695" cy="54864"/>
           </a:xfrm>
           <a:prstGeom prst="rect">
             <a:avLst/>
           </a:prstGeom>
-          <a:noFill/>
-        </p:spPr>
-        <p:txBody>
-          <a:bodyPr wrap="square">
-            <a:spAutoFit/>
-          </a:bodyPr>
-          <a:lstStyle/>
-          <a:p>
-            <a:r>
-              <a:rPr sz="1100" b="1">
-                <a:solidFill>
-                  <a:srgbClr val="38BDF8"/>
-                </a:solidFill>
-                <a:latin typeface="Segoe UI"/>
-              </a:rPr>
-              <a:t>OUR INNOVATION</a:t>
-            </a:r>
-          </a:p>
-        </p:txBody>
-      </p:sp>
-      <p:sp>
-        <p:nvSpPr>
-          <p:cNvPr id="4" name="TextBox 3"/>
-          <p:cNvSpPr txBox="1"/>
-          <p:nvPr/>
-        </p:nvSpPr>
-        <p:spPr>
-          <a:xfrm>
-            <a:off x="731520" y="685800"/>
-            <a:ext cx="10698480" cy="640080"/>
-          </a:xfrm>
-          <a:prstGeom prst="rect">
-            <a:avLst/>
-          </a:prstGeom>
-          <a:noFill/>
-        </p:spPr>
-        <p:txBody>
-          <a:bodyPr wrap="square">
-            <a:spAutoFit/>
-          </a:bodyPr>
-          <a:lstStyle/>
-          <a:p>
-            <a:r>
-              <a:rPr sz="2600" b="1">
-                <a:solidFill>
-                  <a:srgbClr val="F8FAFC"/>
-                </a:solidFill>
-                <a:latin typeface="Segoe UI"/>
-              </a:rPr>
-              <a:t>Dual-Axis Token Projection &amp; N-Gram Behavioral Modeling</a:t>
-            </a:r>
-          </a:p>
-          <a:p>
-            <a:r>
-              <a:rPr sz="1300">
-                <a:solidFill>
-                  <a:srgbClr val="94A3B8"/>
-                </a:solidFill>
-                <a:latin typeface="Segoe UI"/>
-              </a:rPr>
-              <a:t>Zero kernel patches, zero new hardware — runs directly on Linux securityfs IMA logs</a:t>
-            </a:r>
-          </a:p>
-        </p:txBody>
-      </p:sp>
-      <p:sp>
-        <p:nvSpPr>
-          <p:cNvPr id="5" name="Rounded Rectangle 4"/>
-          <p:cNvSpPr/>
-          <p:nvPr/>
-        </p:nvSpPr>
-        <p:spPr>
-          <a:xfrm>
-            <a:off x="731520" y="1645920"/>
-            <a:ext cx="3383280" cy="4572000"/>
-          </a:xfrm>
-          <a:prstGeom prst="roundRect">
-            <a:avLst/>
-          </a:prstGeom>
           <a:solidFill>
-            <a:srgbClr val="161E2E"/>
+            <a:srgbClr val="38BDF8"/>
           </a:solidFill>
-          <a:ln w="12700">
-            <a:solidFill>
-              <a:srgbClr val="2D3B55"/>
-            </a:solidFill>
+          <a:ln>
+            <a:noFill/>
           </a:ln>
         </p:spPr>
         <p:style>
@@ -3979,14 +4137,14 @@
       </p:sp>
       <p:sp>
         <p:nvSpPr>
-          <p:cNvPr id="6" name="TextBox 5"/>
+          <p:cNvPr id="4" name="TextBox 3"/>
           <p:cNvSpPr txBox="1"/>
           <p:nvPr/>
         </p:nvSpPr>
         <p:spPr>
           <a:xfrm>
-            <a:off x="914400" y="1783080"/>
-            <a:ext cx="3017520" cy="4297680"/>
+            <a:off x="731520" y="365760"/>
+            <a:ext cx="10698480" cy="320040"/>
           </a:xfrm>
           <a:prstGeom prst="rect">
             <a:avLst/>
@@ -3999,19 +4157,152 @@
           </a:bodyPr>
           <a:lstStyle/>
           <a:p>
+            <a:r>
+              <a:rPr sz="1100" b="1">
+                <a:solidFill>
+                  <a:srgbClr val="38BDF8"/>
+                </a:solidFill>
+                <a:latin typeface="Segoe UI"/>
+              </a:rPr>
+              <a:t>CORE INNOVATION</a:t>
+            </a:r>
+          </a:p>
+        </p:txBody>
+      </p:sp>
+      <p:sp>
+        <p:nvSpPr>
+          <p:cNvPr id="5" name="TextBox 4"/>
+          <p:cNvSpPr txBox="1"/>
+          <p:nvPr/>
+        </p:nvSpPr>
+        <p:spPr>
+          <a:xfrm>
+            <a:off x="731520" y="640080"/>
+            <a:ext cx="10698480" cy="548640"/>
+          </a:xfrm>
+          <a:prstGeom prst="rect">
+            <a:avLst/>
+          </a:prstGeom>
+          <a:noFill/>
+        </p:spPr>
+        <p:txBody>
+          <a:bodyPr wrap="square">
+            <a:spAutoFit/>
+          </a:bodyPr>
+          <a:lstStyle/>
+          <a:p>
+            <a:r>
+              <a:rPr sz="2400" b="1">
+                <a:solidFill>
+                  <a:srgbClr val="F8FAFC"/>
+                </a:solidFill>
+                <a:latin typeface="Segoe UI"/>
+              </a:rPr>
+              <a:t>Dual-Axis Token Projection &amp; N-Gram Sequence Modeling</a:t>
+            </a:r>
+          </a:p>
+          <a:p>
+            <a:r>
+              <a:rPr sz="1200">
+                <a:solidFill>
+                  <a:srgbClr val="94A3B8"/>
+                </a:solidFill>
+                <a:latin typeface="Segoe UI"/>
+              </a:rPr>
+              <a:t>Zero kernel patches, zero new hardware — reads native Linux securityfs IMA measurement logs.</a:t>
+            </a:r>
+          </a:p>
+        </p:txBody>
+      </p:sp>
+      <p:sp>
+        <p:nvSpPr>
+          <p:cNvPr id="6" name="Rounded Rectangle 5"/>
+          <p:cNvSpPr/>
+          <p:nvPr/>
+        </p:nvSpPr>
+        <p:spPr>
+          <a:xfrm>
+            <a:off x="731520" y="1554480"/>
+            <a:ext cx="3383280" cy="4846320"/>
+          </a:xfrm>
+          <a:prstGeom prst="roundRect">
+            <a:avLst/>
+          </a:prstGeom>
+          <a:solidFill>
+            <a:srgbClr val="131B2C"/>
+          </a:solidFill>
+          <a:ln w="12700">
+            <a:solidFill>
+              <a:srgbClr val="26334D"/>
+            </a:solidFill>
+          </a:ln>
+        </p:spPr>
+        <p:style>
+          <a:lnRef idx="1">
+            <a:schemeClr val="accent1"/>
+          </a:lnRef>
+          <a:fillRef idx="3">
+            <a:schemeClr val="accent1"/>
+          </a:fillRef>
+          <a:effectRef idx="2">
+            <a:schemeClr val="accent1"/>
+          </a:effectRef>
+          <a:fontRef idx="minor">
+            <a:schemeClr val="lt1"/>
+          </a:fontRef>
+        </p:style>
+        <p:txBody>
+          <a:bodyPr rtlCol="0" anchor="ctr"/>
+          <a:lstStyle/>
+          <a:p>
+            <a:pPr algn="ctr"/>
+          </a:p>
+        </p:txBody>
+      </p:sp>
+      <p:sp>
+        <p:nvSpPr>
+          <p:cNvPr id="7" name="TextBox 6"/>
+          <p:cNvSpPr txBox="1"/>
+          <p:nvPr/>
+        </p:nvSpPr>
+        <p:spPr>
+          <a:xfrm>
+            <a:off x="932688" y="1719072"/>
+            <a:ext cx="2980944" cy="4517136"/>
+          </a:xfrm>
+          <a:prstGeom prst="rect">
+            <a:avLst/>
+          </a:prstGeom>
+          <a:noFill/>
+        </p:spPr>
+        <p:txBody>
+          <a:bodyPr wrap="square">
+            <a:spAutoFit/>
+          </a:bodyPr>
+          <a:lstStyle/>
+          <a:p>
             <a:pPr>
               <a:spcAft>
-                <a:spcPts val="800"/>
+                <a:spcPts val="1000"/>
               </a:spcAft>
             </a:pPr>
             <a:r>
-              <a:rPr sz="1700" b="1">
+              <a:rPr sz="1100" b="1">
                 <a:solidFill>
                   <a:srgbClr val="38BDF8"/>
                 </a:solidFill>
                 <a:latin typeface="Segoe UI"/>
               </a:rPr>
-              <a:t>1. Dual Token Projection</a:t>
+              <a:t>[1. PROJECTION] </a:t>
+            </a:r>
+            <a:r>
+              <a:rPr sz="1600" b="1">
+                <a:solidFill>
+                  <a:srgbClr val="F8FAFC"/>
+                </a:solidFill>
+                <a:latin typeface="Segoe UI"/>
+              </a:rPr>
+              <a:t>Dual-Axis Tokenization</a:t>
             </a:r>
           </a:p>
           <a:p>
@@ -4021,7 +4312,7 @@
               </a:spcAft>
             </a:pPr>
             <a:r>
-              <a:rPr sz="1300" b="1">
+              <a:rPr sz="1250" b="1">
                 <a:solidFill>
                   <a:srgbClr val="38BDF8"/>
                 </a:solidFill>
@@ -4030,13 +4321,13 @@
               <a:t>Identity Axis: </a:t>
             </a:r>
             <a:r>
-              <a:rPr sz="1300">
+              <a:rPr sz="1250">
                 <a:solidFill>
                   <a:srgbClr val="F8FAFC"/>
                 </a:solidFill>
                 <a:latin typeface="Segoe UI"/>
               </a:rPr>
-              <a:t>Normalised path (e.g. /init, /bin/systemd) — remains deterministic across clean boots.</a:t>
+              <a:t>Normalised path (/init, /bin/systemd) — deterministic across boots.</a:t>
             </a:r>
           </a:p>
           <a:p>
@@ -4046,7 +4337,7 @@
               </a:spcAft>
             </a:pPr>
             <a:r>
-              <a:rPr sz="1300" b="1">
+              <a:rPr sz="1250" b="1">
                 <a:solidFill>
                   <a:srgbClr val="34D399"/>
                 </a:solidFill>
@@ -4055,13 +4346,13 @@
               <a:t>Content Axis: </a:t>
             </a:r>
             <a:r>
-              <a:rPr sz="1300">
+              <a:rPr sz="1250">
                 <a:solidFill>
                   <a:srgbClr val="F8FAFC"/>
                 </a:solidFill>
                 <a:latin typeface="Segoe UI"/>
               </a:rPr>
-              <a:t>Cryptographic hash — detects direct byte-level tampering.</a:t>
+              <a:t>Cryptographic hash — catches direct byte corruption.</a:t>
             </a:r>
           </a:p>
           <a:p>
@@ -4071,46 +4362,71 @@
               </a:spcAft>
             </a:pPr>
             <a:r>
-              <a:rPr sz="1300" b="1">
+              <a:rPr sz="1250" b="1">
                 <a:solidFill>
                   <a:srgbClr val="94A3B8"/>
                 </a:solidFill>
                 <a:latin typeface="Segoe UI"/>
               </a:rPr>
-              <a:t>Why it matters: </a:t>
-            </a:r>
-            <a:r>
-              <a:rPr sz="1300">
+              <a:t>The Innovation: </a:t>
+            </a:r>
+            <a:r>
+              <a:rPr sz="1250">
                 <a:solidFill>
                   <a:srgbClr val="F8FAFC"/>
                 </a:solidFill>
                 <a:latin typeface="Segoe UI"/>
               </a:rPr>
-              <a:t>Projects continuous measurement logs into discrete tokens for sequence anomaly analysis.</a:t>
-            </a:r>
-          </a:p>
-        </p:txBody>
-      </p:sp>
-      <p:sp>
-        <p:nvSpPr>
-          <p:cNvPr id="7" name="Rounded Rectangle 6"/>
+              <a:t>Projects continuous measurement streams into discrete tokens for sequence modeling.</a:t>
+            </a:r>
+          </a:p>
+          <a:p>
+            <a:pPr>
+              <a:spcAft>
+                <a:spcPts val="600"/>
+              </a:spcAft>
+            </a:pPr>
+            <a:r>
+              <a:rPr sz="1250" b="1">
+                <a:solidFill>
+                  <a:srgbClr val="94A3B8"/>
+                </a:solidFill>
+                <a:latin typeface="Segoe UI"/>
+              </a:rPr>
+              <a:t>Native IMA: </a:t>
+            </a:r>
+            <a:r>
+              <a:rPr sz="1250">
+                <a:solidFill>
+                  <a:srgbClr val="F8FAFC"/>
+                </a:solidFill>
+                <a:latin typeface="Segoe UI"/>
+              </a:rPr>
+              <a:t>Reads /sys/kernel/security/ima/ascii_runtime_measurements directly.</a:t>
+            </a:r>
+          </a:p>
+        </p:txBody>
+      </p:sp>
+      <p:sp>
+        <p:nvSpPr>
+          <p:cNvPr id="8" name="Rounded Rectangle 7"/>
           <p:cNvSpPr/>
           <p:nvPr/>
         </p:nvSpPr>
         <p:spPr>
           <a:xfrm>
-            <a:off x="4389120" y="1645920"/>
-            <a:ext cx="3383280" cy="4572000"/>
+            <a:off x="4389120" y="1554480"/>
+            <a:ext cx="3383280" cy="4846320"/>
           </a:xfrm>
           <a:prstGeom prst="roundRect">
             <a:avLst/>
           </a:prstGeom>
           <a:solidFill>
-            <a:srgbClr val="161E2E"/>
+            <a:srgbClr val="131B2C"/>
           </a:solidFill>
           <a:ln w="12700">
             <a:solidFill>
-              <a:srgbClr val="2D3B55"/>
+              <a:srgbClr val="26334D"/>
             </a:solidFill>
           </a:ln>
         </p:spPr>
@@ -4138,14 +4454,14 @@
       </p:sp>
       <p:sp>
         <p:nvSpPr>
-          <p:cNvPr id="8" name="TextBox 7"/>
+          <p:cNvPr id="9" name="TextBox 8"/>
           <p:cNvSpPr txBox="1"/>
           <p:nvPr/>
         </p:nvSpPr>
         <p:spPr>
           <a:xfrm>
-            <a:off x="4572000" y="1783080"/>
-            <a:ext cx="3017520" cy="4297680"/>
+            <a:off x="4590288" y="1719072"/>
+            <a:ext cx="2980944" cy="4517136"/>
           </a:xfrm>
           <a:prstGeom prst="rect">
             <a:avLst/>
@@ -4160,17 +4476,26 @@
           <a:p>
             <a:pPr>
               <a:spcAft>
-                <a:spcPts val="800"/>
+                <a:spcPts val="1000"/>
               </a:spcAft>
             </a:pPr>
             <a:r>
-              <a:rPr sz="1700" b="1">
+              <a:rPr sz="1100" b="1">
                 <a:solidFill>
                   <a:srgbClr val="34D399"/>
                 </a:solidFill>
                 <a:latin typeface="Segoe UI"/>
               </a:rPr>
-              <a:t>2. N-Gram Learning</a:t>
+              <a:t>[2. LEARNING] </a:t>
+            </a:r>
+            <a:r>
+              <a:rPr sz="1600" b="1">
+                <a:solidFill>
+                  <a:srgbClr val="F8FAFC"/>
+                </a:solidFill>
+                <a:latin typeface="Segoe UI"/>
+              </a:rPr>
+              <a:t>N-Gram Behavioral Model</a:t>
             </a:r>
           </a:p>
           <a:p>
@@ -4180,22 +4505,22 @@
               </a:spcAft>
             </a:pPr>
             <a:r>
-              <a:rPr sz="1300" b="1">
+              <a:rPr sz="1250" b="1">
                 <a:solidFill>
                   <a:srgbClr val="34D399"/>
                 </a:solidFill>
                 <a:latin typeface="Segoe UI"/>
               </a:rPr>
-              <a:t>Rapid Convergence: </a:t>
-            </a:r>
-            <a:r>
-              <a:rPr sz="1300">
+              <a:t>Rapid Training: </a:t>
+            </a:r>
+            <a:r>
+              <a:rPr sz="1250">
                 <a:solidFill>
                   <a:srgbClr val="F8FAFC"/>
                 </a:solidFill>
                 <a:latin typeface="Segoe UI"/>
               </a:rPr>
-              <a:t>Converges within 4-5 baseline boots of the physical machine.</a:t>
+              <a:t>Converges within 4-5 baseline boots on physical machines.</a:t>
             </a:r>
           </a:p>
           <a:p>
@@ -4205,22 +4530,22 @@
               </a:spcAft>
             </a:pPr>
             <a:r>
-              <a:rPr sz="1300" b="1">
+              <a:rPr sz="1250" b="1">
                 <a:solidFill>
                   <a:srgbClr val="34D399"/>
                 </a:solidFill>
                 <a:latin typeface="Segoe UI"/>
               </a:rPr>
-              <a:t>Inspectable: </a:t>
-            </a:r>
-            <a:r>
-              <a:rPr sz="1300">
+              <a:t>100% Inspectable: </a:t>
+            </a:r>
+            <a:r>
+              <a:rPr sz="1250">
                 <a:solidFill>
                   <a:srgbClr val="F8FAFC"/>
                 </a:solidFill>
                 <a:latin typeface="Segoe UI"/>
               </a:rPr>
-              <a:t>Every alert pinpoints the exact anomalous transition (A -&gt; B -&gt; C).</a:t>
+              <a:t>Every alert points to a concrete transition: A -&gt; B -&gt; C.</a:t>
             </a:r>
           </a:p>
           <a:p>
@@ -4230,46 +4555,71 @@
               </a:spcAft>
             </a:pPr>
             <a:r>
-              <a:rPr sz="1300" b="1">
+              <a:rPr sz="1250" b="1">
+                <a:solidFill>
+                  <a:srgbClr val="FBBF24"/>
+                </a:solidFill>
+                <a:latin typeface="Segoe UI"/>
+              </a:rPr>
+              <a:t>Zero Black Box: </a:t>
+            </a:r>
+            <a:r>
+              <a:rPr sz="1250">
                 <a:solidFill>
                   <a:srgbClr val="F8FAFC"/>
                 </a:solidFill>
                 <a:latin typeface="Segoe UI"/>
               </a:rPr>
-              <a:t>Zero Black Box: </a:t>
-            </a:r>
-            <a:r>
-              <a:rPr sz="1300">
+              <a:t>Avoids opaque neural weights (DeepLog/LogBERT) that require 10,000+ logs.</a:t>
+            </a:r>
+          </a:p>
+          <a:p>
+            <a:pPr>
+              <a:spcAft>
+                <a:spcPts val="600"/>
+              </a:spcAft>
+            </a:pPr>
+            <a:r>
+              <a:rPr sz="1250" b="1">
                 <a:solidFill>
                   <a:srgbClr val="F8FAFC"/>
                 </a:solidFill>
                 <a:latin typeface="Segoe UI"/>
               </a:rPr>
-              <a:t>No opaque neural network weights; human auditors can verify every alert.</a:t>
-            </a:r>
-          </a:p>
-        </p:txBody>
-      </p:sp>
-      <p:sp>
-        <p:nvSpPr>
-          <p:cNvPr id="9" name="Rounded Rectangle 8"/>
+              <a:t>Actionable: </a:t>
+            </a:r>
+            <a:r>
+              <a:rPr sz="1250">
+                <a:solidFill>
+                  <a:srgbClr val="F8FAFC"/>
+                </a:solidFill>
+                <a:latin typeface="Segoe UI"/>
+              </a:rPr>
+              <a:t>System administrators can verify and audit every flagged anomaly.</a:t>
+            </a:r>
+          </a:p>
+        </p:txBody>
+      </p:sp>
+      <p:sp>
+        <p:nvSpPr>
+          <p:cNvPr id="10" name="Rounded Rectangle 9"/>
           <p:cNvSpPr/>
           <p:nvPr/>
         </p:nvSpPr>
         <p:spPr>
           <a:xfrm>
-            <a:off x="8046720" y="1645920"/>
-            <a:ext cx="3383280" cy="4572000"/>
+            <a:off x="8046720" y="1554480"/>
+            <a:ext cx="3383280" cy="4846320"/>
           </a:xfrm>
           <a:prstGeom prst="roundRect">
             <a:avLst/>
           </a:prstGeom>
           <a:solidFill>
-            <a:srgbClr val="161E2E"/>
+            <a:srgbClr val="131B2C"/>
           </a:solidFill>
           <a:ln w="12700">
             <a:solidFill>
-              <a:srgbClr val="2D3B55"/>
+              <a:srgbClr val="A855F7"/>
             </a:solidFill>
           </a:ln>
         </p:spPr>
@@ -4297,14 +4647,14 @@
       </p:sp>
       <p:sp>
         <p:nvSpPr>
-          <p:cNvPr id="10" name="TextBox 9"/>
+          <p:cNvPr id="11" name="TextBox 10"/>
           <p:cNvSpPr txBox="1"/>
           <p:nvPr/>
         </p:nvSpPr>
         <p:spPr>
           <a:xfrm>
-            <a:off x="8229600" y="1783080"/>
-            <a:ext cx="3017520" cy="4297680"/>
+            <a:off x="8247888" y="1719072"/>
+            <a:ext cx="2980944" cy="4517136"/>
           </a:xfrm>
           <a:prstGeom prst="rect">
             <a:avLst/>
@@ -4319,17 +4669,26 @@
           <a:p>
             <a:pPr>
               <a:spcAft>
-                <a:spcPts val="800"/>
+                <a:spcPts val="1000"/>
               </a:spcAft>
             </a:pPr>
             <a:r>
-              <a:rPr sz="1700" b="1">
-                <a:solidFill>
-                  <a:srgbClr val="A855F7"/>
-                </a:solidFill>
-                <a:latin typeface="Segoe UI"/>
-              </a:rPr>
-              <a:t>3. Hybrid PQC Signing</a:t>
+              <a:rPr sz="1100" b="1">
+                <a:solidFill>
+                  <a:srgbClr val="C084FC"/>
+                </a:solidFill>
+                <a:latin typeface="Segoe UI"/>
+              </a:rPr>
+              <a:t>[3. POST-QUANTUM] </a:t>
+            </a:r>
+            <a:r>
+              <a:rPr sz="1600" b="1">
+                <a:solidFill>
+                  <a:srgbClr val="F8FAFC"/>
+                </a:solidFill>
+                <a:latin typeface="Segoe UI"/>
+              </a:rPr>
+              <a:t>Dual Hybrid Signing</a:t>
             </a:r>
           </a:p>
           <a:p>
@@ -4339,16 +4698,16 @@
               </a:spcAft>
             </a:pPr>
             <a:r>
-              <a:rPr sz="1300" b="1">
-                <a:solidFill>
-                  <a:srgbClr val="A855F7"/>
+              <a:rPr sz="1250" b="1">
+                <a:solidFill>
+                  <a:srgbClr val="C084FC"/>
                 </a:solidFill>
                 <a:latin typeface="Segoe UI"/>
               </a:rPr>
               <a:t>Dual Signatures: </a:t>
             </a:r>
             <a:r>
-              <a:rPr sz="1300">
+              <a:rPr sz="1250">
                 <a:solidFill>
                   <a:srgbClr val="F8FAFC"/>
                 </a:solidFill>
@@ -4364,16 +4723,16 @@
               </a:spcAft>
             </a:pPr>
             <a:r>
-              <a:rPr sz="1300" b="1">
-                <a:solidFill>
-                  <a:srgbClr val="A855F7"/>
+              <a:rPr sz="1250" b="1">
+                <a:solidFill>
+                  <a:srgbClr val="C084FC"/>
                 </a:solidFill>
                 <a:latin typeface="Segoe UI"/>
               </a:rPr>
               <a:t>RFC 9019 Standard: </a:t>
             </a:r>
             <a:r>
-              <a:rPr sz="1300">
+              <a:rPr sz="1250">
                 <a:solidFill>
                   <a:srgbClr val="F8FAFC"/>
                 </a:solidFill>
@@ -4389,7 +4748,32 @@
               </a:spcAft>
             </a:pPr>
             <a:r>
-              <a:rPr sz="1300" b="1">
+              <a:rPr sz="1250" b="1">
+                <a:solidFill>
+                  <a:srgbClr val="34D399"/>
+                </a:solidFill>
+                <a:latin typeface="Segoe UI"/>
+              </a:rPr>
+              <a:t>NSA CNSA 2.0: </a:t>
+            </a:r>
+            <a:r>
+              <a:rPr sz="1250">
+                <a:solidFill>
+                  <a:srgbClr val="F8FAFC"/>
+                </a:solidFill>
+                <a:latin typeface="Segoe UI"/>
+              </a:rPr>
+              <a:t>Directly satisfies national priority for quantum-safe boot firmware.</a:t>
+            </a:r>
+          </a:p>
+          <a:p>
+            <a:pPr>
+              <a:spcAft>
+                <a:spcPts val="600"/>
+              </a:spcAft>
+            </a:pPr>
+            <a:r>
+              <a:rPr sz="1250" b="1">
                 <a:solidFill>
                   <a:srgbClr val="94A3B8"/>
                 </a:solidFill>
@@ -4398,7 +4782,7 @@
               <a:t>OpenSSL 3.5: </a:t>
             </a:r>
             <a:r>
-              <a:rPr sz="1300">
+              <a:rPr sz="1250">
                 <a:solidFill>
                   <a:srgbClr val="F8FAFC"/>
                 </a:solidFill>
@@ -4442,7 +4826,7 @@
             <a:avLst/>
           </a:prstGeom>
           <a:solidFill>
-            <a:srgbClr val="0B1120"/>
+            <a:srgbClr val="0A0F1D"/>
           </a:solidFill>
           <a:ln>
             <a:noFill/>
@@ -4472,104 +4856,23 @@
       </p:sp>
       <p:sp>
         <p:nvSpPr>
-          <p:cNvPr id="3" name="TextBox 2"/>
-          <p:cNvSpPr txBox="1"/>
+          <p:cNvPr id="3" name="Rectangle 2"/>
+          <p:cNvSpPr/>
           <p:nvPr/>
         </p:nvSpPr>
         <p:spPr>
           <a:xfrm>
-            <a:off x="731520" y="365760"/>
-            <a:ext cx="10698480" cy="365760"/>
+            <a:off x="0" y="0"/>
+            <a:ext cx="12191695" cy="54864"/>
           </a:xfrm>
           <a:prstGeom prst="rect">
             <a:avLst/>
           </a:prstGeom>
-          <a:noFill/>
-        </p:spPr>
-        <p:txBody>
-          <a:bodyPr wrap="square">
-            <a:spAutoFit/>
-          </a:bodyPr>
-          <a:lstStyle/>
-          <a:p>
-            <a:r>
-              <a:rPr sz="1100" b="1">
-                <a:solidFill>
-                  <a:srgbClr val="38BDF8"/>
-                </a:solidFill>
-                <a:latin typeface="Segoe UI"/>
-              </a:rPr>
-              <a:t>EMPIRICAL EVALUATION</a:t>
-            </a:r>
-          </a:p>
-        </p:txBody>
-      </p:sp>
-      <p:sp>
-        <p:nvSpPr>
-          <p:cNvPr id="4" name="TextBox 3"/>
-          <p:cNvSpPr txBox="1"/>
-          <p:nvPr/>
-        </p:nvSpPr>
-        <p:spPr>
-          <a:xfrm>
-            <a:off x="731520" y="685800"/>
-            <a:ext cx="10698480" cy="640080"/>
-          </a:xfrm>
-          <a:prstGeom prst="rect">
-            <a:avLst/>
-          </a:prstGeom>
-          <a:noFill/>
-        </p:spPr>
-        <p:txBody>
-          <a:bodyPr wrap="square">
-            <a:spAutoFit/>
-          </a:bodyPr>
-          <a:lstStyle/>
-          <a:p>
-            <a:r>
-              <a:rPr sz="2600" b="1">
-                <a:solidFill>
-                  <a:srgbClr val="F8FAFC"/>
-                </a:solidFill>
-                <a:latin typeface="Segoe UI"/>
-              </a:rPr>
-              <a:t>4-Vector Threat Benchmark: Allowlist vs PRAHARI</a:t>
-            </a:r>
-          </a:p>
-          <a:p>
-            <a:r>
-              <a:rPr sz="1300">
-                <a:solidFill>
-                  <a:srgbClr val="94A3B8"/>
-                </a:solidFill>
-                <a:latin typeface="Segoe UI"/>
-              </a:rPr>
-              <a:t>Evaluating tamper, insert, reorder, and substitute attacks on Linux IMA logs</a:t>
-            </a:r>
-          </a:p>
-        </p:txBody>
-      </p:sp>
-      <p:sp>
-        <p:nvSpPr>
-          <p:cNvPr id="5" name="Rounded Rectangle 4"/>
-          <p:cNvSpPr/>
-          <p:nvPr/>
-        </p:nvSpPr>
-        <p:spPr>
-          <a:xfrm>
-            <a:off x="731520" y="1645920"/>
-            <a:ext cx="10698480" cy="4572000"/>
-          </a:xfrm>
-          <a:prstGeom prst="roundRect">
-            <a:avLst/>
-          </a:prstGeom>
           <a:solidFill>
-            <a:srgbClr val="161E2E"/>
+            <a:srgbClr val="38BDF8"/>
           </a:solidFill>
-          <a:ln w="12700">
-            <a:solidFill>
-              <a:srgbClr val="2D3B55"/>
-            </a:solidFill>
+          <a:ln>
+            <a:noFill/>
           </a:ln>
         </p:spPr>
         <p:style>
@@ -4596,14 +4899,14 @@
       </p:sp>
       <p:sp>
         <p:nvSpPr>
-          <p:cNvPr id="6" name="TextBox 5"/>
+          <p:cNvPr id="4" name="TextBox 3"/>
           <p:cNvSpPr txBox="1"/>
           <p:nvPr/>
         </p:nvSpPr>
         <p:spPr>
           <a:xfrm>
-            <a:off x="1005840" y="1828800"/>
-            <a:ext cx="10149840" cy="4114800"/>
+            <a:off x="731520" y="365760"/>
+            <a:ext cx="10698480" cy="320040"/>
           </a:xfrm>
           <a:prstGeom prst="rect">
             <a:avLst/>
@@ -4616,9 +4919,133 @@
           </a:bodyPr>
           <a:lstStyle/>
           <a:p>
+            <a:r>
+              <a:rPr sz="1100" b="1">
+                <a:solidFill>
+                  <a:srgbClr val="38BDF8"/>
+                </a:solidFill>
+                <a:latin typeface="Segoe UI"/>
+              </a:rPr>
+              <a:t>EVALUATION</a:t>
+            </a:r>
+          </a:p>
+        </p:txBody>
+      </p:sp>
+      <p:sp>
+        <p:nvSpPr>
+          <p:cNvPr id="5" name="TextBox 4"/>
+          <p:cNvSpPr txBox="1"/>
+          <p:nvPr/>
+        </p:nvSpPr>
+        <p:spPr>
+          <a:xfrm>
+            <a:off x="731520" y="640080"/>
+            <a:ext cx="10698480" cy="548640"/>
+          </a:xfrm>
+          <a:prstGeom prst="rect">
+            <a:avLst/>
+          </a:prstGeom>
+          <a:noFill/>
+        </p:spPr>
+        <p:txBody>
+          <a:bodyPr wrap="square">
+            <a:spAutoFit/>
+          </a:bodyPr>
+          <a:lstStyle/>
+          <a:p>
+            <a:r>
+              <a:rPr sz="2400" b="1">
+                <a:solidFill>
+                  <a:srgbClr val="F8FAFC"/>
+                </a:solidFill>
+                <a:latin typeface="Segoe UI"/>
+              </a:rPr>
+              <a:t>4-Vector Threat Benchmark: Allowlist vs PRAHARI</a:t>
+            </a:r>
+          </a:p>
+          <a:p>
+            <a:r>
+              <a:rPr sz="1200">
+                <a:solidFill>
+                  <a:srgbClr val="94A3B8"/>
+                </a:solidFill>
+                <a:latin typeface="Segoe UI"/>
+              </a:rPr>
+              <a:t>Comprehensive evaluation across synthetic and hardware-captured Linux boot logs.</a:t>
+            </a:r>
+          </a:p>
+        </p:txBody>
+      </p:sp>
+      <p:sp>
+        <p:nvSpPr>
+          <p:cNvPr id="6" name="Rounded Rectangle 5"/>
+          <p:cNvSpPr/>
+          <p:nvPr/>
+        </p:nvSpPr>
+        <p:spPr>
+          <a:xfrm>
+            <a:off x="731520" y="1554480"/>
+            <a:ext cx="10698480" cy="4846320"/>
+          </a:xfrm>
+          <a:prstGeom prst="roundRect">
+            <a:avLst/>
+          </a:prstGeom>
+          <a:solidFill>
+            <a:srgbClr val="131B2C"/>
+          </a:solidFill>
+          <a:ln w="12700">
+            <a:solidFill>
+              <a:srgbClr val="26334D"/>
+            </a:solidFill>
+          </a:ln>
+        </p:spPr>
+        <p:style>
+          <a:lnRef idx="1">
+            <a:schemeClr val="accent1"/>
+          </a:lnRef>
+          <a:fillRef idx="3">
+            <a:schemeClr val="accent1"/>
+          </a:fillRef>
+          <a:effectRef idx="2">
+            <a:schemeClr val="accent1"/>
+          </a:effectRef>
+          <a:fontRef idx="minor">
+            <a:schemeClr val="lt1"/>
+          </a:fontRef>
+        </p:style>
+        <p:txBody>
+          <a:bodyPr rtlCol="0" anchor="ctr"/>
+          <a:lstStyle/>
+          <a:p>
+            <a:pPr algn="ctr"/>
+          </a:p>
+        </p:txBody>
+      </p:sp>
+      <p:sp>
+        <p:nvSpPr>
+          <p:cNvPr id="7" name="TextBox 6"/>
+          <p:cNvSpPr txBox="1"/>
+          <p:nvPr/>
+        </p:nvSpPr>
+        <p:spPr>
+          <a:xfrm>
+            <a:off x="914400" y="1737360"/>
+            <a:ext cx="10332720" cy="4389120"/>
+          </a:xfrm>
+          <a:prstGeom prst="rect">
+            <a:avLst/>
+          </a:prstGeom>
+          <a:noFill/>
+        </p:spPr>
+        <p:txBody>
+          <a:bodyPr wrap="square">
+            <a:spAutoFit/>
+          </a:bodyPr>
+          <a:lstStyle/>
+          <a:p>
             <a:pPr>
               <a:spcAft>
-                <a:spcPts val="1200"/>
+                <a:spcPts val="1400"/>
               </a:spcAft>
             </a:pPr>
             <a:r>
@@ -4628,7 +5055,7 @@
                 </a:solidFill>
                 <a:latin typeface="Segoe UI"/>
               </a:rPr>
-              <a:t>ATTACK VECTOR  </a:t>
+              <a:t>ATTACK VECTOR </a:t>
             </a:r>
             <a:r>
               <a:rPr sz="1300">
@@ -4637,7 +5064,7 @@
                 </a:solidFill>
                 <a:latin typeface="Segoe UI"/>
               </a:rPr>
-              <a:t>ATTACK MECHANISM                             </a:t>
+              <a:t>REAL-WORLD THREAT MECHANISM                  </a:t>
             </a:r>
             <a:r>
               <a:rPr b="1" sz="1300">
@@ -4656,12 +5083,21 @@
                 <a:latin typeface="Segoe UI"/>
               </a:rPr>
               <a:t>PRAHARI (BEHAVIOURAL)        </a:t>
+            </a:r>
+            <a:r>
+              <a:rPr b="1" sz="1300">
+                <a:solidFill>
+                  <a:srgbClr val="38BDF8"/>
+                </a:solidFill>
+                <a:latin typeface="Segoe UI"/>
+              </a:rPr>
+              <a:t>VERDICT </a:t>
             </a:r>
           </a:p>
           <a:p>
             <a:pPr>
               <a:spcAft>
-                <a:spcPts val="1200"/>
+                <a:spcPts val="1400"/>
               </a:spcAft>
             </a:pPr>
             <a:r>
@@ -4671,7 +5107,7 @@
                 </a:solidFill>
                 <a:latin typeface="Consolas"/>
               </a:rPr>
-              <a:t>Tamper         </a:t>
+              <a:t>Tamper        </a:t>
             </a:r>
             <a:r>
               <a:rPr sz="1200">
@@ -4680,7 +5116,7 @@
                 </a:solidFill>
                 <a:latin typeface="Consolas"/>
               </a:rPr>
-              <a:t>Direct byte corruption in measured binary    </a:t>
+              <a:t>Direct byte modification in measured binary  </a:t>
             </a:r>
             <a:r>
               <a:rPr b="1" sz="1200">
@@ -4699,12 +5135,21 @@
                 <a:latin typeface="Consolas"/>
               </a:rPr>
               <a:t>DETECT (Tampered Hash)       </a:t>
+            </a:r>
+            <a:r>
+              <a:rPr b="1" sz="1200">
+                <a:solidFill>
+                  <a:srgbClr val="64748B"/>
+                </a:solidFill>
+                <a:latin typeface="Consolas"/>
+              </a:rPr>
+              <a:t>Caught By Both </a:t>
             </a:r>
           </a:p>
           <a:p>
             <a:pPr>
               <a:spcAft>
-                <a:spcPts val="1200"/>
+                <a:spcPts val="1400"/>
               </a:spcAft>
             </a:pPr>
             <a:r>
@@ -4714,7 +5159,7 @@
                 </a:solidFill>
                 <a:latin typeface="Consolas"/>
               </a:rPr>
-              <a:t>Insert         </a:t>
+              <a:t>Insert        </a:t>
             </a:r>
             <a:r>
               <a:rPr sz="1200">
@@ -4723,7 +5168,7 @@
                 </a:solidFill>
                 <a:latin typeface="Consolas"/>
               </a:rPr>
-              <a:t>Injection of unauthorized rogue kernel module </a:t>
+              <a:t>Rogue injected kernel module / persistence payload </a:t>
             </a:r>
             <a:r>
               <a:rPr b="1" sz="1200">
@@ -4742,22 +5187,31 @@
                 <a:latin typeface="Consolas"/>
               </a:rPr>
               <a:t>DETECT (Unknown + Sequence)  </a:t>
+            </a:r>
+            <a:r>
+              <a:rPr b="1" sz="1200">
+                <a:solidFill>
+                  <a:srgbClr val="64748B"/>
+                </a:solidFill>
+                <a:latin typeface="Consolas"/>
+              </a:rPr>
+              <a:t>Caught By Both </a:t>
             </a:r>
           </a:p>
           <a:p>
             <a:pPr>
               <a:spcAft>
-                <a:spcPts val="1200"/>
+                <a:spcPts val="1400"/>
               </a:spcAft>
             </a:pPr>
             <a:r>
               <a:rPr b="1" sz="1200">
                 <a:solidFill>
-                  <a:srgbClr val="FBBF24"/>
+                  <a:srgbClr val="F8FAFC"/>
                 </a:solidFill>
                 <a:latin typeface="Consolas"/>
               </a:rPr>
-              <a:t>Reorder        </a:t>
+              <a:t>Reorder       </a:t>
             </a:r>
             <a:r>
               <a:rPr sz="1200">
@@ -4785,22 +5239,31 @@
                 <a:latin typeface="Consolas"/>
               </a:rPr>
               <a:t>DETECT (Sequence Anomaly)    </a:t>
+            </a:r>
+            <a:r>
+              <a:rPr b="1" sz="1200">
+                <a:solidFill>
+                  <a:srgbClr val="34D399"/>
+                </a:solidFill>
+                <a:latin typeface="Consolas"/>
+              </a:rPr>
+              <a:t>PRAHARI Advantage </a:t>
             </a:r>
           </a:p>
           <a:p>
             <a:pPr>
               <a:spcAft>
-                <a:spcPts val="1200"/>
+                <a:spcPts val="1400"/>
               </a:spcAft>
             </a:pPr>
             <a:r>
               <a:rPr b="1" sz="1200">
                 <a:solidFill>
-                  <a:srgbClr val="FBBF24"/>
+                  <a:srgbClr val="F8FAFC"/>
                 </a:solidFill>
                 <a:latin typeface="Consolas"/>
               </a:rPr>
-              <a:t>Substitute     </a:t>
+              <a:t>Substitute    </a:t>
             </a:r>
             <a:r>
               <a:rPr sz="1200">
@@ -4809,7 +5272,7 @@
                 </a:solidFill>
                 <a:latin typeface="Consolas"/>
               </a:rPr>
-              <a:t>Relocating signed binary to abnormal boot phase </a:t>
+              <a:t>Relocating authentic signed binary (BlackLotus) </a:t>
             </a:r>
             <a:r>
               <a:rPr b="1" sz="1200">
@@ -4828,6 +5291,15 @@
                 <a:latin typeface="Consolas"/>
               </a:rPr>
               <a:t>DETECT (Sequence Anomaly)    </a:t>
+            </a:r>
+            <a:r>
+              <a:rPr b="1" sz="1200">
+                <a:solidFill>
+                  <a:srgbClr val="34D399"/>
+                </a:solidFill>
+                <a:latin typeface="Consolas"/>
+              </a:rPr>
+              <a:t>PRAHARI Advantage </a:t>
             </a:r>
           </a:p>
         </p:txBody>
@@ -4865,7 +5337,7 @@
             <a:avLst/>
           </a:prstGeom>
           <a:solidFill>
-            <a:srgbClr val="0B1120"/>
+            <a:srgbClr val="0A0F1D"/>
           </a:solidFill>
           <a:ln>
             <a:noFill/>
@@ -4895,14 +5367,57 @@
       </p:sp>
       <p:sp>
         <p:nvSpPr>
-          <p:cNvPr id="3" name="TextBox 2"/>
+          <p:cNvPr id="3" name="Rectangle 2"/>
+          <p:cNvSpPr/>
+          <p:nvPr/>
+        </p:nvSpPr>
+        <p:spPr>
+          <a:xfrm>
+            <a:off x="0" y="0"/>
+            <a:ext cx="12191695" cy="54864"/>
+          </a:xfrm>
+          <a:prstGeom prst="rect">
+            <a:avLst/>
+          </a:prstGeom>
+          <a:solidFill>
+            <a:srgbClr val="38BDF8"/>
+          </a:solidFill>
+          <a:ln>
+            <a:noFill/>
+          </a:ln>
+        </p:spPr>
+        <p:style>
+          <a:lnRef idx="1">
+            <a:schemeClr val="accent1"/>
+          </a:lnRef>
+          <a:fillRef idx="3">
+            <a:schemeClr val="accent1"/>
+          </a:fillRef>
+          <a:effectRef idx="2">
+            <a:schemeClr val="accent1"/>
+          </a:effectRef>
+          <a:fontRef idx="minor">
+            <a:schemeClr val="lt1"/>
+          </a:fontRef>
+        </p:style>
+        <p:txBody>
+          <a:bodyPr rtlCol="0" anchor="ctr"/>
+          <a:lstStyle/>
+          <a:p>
+            <a:pPr algn="ctr"/>
+          </a:p>
+        </p:txBody>
+      </p:sp>
+      <p:sp>
+        <p:nvSpPr>
+          <p:cNvPr id="4" name="TextBox 3"/>
           <p:cNvSpPr txBox="1"/>
           <p:nvPr/>
         </p:nvSpPr>
         <p:spPr>
           <a:xfrm>
             <a:off x="731520" y="365760"/>
-            <a:ext cx="10698480" cy="365760"/>
+            <a:ext cx="10698480" cy="320040"/>
           </a:xfrm>
           <a:prstGeom prst="rect">
             <a:avLst/>
@@ -4922,21 +5437,21 @@
                 </a:solidFill>
                 <a:latin typeface="Segoe UI"/>
               </a:rPr>
-              <a:t>SYSTEM ARCHITECTURE</a:t>
-            </a:r>
-          </a:p>
-        </p:txBody>
-      </p:sp>
-      <p:sp>
-        <p:nvSpPr>
-          <p:cNvPr id="4" name="TextBox 3"/>
+              <a:t>ARCHITECTURE</a:t>
+            </a:r>
+          </a:p>
+        </p:txBody>
+      </p:sp>
+      <p:sp>
+        <p:nvSpPr>
+          <p:cNvPr id="5" name="TextBox 4"/>
           <p:cNvSpPr txBox="1"/>
           <p:nvPr/>
         </p:nvSpPr>
         <p:spPr>
           <a:xfrm>
-            <a:off x="731520" y="685800"/>
-            <a:ext cx="10698480" cy="640080"/>
+            <a:off x="731520" y="640080"/>
+            <a:ext cx="10698480" cy="548640"/>
           </a:xfrm>
           <a:prstGeom prst="rect">
             <a:avLst/>
@@ -4950,20 +5465,76 @@
           <a:lstStyle/>
           <a:p>
             <a:r>
-              <a:rPr sz="2600" b="1">
+              <a:rPr sz="2400" b="1">
                 <a:solidFill>
                   <a:srgbClr val="F8FAFC"/>
                 </a:solidFill>
                 <a:latin typeface="Segoe UI"/>
               </a:rPr>
-              <a:t>End-to-End Pipeline: Kernel IMA -&gt; Tokenizer -&gt; N-Gram -&gt; PQC Signer</a:t>
-            </a:r>
+              <a:t>End-to-End System Pipeline</a:t>
+            </a:r>
+          </a:p>
+          <a:p>
+            <a:r>
+              <a:rPr sz="1200">
+                <a:solidFill>
+                  <a:srgbClr val="94A3B8"/>
+                </a:solidFill>
+                <a:latin typeface="Segoe UI"/>
+              </a:rPr>
+              <a:t>Securityfs Event Ingestion -&gt; Dual Tokenizer -&gt; N-Gram Detector -&gt; Hybrid Signer</a:t>
+            </a:r>
+          </a:p>
+        </p:txBody>
+      </p:sp>
+      <p:sp>
+        <p:nvSpPr>
+          <p:cNvPr id="6" name="Rounded Rectangle 5"/>
+          <p:cNvSpPr/>
+          <p:nvPr/>
+        </p:nvSpPr>
+        <p:spPr>
+          <a:xfrm>
+            <a:off x="731520" y="1463040"/>
+            <a:ext cx="10698480" cy="4937760"/>
+          </a:xfrm>
+          <a:prstGeom prst="roundRect">
+            <a:avLst/>
+          </a:prstGeom>
+          <a:solidFill>
+            <a:srgbClr val="131B2C"/>
+          </a:solidFill>
+          <a:ln w="12700">
+            <a:solidFill>
+              <a:srgbClr val="06B6D4"/>
+            </a:solidFill>
+          </a:ln>
+        </p:spPr>
+        <p:style>
+          <a:lnRef idx="1">
+            <a:schemeClr val="accent1"/>
+          </a:lnRef>
+          <a:fillRef idx="3">
+            <a:schemeClr val="accent1"/>
+          </a:fillRef>
+          <a:effectRef idx="2">
+            <a:schemeClr val="accent1"/>
+          </a:effectRef>
+          <a:fontRef idx="minor">
+            <a:schemeClr val="lt1"/>
+          </a:fontRef>
+        </p:style>
+        <p:txBody>
+          <a:bodyPr rtlCol="0" anchor="ctr"/>
+          <a:lstStyle/>
+          <a:p>
+            <a:pPr algn="ctr"/>
           </a:p>
         </p:txBody>
       </p:sp>
       <p:pic>
         <p:nvPicPr>
-          <p:cNvPr id="5" name="Picture 4" descr="p_arch_slide.jpg"/>
+          <p:cNvPr id="7" name="Picture 6" descr="p_arch_hi.jpg"/>
           <p:cNvPicPr>
             <a:picLocks noChangeAspect="1"/>
           </p:cNvPicPr>
@@ -4977,8 +5548,8 @@
         </p:blipFill>
         <p:spPr>
           <a:xfrm>
-            <a:off x="731520" y="1645920"/>
-            <a:ext cx="10698480" cy="5359938"/>
+            <a:off x="914400" y="1645920"/>
+            <a:ext cx="10332720" cy="5175927"/>
           </a:xfrm>
           <a:prstGeom prst="rect">
             <a:avLst/>
@@ -5018,7 +5589,7 @@
             <a:avLst/>
           </a:prstGeom>
           <a:solidFill>
-            <a:srgbClr val="0B1120"/>
+            <a:srgbClr val="0A0F1D"/>
           </a:solidFill>
           <a:ln>
             <a:noFill/>
@@ -5048,14 +5619,57 @@
       </p:sp>
       <p:sp>
         <p:nvSpPr>
-          <p:cNvPr id="3" name="TextBox 2"/>
+          <p:cNvPr id="3" name="Rectangle 2"/>
+          <p:cNvSpPr/>
+          <p:nvPr/>
+        </p:nvSpPr>
+        <p:spPr>
+          <a:xfrm>
+            <a:off x="0" y="0"/>
+            <a:ext cx="12191695" cy="54864"/>
+          </a:xfrm>
+          <a:prstGeom prst="rect">
+            <a:avLst/>
+          </a:prstGeom>
+          <a:solidFill>
+            <a:srgbClr val="38BDF8"/>
+          </a:solidFill>
+          <a:ln>
+            <a:noFill/>
+          </a:ln>
+        </p:spPr>
+        <p:style>
+          <a:lnRef idx="1">
+            <a:schemeClr val="accent1"/>
+          </a:lnRef>
+          <a:fillRef idx="3">
+            <a:schemeClr val="accent1"/>
+          </a:fillRef>
+          <a:effectRef idx="2">
+            <a:schemeClr val="accent1"/>
+          </a:effectRef>
+          <a:fontRef idx="minor">
+            <a:schemeClr val="lt1"/>
+          </a:fontRef>
+        </p:style>
+        <p:txBody>
+          <a:bodyPr rtlCol="0" anchor="ctr"/>
+          <a:lstStyle/>
+          <a:p>
+            <a:pPr algn="ctr"/>
+          </a:p>
+        </p:txBody>
+      </p:sp>
+      <p:sp>
+        <p:nvSpPr>
+          <p:cNvPr id="4" name="TextBox 3"/>
           <p:cNvSpPr txBox="1"/>
           <p:nvPr/>
         </p:nvSpPr>
         <p:spPr>
           <a:xfrm>
             <a:off x="731520" y="365760"/>
-            <a:ext cx="10698480" cy="365760"/>
+            <a:ext cx="10698480" cy="320040"/>
           </a:xfrm>
           <a:prstGeom prst="rect">
             <a:avLst/>
@@ -5075,21 +5689,21 @@
                 </a:solidFill>
                 <a:latin typeface="Segoe UI"/>
               </a:rPr>
-              <a:t>INTERACTIVE TERMINAL UI</a:t>
-            </a:r>
-          </a:p>
-        </p:txBody>
-      </p:sp>
-      <p:sp>
-        <p:nvSpPr>
-          <p:cNvPr id="4" name="TextBox 3"/>
+              <a:t>INTERFACE</a:t>
+            </a:r>
+          </a:p>
+        </p:txBody>
+      </p:sp>
+      <p:sp>
+        <p:nvSpPr>
+          <p:cNvPr id="5" name="TextBox 4"/>
           <p:cNvSpPr txBox="1"/>
           <p:nvPr/>
         </p:nvSpPr>
         <p:spPr>
           <a:xfrm>
-            <a:off x="731520" y="685800"/>
-            <a:ext cx="10698480" cy="640080"/>
+            <a:off x="731520" y="640080"/>
+            <a:ext cx="10698480" cy="548640"/>
           </a:xfrm>
           <a:prstGeom prst="rect">
             <a:avLst/>
@@ -5103,20 +5717,76 @@
           <a:lstStyle/>
           <a:p>
             <a:r>
-              <a:rPr sz="2600" b="1">
+              <a:rPr sz="2400" b="1">
                 <a:solidFill>
                   <a:srgbClr val="F8FAFC"/>
                 </a:solidFill>
                 <a:latin typeface="Segoe UI"/>
               </a:rPr>
-              <a:t>Live Operator Interface Built on Textual (SSH &amp; Server Ready)</a:t>
-            </a:r>
+              <a:t>Live Operator Terminal UI &amp; HTML Security Portal</a:t>
+            </a:r>
+          </a:p>
+          <a:p>
+            <a:r>
+              <a:rPr sz="1200">
+                <a:solidFill>
+                  <a:srgbClr val="94A3B8"/>
+                </a:solidFill>
+                <a:latin typeface="Segoe UI"/>
+              </a:rPr>
+              <a:t>Built with Textual — optimized for SSH server administration with dynamic attack simulation hotkeys.</a:t>
+            </a:r>
+          </a:p>
+        </p:txBody>
+      </p:sp>
+      <p:sp>
+        <p:nvSpPr>
+          <p:cNvPr id="6" name="Rounded Rectangle 5"/>
+          <p:cNvSpPr/>
+          <p:nvPr/>
+        </p:nvSpPr>
+        <p:spPr>
+          <a:xfrm>
+            <a:off x="731520" y="1463040"/>
+            <a:ext cx="10698480" cy="4937760"/>
+          </a:xfrm>
+          <a:prstGeom prst="roundRect">
+            <a:avLst/>
+          </a:prstGeom>
+          <a:solidFill>
+            <a:srgbClr val="131B2C"/>
+          </a:solidFill>
+          <a:ln w="12700">
+            <a:solidFill>
+              <a:srgbClr val="10B981"/>
+            </a:solidFill>
+          </a:ln>
+        </p:spPr>
+        <p:style>
+          <a:lnRef idx="1">
+            <a:schemeClr val="accent1"/>
+          </a:lnRef>
+          <a:fillRef idx="3">
+            <a:schemeClr val="accent1"/>
+          </a:fillRef>
+          <a:effectRef idx="2">
+            <a:schemeClr val="accent1"/>
+          </a:effectRef>
+          <a:fontRef idx="minor">
+            <a:schemeClr val="lt1"/>
+          </a:fontRef>
+        </p:style>
+        <p:txBody>
+          <a:bodyPr rtlCol="0" anchor="ctr"/>
+          <a:lstStyle/>
+          <a:p>
+            <a:pPr algn="ctr"/>
           </a:p>
         </p:txBody>
       </p:sp>
       <p:pic>
         <p:nvPicPr>
-          <p:cNvPr id="5" name="Picture 4" descr="p_tui_slide.jpg"/>
+          <p:cNvPr id="7" name="Picture 6" descr="p_tui_hi.jpg"/>
           <p:cNvPicPr>
             <a:picLocks noChangeAspect="1"/>
           </p:cNvPicPr>
@@ -5130,8 +5800,8 @@
         </p:blipFill>
         <p:spPr>
           <a:xfrm>
-            <a:off x="1371600" y="1645920"/>
-            <a:ext cx="9418320" cy="6515940"/>
+            <a:off x="1280160" y="1600200"/>
+            <a:ext cx="9601200" cy="6636124"/>
           </a:xfrm>
           <a:prstGeom prst="rect">
             <a:avLst/>
@@ -5171,7 +5841,7 @@
             <a:avLst/>
           </a:prstGeom>
           <a:solidFill>
-            <a:srgbClr val="0B1120"/>
+            <a:srgbClr val="0A0F1D"/>
           </a:solidFill>
           <a:ln>
             <a:noFill/>
@@ -5201,93 +5871,23 @@
       </p:sp>
       <p:sp>
         <p:nvSpPr>
-          <p:cNvPr id="3" name="TextBox 2"/>
-          <p:cNvSpPr txBox="1"/>
+          <p:cNvPr id="3" name="Rectangle 2"/>
+          <p:cNvSpPr/>
           <p:nvPr/>
         </p:nvSpPr>
         <p:spPr>
           <a:xfrm>
-            <a:off x="731520" y="365760"/>
-            <a:ext cx="10698480" cy="365760"/>
+            <a:off x="0" y="0"/>
+            <a:ext cx="12191695" cy="54864"/>
           </a:xfrm>
           <a:prstGeom prst="rect">
             <a:avLst/>
           </a:prstGeom>
-          <a:noFill/>
-        </p:spPr>
-        <p:txBody>
-          <a:bodyPr wrap="square">
-            <a:spAutoFit/>
-          </a:bodyPr>
-          <a:lstStyle/>
-          <a:p>
-            <a:r>
-              <a:rPr sz="1100" b="1">
-                <a:solidFill>
-                  <a:srgbClr val="38BDF8"/>
-                </a:solidFill>
-                <a:latin typeface="Segoe UI"/>
-              </a:rPr>
-              <a:t>OPEN SOURCE TECH STACK &amp; COMPLIANCE</a:t>
-            </a:r>
-          </a:p>
-        </p:txBody>
-      </p:sp>
-      <p:sp>
-        <p:nvSpPr>
-          <p:cNvPr id="4" name="TextBox 3"/>
-          <p:cNvSpPr txBox="1"/>
-          <p:nvPr/>
-        </p:nvSpPr>
-        <p:spPr>
-          <a:xfrm>
-            <a:off x="731520" y="685800"/>
-            <a:ext cx="10698480" cy="640080"/>
-          </a:xfrm>
-          <a:prstGeom prst="rect">
-            <a:avLst/>
-          </a:prstGeom>
-          <a:noFill/>
-        </p:spPr>
-        <p:txBody>
-          <a:bodyPr wrap="square">
-            <a:spAutoFit/>
-          </a:bodyPr>
-          <a:lstStyle/>
-          <a:p>
-            <a:r>
-              <a:rPr sz="2600" b="1">
-                <a:solidFill>
-                  <a:srgbClr val="F8FAFC"/>
-                </a:solidFill>
-                <a:latin typeface="Segoe UI"/>
-              </a:rPr>
-              <a:t>Standards-Compliant, DPDP Act 2023 Aligned, Indigenous Ready</a:t>
-            </a:r>
-          </a:p>
-        </p:txBody>
-      </p:sp>
-      <p:sp>
-        <p:nvSpPr>
-          <p:cNvPr id="5" name="Rounded Rectangle 4"/>
-          <p:cNvSpPr/>
-          <p:nvPr/>
-        </p:nvSpPr>
-        <p:spPr>
-          <a:xfrm>
-            <a:off x="731520" y="1645920"/>
-            <a:ext cx="5120640" cy="4572000"/>
-          </a:xfrm>
-          <a:prstGeom prst="roundRect">
-            <a:avLst/>
-          </a:prstGeom>
           <a:solidFill>
-            <a:srgbClr val="161E2E"/>
+            <a:srgbClr val="38BDF8"/>
           </a:solidFill>
-          <a:ln w="12700">
-            <a:solidFill>
-              <a:srgbClr val="2D3B55"/>
-            </a:solidFill>
+          <a:ln>
+            <a:noFill/>
           </a:ln>
         </p:spPr>
         <p:style>
@@ -5314,14 +5914,14 @@
       </p:sp>
       <p:sp>
         <p:nvSpPr>
-          <p:cNvPr id="6" name="TextBox 5"/>
+          <p:cNvPr id="4" name="TextBox 3"/>
           <p:cNvSpPr txBox="1"/>
           <p:nvPr/>
         </p:nvSpPr>
         <p:spPr>
           <a:xfrm>
-            <a:off x="914400" y="1783080"/>
-            <a:ext cx="4754879" cy="4297680"/>
+            <a:off x="731520" y="365760"/>
+            <a:ext cx="10698480" cy="320040"/>
           </a:xfrm>
           <a:prstGeom prst="rect">
             <a:avLst/>
@@ -5334,19 +5934,152 @@
           </a:bodyPr>
           <a:lstStyle/>
           <a:p>
+            <a:r>
+              <a:rPr sz="1100" b="1">
+                <a:solidFill>
+                  <a:srgbClr val="38BDF8"/>
+                </a:solidFill>
+                <a:latin typeface="Segoe UI"/>
+              </a:rPr>
+              <a:t>ENGINEERING &amp; SOVEREIGNTY</a:t>
+            </a:r>
+          </a:p>
+        </p:txBody>
+      </p:sp>
+      <p:sp>
+        <p:nvSpPr>
+          <p:cNvPr id="5" name="TextBox 4"/>
+          <p:cNvSpPr txBox="1"/>
+          <p:nvPr/>
+        </p:nvSpPr>
+        <p:spPr>
+          <a:xfrm>
+            <a:off x="731520" y="640080"/>
+            <a:ext cx="10698480" cy="548640"/>
+          </a:xfrm>
+          <a:prstGeom prst="rect">
+            <a:avLst/>
+          </a:prstGeom>
+          <a:noFill/>
+        </p:spPr>
+        <p:txBody>
+          <a:bodyPr wrap="square">
+            <a:spAutoFit/>
+          </a:bodyPr>
+          <a:lstStyle/>
+          <a:p>
+            <a:r>
+              <a:rPr sz="2400" b="1">
+                <a:solidFill>
+                  <a:srgbClr val="F8FAFC"/>
+                </a:solidFill>
+                <a:latin typeface="Segoe UI"/>
+              </a:rPr>
+              <a:t>Open Source Stack, DPDP Act 2023 &amp; Indigenous Security</a:t>
+            </a:r>
+          </a:p>
+          <a:p>
+            <a:r>
+              <a:rPr sz="1200">
+                <a:solidFill>
+                  <a:srgbClr val="94A3B8"/>
+                </a:solidFill>
+                <a:latin typeface="Segoe UI"/>
+              </a:rPr>
+              <a:t>Standards-compliant, sovereign security infrastructure for Atmanirbhar Bharat.</a:t>
+            </a:r>
+          </a:p>
+        </p:txBody>
+      </p:sp>
+      <p:sp>
+        <p:nvSpPr>
+          <p:cNvPr id="6" name="Rounded Rectangle 5"/>
+          <p:cNvSpPr/>
+          <p:nvPr/>
+        </p:nvSpPr>
+        <p:spPr>
+          <a:xfrm>
+            <a:off x="731520" y="1554480"/>
+            <a:ext cx="5120640" cy="4846320"/>
+          </a:xfrm>
+          <a:prstGeom prst="roundRect">
+            <a:avLst/>
+          </a:prstGeom>
+          <a:solidFill>
+            <a:srgbClr val="131B2C"/>
+          </a:solidFill>
+          <a:ln w="12700">
+            <a:solidFill>
+              <a:srgbClr val="26334D"/>
+            </a:solidFill>
+          </a:ln>
+        </p:spPr>
+        <p:style>
+          <a:lnRef idx="1">
+            <a:schemeClr val="accent1"/>
+          </a:lnRef>
+          <a:fillRef idx="3">
+            <a:schemeClr val="accent1"/>
+          </a:fillRef>
+          <a:effectRef idx="2">
+            <a:schemeClr val="accent1"/>
+          </a:effectRef>
+          <a:fontRef idx="minor">
+            <a:schemeClr val="lt1"/>
+          </a:fontRef>
+        </p:style>
+        <p:txBody>
+          <a:bodyPr rtlCol="0" anchor="ctr"/>
+          <a:lstStyle/>
+          <a:p>
+            <a:pPr algn="ctr"/>
+          </a:p>
+        </p:txBody>
+      </p:sp>
+      <p:sp>
+        <p:nvSpPr>
+          <p:cNvPr id="7" name="TextBox 6"/>
+          <p:cNvSpPr txBox="1"/>
+          <p:nvPr/>
+        </p:nvSpPr>
+        <p:spPr>
+          <a:xfrm>
+            <a:off x="932688" y="1719072"/>
+            <a:ext cx="4718303" cy="4517136"/>
+          </a:xfrm>
+          <a:prstGeom prst="rect">
+            <a:avLst/>
+          </a:prstGeom>
+          <a:noFill/>
+        </p:spPr>
+        <p:txBody>
+          <a:bodyPr wrap="square">
+            <a:spAutoFit/>
+          </a:bodyPr>
+          <a:lstStyle/>
+          <a:p>
             <a:pPr>
               <a:spcAft>
-                <a:spcPts val="800"/>
+                <a:spcPts val="1000"/>
               </a:spcAft>
             </a:pPr>
             <a:r>
-              <a:rPr sz="1700" b="1">
+              <a:rPr sz="1100" b="1">
                 <a:solidFill>
                   <a:srgbClr val="38BDF8"/>
                 </a:solidFill>
                 <a:latin typeface="Segoe UI"/>
               </a:rPr>
-              <a:t>Tech Stack &amp; Dependencies</a:t>
+              <a:t>[OPEN SOURCE TECH STACK] </a:t>
+            </a:r>
+            <a:r>
+              <a:rPr sz="1600" b="1">
+                <a:solidFill>
+                  <a:srgbClr val="F8FAFC"/>
+                </a:solidFill>
+                <a:latin typeface="Segoe UI"/>
+              </a:rPr>
+              <a:t>Modular, Inspectable, Tested</a:t>
             </a:r>
           </a:p>
           <a:p>
@@ -5356,22 +6089,22 @@
               </a:spcAft>
             </a:pPr>
             <a:r>
-              <a:rPr sz="1300" b="1">
+              <a:rPr sz="1250" b="1">
                 <a:solidFill>
                   <a:srgbClr val="38BDF8"/>
                 </a:solidFill>
                 <a:latin typeface="Segoe UI"/>
               </a:rPr>
-              <a:t>Core Language: </a:t>
-            </a:r>
-            <a:r>
-              <a:rPr sz="1300">
+              <a:t>Language &amp; Package: </a:t>
+            </a:r>
+            <a:r>
+              <a:rPr sz="1250">
                 <a:solidFill>
                   <a:srgbClr val="F8FAFC"/>
                 </a:solidFill>
                 <a:latin typeface="Segoe UI"/>
               </a:rPr>
-              <a:t>Python 3.9+ (Clean, modular, pip-installable package)</a:t>
+              <a:t>Python 3.9+ pip-installable library with zero exotic binary blobs.</a:t>
             </a:r>
           </a:p>
           <a:p>
@@ -5381,22 +6114,22 @@
               </a:spcAft>
             </a:pPr>
             <a:r>
-              <a:rPr sz="1300" b="1">
-                <a:solidFill>
-                  <a:srgbClr val="34D399"/>
-                </a:solidFill>
-                <a:latin typeface="Segoe UI"/>
-              </a:rPr>
-              <a:t>Cryptography: </a:t>
-            </a:r>
-            <a:r>
-              <a:rPr sz="1300">
+              <a:rPr sz="1250" b="1">
+                <a:solidFill>
+                  <a:srgbClr val="C084FC"/>
+                </a:solidFill>
+                <a:latin typeface="Segoe UI"/>
+              </a:rPr>
+              <a:t>Post-Quantum Cryptography: </a:t>
+            </a:r>
+            <a:r>
+              <a:rPr sz="1250">
                 <a:solidFill>
                   <a:srgbClr val="F8FAFC"/>
                 </a:solidFill>
                 <a:latin typeface="Segoe UI"/>
               </a:rPr>
-              <a:t>OpenSSL 3.5 (Apache-2.0) native ML-DSA-65 &amp; ECDSA P-256</a:t>
+              <a:t>OpenSSL 3.5 (Apache-2.0) native ML-DSA-65 &amp; ECDSA P-256.</a:t>
             </a:r>
           </a:p>
           <a:p>
@@ -5406,22 +6139,22 @@
               </a:spcAft>
             </a:pPr>
             <a:r>
-              <a:rPr sz="1300" b="1">
+              <a:rPr sz="1250" b="1">
                 <a:solidFill>
                   <a:srgbClr val="F8FAFC"/>
                 </a:solidFill>
                 <a:latin typeface="Segoe UI"/>
               </a:rPr>
-              <a:t>TUI Interface: </a:t>
-            </a:r>
-            <a:r>
-              <a:rPr sz="1300">
+              <a:t>Operator Interface: </a:t>
+            </a:r>
+            <a:r>
+              <a:rPr sz="1250">
                 <a:solidFill>
                   <a:srgbClr val="F8FAFC"/>
                 </a:solidFill>
                 <a:latin typeface="Segoe UI"/>
               </a:rPr>
-              <a:t>Textual (MIT) — live simulation keys [c]lean, [t]amper, [r]eorder, [s]ubstitute</a:t>
+              <a:t>Textual (MIT) TUI with real-time live simulation hotkeys [c],[t],[i],[r],[s].</a:t>
             </a:r>
           </a:p>
           <a:p>
@@ -5431,22 +6164,22 @@
               </a:spcAft>
             </a:pPr>
             <a:r>
-              <a:rPr sz="1300" b="1">
+              <a:rPr sz="1250" b="1">
                 <a:solidFill>
                   <a:srgbClr val="94A3B8"/>
                 </a:solidFill>
                 <a:latin typeface="Segoe UI"/>
               </a:rPr>
-              <a:t>Visualisation: </a:t>
-            </a:r>
-            <a:r>
-              <a:rPr sz="1300">
+              <a:t>HTML Dashboard: </a:t>
+            </a:r>
+            <a:r>
+              <a:rPr sz="1250">
                 <a:solidFill>
                   <a:srgbClr val="F8FAFC"/>
                 </a:solidFill>
                 <a:latin typeface="Segoe UI"/>
               </a:rPr>
-              <a:t>Plotly (MIT) interactive sequence swimlane dashboard (boot.html)</a:t>
+              <a:t>Plotly (MIT) interactive sequence timeline (boot.html).</a:t>
             </a:r>
           </a:p>
           <a:p>
@@ -5456,46 +6189,71 @@
               </a:spcAft>
             </a:pPr>
             <a:r>
-              <a:rPr sz="1300" b="1">
+              <a:rPr sz="1250" b="1">
                 <a:solidFill>
                   <a:srgbClr val="34D399"/>
                 </a:solidFill>
                 <a:latin typeface="Segoe UI"/>
               </a:rPr>
+              <a:t>Automated Tests: </a:t>
+            </a:r>
+            <a:r>
+              <a:rPr sz="1250">
+                <a:solidFill>
+                  <a:srgbClr val="F8FAFC"/>
+                </a:solidFill>
+                <a:latin typeface="Segoe UI"/>
+              </a:rPr>
+              <a:t>100% test coverage with GitHub Actions CI workflow.</a:t>
+            </a:r>
+          </a:p>
+          <a:p>
+            <a:pPr>
+              <a:spcAft>
+                <a:spcPts val="600"/>
+              </a:spcAft>
+            </a:pPr>
+            <a:r>
+              <a:rPr sz="1250" b="1">
+                <a:solidFill>
+                  <a:srgbClr val="34D399"/>
+                </a:solidFill>
+                <a:latin typeface="Segoe UI"/>
+              </a:rPr>
               <a:t>Licensing: </a:t>
             </a:r>
             <a:r>
-              <a:rPr sz="1300">
+              <a:rPr sz="1250">
                 <a:solidFill>
                   <a:srgbClr val="F8FAFC"/>
                 </a:solidFill>
                 <a:latin typeface="Segoe UI"/>
               </a:rPr>
-              <a:t>100% Open Source under MIT License</a:t>
-            </a:r>
-          </a:p>
-        </p:txBody>
-      </p:sp>
-      <p:sp>
-        <p:nvSpPr>
-          <p:cNvPr id="7" name="Rounded Rectangle 6"/>
+              <a:t>100% Open Source under the MIT License.</a:t>
+            </a:r>
+          </a:p>
+        </p:txBody>
+      </p:sp>
+      <p:sp>
+        <p:nvSpPr>
+          <p:cNvPr id="8" name="Rounded Rectangle 7"/>
           <p:cNvSpPr/>
           <p:nvPr/>
         </p:nvSpPr>
         <p:spPr>
           <a:xfrm>
-            <a:off x="6217920" y="1645920"/>
-            <a:ext cx="5120640" cy="4572000"/>
+            <a:off x="6217920" y="1554480"/>
+            <a:ext cx="5120640" cy="4846320"/>
           </a:xfrm>
           <a:prstGeom prst="roundRect">
             <a:avLst/>
           </a:prstGeom>
           <a:solidFill>
-            <a:srgbClr val="161E2E"/>
+            <a:srgbClr val="131B2C"/>
           </a:solidFill>
           <a:ln w="12700">
             <a:solidFill>
-              <a:srgbClr val="2D3B55"/>
+              <a:srgbClr val="10B981"/>
             </a:solidFill>
           </a:ln>
         </p:spPr>
@@ -5523,14 +6281,14 @@
       </p:sp>
       <p:sp>
         <p:nvSpPr>
-          <p:cNvPr id="8" name="TextBox 7"/>
+          <p:cNvPr id="9" name="TextBox 8"/>
           <p:cNvSpPr txBox="1"/>
           <p:nvPr/>
         </p:nvSpPr>
         <p:spPr>
           <a:xfrm>
-            <a:off x="6400800" y="1783080"/>
-            <a:ext cx="4754879" cy="4297680"/>
+            <a:off x="6419088" y="1719072"/>
+            <a:ext cx="4718303" cy="4517136"/>
           </a:xfrm>
           <a:prstGeom prst="rect">
             <a:avLst/>
@@ -5545,17 +6303,26 @@
           <a:p>
             <a:pPr>
               <a:spcAft>
-                <a:spcPts val="800"/>
+                <a:spcPts val="1000"/>
               </a:spcAft>
             </a:pPr>
             <a:r>
-              <a:rPr sz="1700" b="1">
+              <a:rPr sz="1100" b="1">
                 <a:solidFill>
                   <a:srgbClr val="34D399"/>
                 </a:solidFill>
                 <a:latin typeface="Segoe UI"/>
               </a:rPr>
-              <a:t>Security &amp; Compliance Standards</a:t>
+              <a:t>[COMPLIANCE &amp; IMPACT] </a:t>
+            </a:r>
+            <a:r>
+              <a:rPr sz="1600" b="1">
+                <a:solidFill>
+                  <a:srgbClr val="F8FAFC"/>
+                </a:solidFill>
+                <a:latin typeface="Segoe UI"/>
+              </a:rPr>
+              <a:t>DPDP Act 2023 &amp; Self-Reliance</a:t>
             </a:r>
           </a:p>
           <a:p>
@@ -5565,22 +6332,22 @@
               </a:spcAft>
             </a:pPr>
             <a:r>
-              <a:rPr sz="1300" b="1">
+              <a:rPr sz="1250" b="1">
                 <a:solidFill>
                   <a:srgbClr val="34D399"/>
                 </a:solidFill>
                 <a:latin typeface="Segoe UI"/>
               </a:rPr>
-              <a:t>DPDP Act 2023: </a:t>
-            </a:r>
-            <a:r>
-              <a:rPr sz="1300">
+              <a:t>DPDP Act 2023 Compliance: </a:t>
+            </a:r>
+            <a:r>
+              <a:rPr sz="1250">
                 <a:solidFill>
                   <a:srgbClr val="F8FAFC"/>
                 </a:solidFill>
                 <a:latin typeface="Segoe UI"/>
               </a:rPr>
-              <a:t>Zero personal data collected or transmitted. Logs strictly contain kernel hashes and system paths.</a:t>
+              <a:t>Zero personal data collected or stored. Telemetry is restricted strictly to local file paths and cryptographic hashes.</a:t>
             </a:r>
           </a:p>
           <a:p>
@@ -5590,22 +6357,22 @@
               </a:spcAft>
             </a:pPr>
             <a:r>
-              <a:rPr sz="1300" b="1">
-                <a:solidFill>
-                  <a:srgbClr val="A855F7"/>
-                </a:solidFill>
-                <a:latin typeface="Segoe UI"/>
-              </a:rPr>
-              <a:t>RFC 9019: </a:t>
-            </a:r>
-            <a:r>
-              <a:rPr sz="1300">
+              <a:rPr sz="1250" b="1">
+                <a:solidFill>
+                  <a:srgbClr val="C084FC"/>
+                </a:solidFill>
+                <a:latin typeface="Segoe UI"/>
+              </a:rPr>
+              <a:t>RFC 9019 Compliance: </a:t>
+            </a:r>
+            <a:r>
+              <a:rPr sz="1250">
                 <a:solidFill>
                   <a:srgbClr val="F8FAFC"/>
                 </a:solidFill>
                 <a:latin typeface="Segoe UI"/>
               </a:rPr>
-              <a:t>Dual classical + post-quantum hybrid attestation manifest pattern.</a:t>
+              <a:t>Complies with Internet Engineering Task Force hybrid post-quantum attestation standards.</a:t>
             </a:r>
           </a:p>
           <a:p>
@@ -5615,22 +6382,22 @@
               </a:spcAft>
             </a:pPr>
             <a:r>
-              <a:rPr sz="1300" b="1">
-                <a:solidFill>
-                  <a:srgbClr val="A855F7"/>
-                </a:solidFill>
-                <a:latin typeface="Segoe UI"/>
-              </a:rPr>
-              <a:t>NSA CNSA 2.0: </a:t>
-            </a:r>
-            <a:r>
-              <a:rPr sz="1300">
+              <a:rPr sz="1250" b="1">
+                <a:solidFill>
+                  <a:srgbClr val="C084FC"/>
+                </a:solidFill>
+                <a:latin typeface="Segoe UI"/>
+              </a:rPr>
+              <a:t>NSA CNSA 2.0 Alignment: </a:t>
+            </a:r>
+            <a:r>
+              <a:rPr sz="1250">
                 <a:solidFill>
                   <a:srgbClr val="F8FAFC"/>
                 </a:solidFill>
                 <a:latin typeface="Segoe UI"/>
               </a:rPr>
-              <a:t>Directly implements firmware/boot integrity quantum transition priority.</a:t>
+              <a:t>Satisfies highest-priority firmware signature transition guidelines.</a:t>
             </a:r>
           </a:p>
           <a:p>
@@ -5640,22 +6407,22 @@
               </a:spcAft>
             </a:pPr>
             <a:r>
-              <a:rPr sz="1300" b="1">
+              <a:rPr sz="1250" b="1">
                 <a:solidFill>
                   <a:srgbClr val="34D399"/>
                 </a:solidFill>
                 <a:latin typeface="Segoe UI"/>
               </a:rPr>
-              <a:t>Atmanirbhar Bharat: </a:t>
-            </a:r>
-            <a:r>
-              <a:rPr sz="1300">
+              <a:t>National Self-Reliance: </a:t>
+            </a:r>
+            <a:r>
+              <a:rPr sz="1250">
                 <a:solidFill>
                   <a:srgbClr val="F8FAFC"/>
                 </a:solidFill>
                 <a:latin typeface="Segoe UI"/>
               </a:rPr>
-              <a:t>Self-reliant security stack requiring zero proprietary foreign telemetry.</a:t>
+              <a:t>Eliminates reliance on proprietary foreign attestation frameworks; runs on existing Linux servers immediately.</a:t>
             </a:r>
           </a:p>
         </p:txBody>

</xml_diff>

<commit_message>
Finalize ultimate presentation decks with hero KPI cards and perfected visual hierarchy
</commit_message>
<xml_diff>
--- a/docs/PRAHARI.pptx
+++ b/docs/PRAHARI.pptx
@@ -3152,7 +3152,7 @@
             <a:avLst/>
           </a:prstGeom>
           <a:solidFill>
-            <a:srgbClr val="38BDF8"/>
+            <a:srgbClr val="34D399"/>
           </a:solidFill>
           <a:ln>
             <a:noFill/>
@@ -3188,7 +3188,7 @@
         </p:nvSpPr>
         <p:spPr>
           <a:xfrm>
-            <a:off x="914400" y="1371600"/>
+            <a:off x="914400" y="1097280"/>
             <a:ext cx="10332720" cy="365760"/>
           </a:xfrm>
           <a:prstGeom prst="rect">
@@ -3209,7 +3209,7 @@
                 </a:solidFill>
                 <a:latin typeface="Segoe UI"/>
               </a:rPr>
-              <a:t>C-DAC / MEITY AI ENABLED OS HACKATHON 2026  •  TRACK 2 (OS &amp; KERNEL LEVEL)</a:t>
+              <a:t>C-DAC / MEITY AI ENABLED OS HACKATHON 2026  •  TRACK 2: AI AT OS &amp; KERNEL LEVEL</a:t>
             </a:r>
           </a:p>
         </p:txBody>
@@ -3222,7 +3222,7 @@
         </p:nvSpPr>
         <p:spPr>
           <a:xfrm>
-            <a:off x="914400" y="1828800"/>
+            <a:off x="914400" y="1554480"/>
             <a:ext cx="10332720" cy="1280160"/>
           </a:xfrm>
           <a:prstGeom prst="rect">
@@ -3248,7 +3248,7 @@
           </a:p>
           <a:p>
             <a:r>
-              <a:rPr sz="2200" b="1">
+              <a:rPr sz="2100" b="1">
                 <a:solidFill>
                   <a:srgbClr val="34D399"/>
                 </a:solidFill>
@@ -3261,14 +3261,59 @@
       </p:sp>
       <p:sp>
         <p:nvSpPr>
-          <p:cNvPr id="6" name="TextBox 5"/>
+          <p:cNvPr id="6" name="Rounded Rectangle 5"/>
+          <p:cNvSpPr/>
+          <p:nvPr/>
+        </p:nvSpPr>
+        <p:spPr>
+          <a:xfrm>
+            <a:off x="914400" y="3200400"/>
+            <a:ext cx="3291840" cy="1188720"/>
+          </a:xfrm>
+          <a:prstGeom prst="roundRect">
+            <a:avLst/>
+          </a:prstGeom>
+          <a:solidFill>
+            <a:srgbClr val="131B2C"/>
+          </a:solidFill>
+          <a:ln w="12700">
+            <a:solidFill>
+              <a:srgbClr val="34D399"/>
+            </a:solidFill>
+          </a:ln>
+        </p:spPr>
+        <p:style>
+          <a:lnRef idx="1">
+            <a:schemeClr val="accent1"/>
+          </a:lnRef>
+          <a:fillRef idx="3">
+            <a:schemeClr val="accent1"/>
+          </a:fillRef>
+          <a:effectRef idx="2">
+            <a:schemeClr val="accent1"/>
+          </a:effectRef>
+          <a:fontRef idx="minor">
+            <a:schemeClr val="lt1"/>
+          </a:fontRef>
+        </p:style>
+        <p:txBody>
+          <a:bodyPr rtlCol="0" anchor="ctr"/>
+          <a:lstStyle/>
+          <a:p>
+            <a:pPr algn="ctr"/>
+          </a:p>
+        </p:txBody>
+      </p:sp>
+      <p:sp>
+        <p:nvSpPr>
+          <p:cNvPr id="7" name="TextBox 6"/>
           <p:cNvSpPr txBox="1"/>
           <p:nvPr/>
         </p:nvSpPr>
         <p:spPr>
           <a:xfrm>
-            <a:off x="914400" y="3657600"/>
-            <a:ext cx="10332720" cy="914400"/>
+            <a:off x="1051560" y="3291840"/>
+            <a:ext cx="3017520" cy="1005840"/>
           </a:xfrm>
           <a:prstGeom prst="rect">
             <a:avLst/>
@@ -3276,33 +3321,257 @@
           <a:noFill/>
         </p:spPr>
         <p:txBody>
-          <a:bodyPr wrap="none">
+          <a:bodyPr wrap="square">
             <a:spAutoFit/>
           </a:bodyPr>
           <a:lstStyle/>
           <a:p>
             <a:r>
-              <a:rPr sz="1600">
+              <a:rPr sz="2600" b="1">
+                <a:solidFill>
+                  <a:srgbClr val="34D399"/>
+                </a:solidFill>
+                <a:latin typeface="Segoe UI"/>
+              </a:rPr>
+              <a:t>4 / 4 Caught</a:t>
+            </a:r>
+          </a:p>
+          <a:p>
+            <a:r>
+              <a:rPr sz="1200" b="1">
+                <a:solidFill>
+                  <a:srgbClr val="F8FAFC"/>
+                </a:solidFill>
+                <a:latin typeface="Segoe UI"/>
+              </a:rPr>
+              <a:t>Attack Vectors Detected</a:t>
+            </a:r>
+          </a:p>
+          <a:p>
+            <a:r>
+              <a:rPr sz="1050">
                 <a:solidFill>
                   <a:srgbClr val="94A3B8"/>
                 </a:solidFill>
                 <a:latin typeface="Segoe UI"/>
               </a:rPr>
-              <a:t>Catches compromised boots when every signature is valid and every hash matches.</a:t>
-            </a:r>
-          </a:p>
-        </p:txBody>
-      </p:sp>
-      <p:sp>
-        <p:nvSpPr>
-          <p:cNvPr id="7" name="Rounded Rectangle 6"/>
+              <a:t>Tamper, Insert, Reorder, Substitute</a:t>
+            </a:r>
+          </a:p>
+        </p:txBody>
+      </p:sp>
+      <p:sp>
+        <p:nvSpPr>
+          <p:cNvPr id="8" name="Rounded Rectangle 7"/>
           <p:cNvSpPr/>
           <p:nvPr/>
         </p:nvSpPr>
         <p:spPr>
           <a:xfrm>
-            <a:off x="914400" y="5029200"/>
-            <a:ext cx="10360152" cy="1097280"/>
+            <a:off x="4434840" y="3200400"/>
+            <a:ext cx="3291840" cy="1188720"/>
+          </a:xfrm>
+          <a:prstGeom prst="roundRect">
+            <a:avLst/>
+          </a:prstGeom>
+          <a:solidFill>
+            <a:srgbClr val="131B2C"/>
+          </a:solidFill>
+          <a:ln w="12700">
+            <a:solidFill>
+              <a:srgbClr val="38BDF8"/>
+            </a:solidFill>
+          </a:ln>
+        </p:spPr>
+        <p:style>
+          <a:lnRef idx="1">
+            <a:schemeClr val="accent1"/>
+          </a:lnRef>
+          <a:fillRef idx="3">
+            <a:schemeClr val="accent1"/>
+          </a:fillRef>
+          <a:effectRef idx="2">
+            <a:schemeClr val="accent1"/>
+          </a:effectRef>
+          <a:fontRef idx="minor">
+            <a:schemeClr val="lt1"/>
+          </a:fontRef>
+        </p:style>
+        <p:txBody>
+          <a:bodyPr rtlCol="0" anchor="ctr"/>
+          <a:lstStyle/>
+          <a:p>
+            <a:pPr algn="ctr"/>
+          </a:p>
+        </p:txBody>
+      </p:sp>
+      <p:sp>
+        <p:nvSpPr>
+          <p:cNvPr id="9" name="TextBox 8"/>
+          <p:cNvSpPr txBox="1"/>
+          <p:nvPr/>
+        </p:nvSpPr>
+        <p:spPr>
+          <a:xfrm>
+            <a:off x="4572000" y="3291840"/>
+            <a:ext cx="3017520" cy="1005840"/>
+          </a:xfrm>
+          <a:prstGeom prst="rect">
+            <a:avLst/>
+          </a:prstGeom>
+          <a:noFill/>
+        </p:spPr>
+        <p:txBody>
+          <a:bodyPr wrap="square">
+            <a:spAutoFit/>
+          </a:bodyPr>
+          <a:lstStyle/>
+          <a:p>
+            <a:r>
+              <a:rPr sz="2600" b="1">
+                <a:solidFill>
+                  <a:srgbClr val="38BDF8"/>
+                </a:solidFill>
+                <a:latin typeface="Segoe UI"/>
+              </a:rPr>
+              <a:t>0 Hardware Changes</a:t>
+            </a:r>
+          </a:p>
+          <a:p>
+            <a:r>
+              <a:rPr sz="1200" b="1">
+                <a:solidFill>
+                  <a:srgbClr val="F8FAFC"/>
+                </a:solidFill>
+                <a:latin typeface="Segoe UI"/>
+              </a:rPr>
+              <a:t>Native Linux IMA Log</a:t>
+            </a:r>
+          </a:p>
+          <a:p>
+            <a:r>
+              <a:rPr sz="1050">
+                <a:solidFill>
+                  <a:srgbClr val="94A3B8"/>
+                </a:solidFill>
+                <a:latin typeface="Segoe UI"/>
+              </a:rPr>
+              <a:t>Runs on standard servers &amp; VMs</a:t>
+            </a:r>
+          </a:p>
+        </p:txBody>
+      </p:sp>
+      <p:sp>
+        <p:nvSpPr>
+          <p:cNvPr id="10" name="Rounded Rectangle 9"/>
+          <p:cNvSpPr/>
+          <p:nvPr/>
+        </p:nvSpPr>
+        <p:spPr>
+          <a:xfrm>
+            <a:off x="7955279" y="3200400"/>
+            <a:ext cx="3291840" cy="1188720"/>
+          </a:xfrm>
+          <a:prstGeom prst="roundRect">
+            <a:avLst/>
+          </a:prstGeom>
+          <a:solidFill>
+            <a:srgbClr val="131B2C"/>
+          </a:solidFill>
+          <a:ln w="12700">
+            <a:solidFill>
+              <a:srgbClr val="C084FC"/>
+            </a:solidFill>
+          </a:ln>
+        </p:spPr>
+        <p:style>
+          <a:lnRef idx="1">
+            <a:schemeClr val="accent1"/>
+          </a:lnRef>
+          <a:fillRef idx="3">
+            <a:schemeClr val="accent1"/>
+          </a:fillRef>
+          <a:effectRef idx="2">
+            <a:schemeClr val="accent1"/>
+          </a:effectRef>
+          <a:fontRef idx="minor">
+            <a:schemeClr val="lt1"/>
+          </a:fontRef>
+        </p:style>
+        <p:txBody>
+          <a:bodyPr rtlCol="0" anchor="ctr"/>
+          <a:lstStyle/>
+          <a:p>
+            <a:pPr algn="ctr"/>
+          </a:p>
+        </p:txBody>
+      </p:sp>
+      <p:sp>
+        <p:nvSpPr>
+          <p:cNvPr id="11" name="TextBox 10"/>
+          <p:cNvSpPr txBox="1"/>
+          <p:nvPr/>
+        </p:nvSpPr>
+        <p:spPr>
+          <a:xfrm>
+            <a:off x="8092440" y="3291840"/>
+            <a:ext cx="3017520" cy="1005840"/>
+          </a:xfrm>
+          <a:prstGeom prst="rect">
+            <a:avLst/>
+          </a:prstGeom>
+          <a:noFill/>
+        </p:spPr>
+        <p:txBody>
+          <a:bodyPr wrap="square">
+            <a:spAutoFit/>
+          </a:bodyPr>
+          <a:lstStyle/>
+          <a:p>
+            <a:r>
+              <a:rPr sz="2600" b="1">
+                <a:solidFill>
+                  <a:srgbClr val="C084FC"/>
+                </a:solidFill>
+                <a:latin typeface="Segoe UI"/>
+              </a:rPr>
+              <a:t>FIPS 204 Ready</a:t>
+            </a:r>
+          </a:p>
+          <a:p>
+            <a:r>
+              <a:rPr sz="1200" b="1">
+                <a:solidFill>
+                  <a:srgbClr val="F8FAFC"/>
+                </a:solidFill>
+                <a:latin typeface="Segoe UI"/>
+              </a:rPr>
+              <a:t>ML-DSA-65 + ECDSA P-256</a:t>
+            </a:r>
+          </a:p>
+          <a:p>
+            <a:r>
+              <a:rPr sz="1050">
+                <a:solidFill>
+                  <a:srgbClr val="94A3B8"/>
+                </a:solidFill>
+                <a:latin typeface="Segoe UI"/>
+              </a:rPr>
+              <a:t>RFC 9019 Dual Hybrid Signing</a:t>
+            </a:r>
+          </a:p>
+        </p:txBody>
+      </p:sp>
+      <p:sp>
+        <p:nvSpPr>
+          <p:cNvPr id="12" name="Rounded Rectangle 11"/>
+          <p:cNvSpPr/>
+          <p:nvPr/>
+        </p:nvSpPr>
+        <p:spPr>
+          <a:xfrm>
+            <a:off x="914400" y="4754880"/>
+            <a:ext cx="10360152" cy="1280160"/>
           </a:xfrm>
           <a:prstGeom prst="roundRect">
             <a:avLst/>
@@ -3340,14 +3609,14 @@
       </p:sp>
       <p:sp>
         <p:nvSpPr>
-          <p:cNvPr id="8" name="TextBox 7"/>
+          <p:cNvPr id="13" name="TextBox 12"/>
           <p:cNvSpPr txBox="1"/>
           <p:nvPr/>
         </p:nvSpPr>
         <p:spPr>
           <a:xfrm>
-            <a:off x="1097280" y="5166360"/>
-            <a:ext cx="9966960" cy="822960"/>
+            <a:off x="1097280" y="4892040"/>
+            <a:ext cx="9966960" cy="1005840"/>
           </a:xfrm>
           <a:prstGeom prst="rect">
             <a:avLst/>
@@ -3367,7 +3636,7 @@
                 </a:solidFill>
                 <a:latin typeface="Segoe UI"/>
               </a:rPr>
-              <a:t>Problem Statement 3: AI-Assisted Secure Boot &amp; Integrity Verification  |  Inbuilt N-Gram Behavioral Model</a:t>
+              <a:t>Problem Statement 3: AI-Assisted Secure Boot &amp; Integrity Verification</a:t>
             </a:r>
           </a:p>
           <a:p>
@@ -3495,7 +3764,7 @@
         </p:nvSpPr>
         <p:spPr>
           <a:xfrm>
-            <a:off x="731520" y="365760"/>
+            <a:off x="731520" y="320040"/>
             <a:ext cx="10698480" cy="320040"/>
           </a:xfrm>
           <a:prstGeom prst="rect">
@@ -3529,7 +3798,7 @@
         </p:nvSpPr>
         <p:spPr>
           <a:xfrm>
-            <a:off x="731520" y="640080"/>
+            <a:off x="731520" y="594360"/>
             <a:ext cx="10698480" cy="548640"/>
           </a:xfrm>
           <a:prstGeom prst="rect">
@@ -3544,13 +3813,13 @@
           <a:lstStyle/>
           <a:p>
             <a:r>
-              <a:rPr sz="2400" b="1">
+              <a:rPr sz="2300" b="1">
                 <a:solidFill>
                   <a:srgbClr val="F8FAFC"/>
                 </a:solidFill>
                 <a:latin typeface="Segoe UI"/>
               </a:rPr>
-              <a:t>Why Traditional Boot Attestation Fails Against Modern Bootkits</a:t>
+              <a:t>Why Signature Verification is Structurally Blind to Modern Bootkits</a:t>
             </a:r>
           </a:p>
           <a:p>
@@ -3561,7 +3830,7 @@
                 </a:solidFill>
                 <a:latin typeface="Segoe UI"/>
               </a:rPr>
-              <a:t>Signatures verify author identity — they say nothing about whether the execution order is normal.</a:t>
+              <a:t>Signatures verify provenance; they say nothing about whether the boot sequence is abnormal.</a:t>
             </a:r>
           </a:p>
         </p:txBody>
@@ -3574,8 +3843,8 @@
         </p:nvSpPr>
         <p:spPr>
           <a:xfrm>
-            <a:off x="731520" y="1554480"/>
-            <a:ext cx="5120640" cy="4023360"/>
+            <a:off x="731520" y="1463040"/>
+            <a:ext cx="5120640" cy="4114800"/>
           </a:xfrm>
           <a:prstGeom prst="roundRect">
             <a:avLst/>
@@ -3619,8 +3888,8 @@
         </p:nvSpPr>
         <p:spPr>
           <a:xfrm>
-            <a:off x="932688" y="1719072"/>
-            <a:ext cx="4718303" cy="3694176"/>
+            <a:off x="932688" y="1609344"/>
+            <a:ext cx="4718303" cy="3822191"/>
           </a:xfrm>
           <a:prstGeom prst="rect">
             <a:avLst/>
@@ -3635,11 +3904,11 @@
           <a:p>
             <a:pPr>
               <a:spcAft>
-                <a:spcPts val="1000"/>
+                <a:spcPts val="800"/>
               </a:spcAft>
             </a:pPr>
             <a:r>
-              <a:rPr sz="1100" b="1">
+              <a:rPr sz="1050" b="1">
                 <a:solidFill>
                   <a:srgbClr val="F87171"/>
                 </a:solidFill>
@@ -3648,7 +3917,7 @@
               <a:t>[THE ALLOWLIST FALLACY] </a:t>
             </a:r>
             <a:r>
-              <a:rPr sz="1600" b="1">
+              <a:rPr sz="1550" b="1">
                 <a:solidFill>
                   <a:srgbClr val="F8FAFC"/>
                 </a:solidFill>
@@ -3660,11 +3929,11 @@
           <a:p>
             <a:pPr>
               <a:spcAft>
-                <a:spcPts val="600"/>
+                <a:spcPts val="500"/>
               </a:spcAft>
             </a:pPr>
             <a:r>
-              <a:rPr sz="1250" b="1">
+              <a:rPr sz="1200" b="1">
                 <a:solidFill>
                   <a:srgbClr val="94A3B8"/>
                 </a:solidFill>
@@ -3673,23 +3942,23 @@
               <a:t>Static Guest List: </a:t>
             </a:r>
             <a:r>
-              <a:rPr sz="1250">
+              <a:rPr sz="1200">
                 <a:solidFill>
                   <a:srgbClr val="F8FAFC"/>
                 </a:solidFill>
                 <a:latin typeface="Segoe UI"/>
               </a:rPr>
-              <a:t>Compares measured file hashes against a manually maintained allowlist.</a:t>
+              <a:t>Checks measured hashes against an allowlist of known-good SHA-256 digests.</a:t>
             </a:r>
           </a:p>
           <a:p>
             <a:pPr>
               <a:spcAft>
-                <a:spcPts val="600"/>
+                <a:spcPts val="500"/>
               </a:spcAft>
             </a:pPr>
             <a:r>
-              <a:rPr sz="1250" b="1">
+              <a:rPr sz="1200" b="1">
                 <a:solidFill>
                   <a:srgbClr val="94A3B8"/>
                 </a:solidFill>
@@ -3698,23 +3967,23 @@
               <a:t>Single Question: </a:t>
             </a:r>
             <a:r>
-              <a:rPr sz="1250">
+              <a:rPr sz="1200">
                 <a:solidFill>
                   <a:srgbClr val="F8FAFC"/>
                 </a:solidFill>
                 <a:latin typeface="Segoe UI"/>
               </a:rPr>
-              <a:t>'Does this hash appear in our database of known-good files?'</a:t>
+              <a:t>'Does this hash appear in the database?'</a:t>
             </a:r>
           </a:p>
           <a:p>
             <a:pPr>
               <a:spcAft>
-                <a:spcPts val="600"/>
+                <a:spcPts val="500"/>
               </a:spcAft>
             </a:pPr>
             <a:r>
-              <a:rPr sz="1250" b="1">
+              <a:rPr sz="1200" b="1">
                 <a:solidFill>
                   <a:srgbClr val="F87171"/>
                 </a:solidFill>
@@ -3723,38 +3992,38 @@
               <a:t>Fatal Blind Spot: </a:t>
             </a:r>
             <a:r>
-              <a:rPr sz="1250">
+              <a:rPr sz="1200">
                 <a:solidFill>
                   <a:srgbClr val="F8FAFC"/>
                 </a:solidFill>
                 <a:latin typeface="Segoe UI"/>
               </a:rPr>
-              <a:t>Cannot see event order, timing, race conditions, or binary permutations.</a:t>
+              <a:t>Completely blind to execution order, race conditions, and binary permutations.</a:t>
             </a:r>
           </a:p>
           <a:p>
             <a:pPr>
               <a:spcAft>
-                <a:spcPts val="600"/>
+                <a:spcPts val="500"/>
               </a:spcAft>
             </a:pPr>
             <a:r>
-              <a:rPr sz="1250" b="1">
+              <a:rPr sz="1200" b="1">
                 <a:solidFill>
                   <a:srgbClr val="F87171"/>
                 </a:solidFill>
                 <a:latin typeface="Segoe UI"/>
               </a:rPr>
-              <a:t>Outcome: </a:t>
-            </a:r>
-            <a:r>
-              <a:rPr sz="1250">
+              <a:t>Zero Protection: </a:t>
+            </a:r>
+            <a:r>
+              <a:rPr sz="1200">
                 <a:solidFill>
                   <a:srgbClr val="F8FAFC"/>
                 </a:solidFill>
                 <a:latin typeface="Segoe UI"/>
               </a:rPr>
-              <a:t>If an attacker runs genuine signed binaries in a malicious sequence, allowlists approve it.</a:t>
+              <a:t>An attacker running valid signed binaries in an abnormal sequence is approved 100%.</a:t>
             </a:r>
           </a:p>
         </p:txBody>
@@ -3767,8 +4036,8 @@
         </p:nvSpPr>
         <p:spPr>
           <a:xfrm>
-            <a:off x="6217920" y="1554480"/>
-            <a:ext cx="5120640" cy="4023360"/>
+            <a:off x="6217920" y="1463040"/>
+            <a:ext cx="5120640" cy="4114800"/>
           </a:xfrm>
           <a:prstGeom prst="roundRect">
             <a:avLst/>
@@ -3812,8 +4081,8 @@
         </p:nvSpPr>
         <p:spPr>
           <a:xfrm>
-            <a:off x="6419088" y="1719072"/>
-            <a:ext cx="4718303" cy="3694176"/>
+            <a:off x="6419088" y="1609344"/>
+            <a:ext cx="4718303" cy="3822191"/>
           </a:xfrm>
           <a:prstGeom prst="rect">
             <a:avLst/>
@@ -3828,11 +4097,11 @@
           <a:p>
             <a:pPr>
               <a:spcAft>
-                <a:spcPts val="1000"/>
+                <a:spcPts val="800"/>
               </a:spcAft>
             </a:pPr>
             <a:r>
-              <a:rPr sz="1100" b="1">
+              <a:rPr sz="1050" b="1">
                 <a:solidFill>
                   <a:srgbClr val="FBBF24"/>
                 </a:solidFill>
@@ -3841,7 +4110,7 @@
               <a:t>[REAL-WORLD VECTORS] </a:t>
             </a:r>
             <a:r>
-              <a:rPr sz="1600" b="1">
+              <a:rPr sz="1550" b="1">
                 <a:solidFill>
                   <a:srgbClr val="F8FAFC"/>
                 </a:solidFill>
@@ -3853,11 +4122,11 @@
           <a:p>
             <a:pPr>
               <a:spcAft>
-                <a:spcPts val="600"/>
+                <a:spcPts val="500"/>
               </a:spcAft>
             </a:pPr>
             <a:r>
-              <a:rPr sz="1250" b="1">
+              <a:rPr sz="1200" b="1">
                 <a:solidFill>
                   <a:srgbClr val="38BDF8"/>
                 </a:solidFill>
@@ -3866,23 +4135,23 @@
               <a:t>BlackLotus: </a:t>
             </a:r>
             <a:r>
-              <a:rPr sz="1250">
+              <a:rPr sz="1200">
                 <a:solidFill>
                   <a:srgbClr val="F8FAFC"/>
                 </a:solidFill>
                 <a:latin typeface="Segoe UI"/>
               </a:rPr>
-              <a:t>Bypassed UEFI Secure Boot by deploying authentic, validly-signed Microsoft binaries that harbored known CVEs.</a:t>
+              <a:t>Bypassed UEFI Secure Boot by shipping authentic, Microsoft-signed binaries with known flaws.</a:t>
             </a:r>
           </a:p>
           <a:p>
             <a:pPr>
               <a:spcAft>
-                <a:spcPts val="600"/>
+                <a:spcPts val="500"/>
               </a:spcAft>
             </a:pPr>
             <a:r>
-              <a:rPr sz="1250" b="1">
+              <a:rPr sz="1200" b="1">
                 <a:solidFill>
                   <a:srgbClr val="38BDF8"/>
                 </a:solidFill>
@@ -3891,23 +4160,23 @@
               <a:t>Bootkitty: </a:t>
             </a:r>
             <a:r>
-              <a:rPr sz="1250">
+              <a:rPr sz="1200">
                 <a:solidFill>
                   <a:srgbClr val="F8FAFC"/>
                 </a:solidFill>
                 <a:latin typeface="Segoe UI"/>
               </a:rPr>
-              <a:t>Compromised Ubuntu Secure Boot through signed components via LogoFAIL memory vulnerabilities.</a:t>
+              <a:t>Compromised Ubuntu Secure Boot through signed components via LogoFAIL vulnerabilities.</a:t>
             </a:r>
           </a:p>
           <a:p>
             <a:pPr>
               <a:spcAft>
-                <a:spcPts val="600"/>
+                <a:spcPts val="500"/>
               </a:spcAft>
             </a:pPr>
             <a:r>
-              <a:rPr sz="1250" b="1">
+              <a:rPr sz="1200" b="1">
                 <a:solidFill>
                   <a:srgbClr val="FBBF24"/>
                 </a:solidFill>
@@ -3916,38 +4185,38 @@
               <a:t>The Reality: </a:t>
             </a:r>
             <a:r>
-              <a:rPr sz="1250">
+              <a:rPr sz="1200">
                 <a:solidFill>
                   <a:srgbClr val="F8FAFC"/>
                 </a:solidFill>
                 <a:latin typeface="Segoe UI"/>
               </a:rPr>
-              <a:t>Every signature was valid. Every hash matched. The machine was owned anyway.</a:t>
+              <a:t>Every signature was valid. Every hash was on the list. The machine was compromised anyway.</a:t>
             </a:r>
           </a:p>
           <a:p>
             <a:pPr>
               <a:spcAft>
-                <a:spcPts val="600"/>
+                <a:spcPts val="500"/>
               </a:spcAft>
             </a:pPr>
             <a:r>
-              <a:rPr sz="1250" b="1">
+              <a:rPr sz="1200" b="1">
                 <a:solidFill>
                   <a:srgbClr val="34D399"/>
                 </a:solidFill>
                 <a:latin typeface="Segoe UI"/>
               </a:rPr>
-              <a:t>The Key Signal: </a:t>
-            </a:r>
-            <a:r>
-              <a:rPr sz="1250">
+              <a:t>The Solution: </a:t>
+            </a:r>
+            <a:r>
+              <a:rPr sz="1200">
                 <a:solidFill>
                   <a:srgbClr val="F8FAFC"/>
                 </a:solidFill>
                 <a:latin typeface="Segoe UI"/>
               </a:rPr>
-              <a:t>Boot event sequence order is the only remaining anomaly signal.</a:t>
+              <a:t>Transition sequence order is the only remaining anomaly signal.</a:t>
             </a:r>
           </a:p>
         </p:txBody>
@@ -3960,7 +4229,7 @@
         </p:nvSpPr>
         <p:spPr>
           <a:xfrm>
-            <a:off x="731520" y="5715000"/>
+            <a:off x="731520" y="5760720"/>
             <a:ext cx="10607040" cy="685800"/>
           </a:xfrm>
           <a:prstGeom prst="roundRect">
@@ -4005,7 +4274,7 @@
         </p:nvSpPr>
         <p:spPr>
           <a:xfrm>
-            <a:off x="914400" y="5760720"/>
+            <a:off x="914400" y="5806440"/>
             <a:ext cx="10241280" cy="594360"/>
           </a:xfrm>
           <a:prstGeom prst="rect">
@@ -4026,7 +4295,7 @@
                 </a:solidFill>
                 <a:latin typeface="Segoe UI"/>
               </a:rPr>
-              <a:t>💡 PRAHARI Principle: Boot integrity is a property of the ORDER of events, not of individual hashes.</a:t>
+              <a:t>💡 Core Insight: Boot integrity is a property of the ORDER of events, not of individual hashes.</a:t>
             </a:r>
           </a:p>
         </p:txBody>
@@ -4143,7 +4412,7 @@
         </p:nvSpPr>
         <p:spPr>
           <a:xfrm>
-            <a:off x="731520" y="365760"/>
+            <a:off x="731520" y="320040"/>
             <a:ext cx="10698480" cy="320040"/>
           </a:xfrm>
           <a:prstGeom prst="rect">
@@ -4164,7 +4433,7 @@
                 </a:solidFill>
                 <a:latin typeface="Segoe UI"/>
               </a:rPr>
-              <a:t>CORE INNOVATION</a:t>
+              <a:t>OUR INNOVATION</a:t>
             </a:r>
           </a:p>
         </p:txBody>
@@ -4177,7 +4446,7 @@
         </p:nvSpPr>
         <p:spPr>
           <a:xfrm>
-            <a:off x="731520" y="640080"/>
+            <a:off x="731520" y="594360"/>
             <a:ext cx="10698480" cy="548640"/>
           </a:xfrm>
           <a:prstGeom prst="rect">
@@ -4192,13 +4461,13 @@
           <a:lstStyle/>
           <a:p>
             <a:r>
-              <a:rPr sz="2400" b="1">
+              <a:rPr sz="2300" b="1">
                 <a:solidFill>
                   <a:srgbClr val="F8FAFC"/>
                 </a:solidFill>
                 <a:latin typeface="Segoe UI"/>
               </a:rPr>
-              <a:t>Dual-Axis Token Projection &amp; N-Gram Sequence Modeling</a:t>
+              <a:t>Dual-Axis Token Projection &amp; N-Gram Behavioral Modeling</a:t>
             </a:r>
           </a:p>
           <a:p>
@@ -4222,8 +4491,8 @@
         </p:nvSpPr>
         <p:spPr>
           <a:xfrm>
-            <a:off x="731520" y="1554480"/>
-            <a:ext cx="3383280" cy="4846320"/>
+            <a:off x="731520" y="1463040"/>
+            <a:ext cx="3383280" cy="4937760"/>
           </a:xfrm>
           <a:prstGeom prst="roundRect">
             <a:avLst/>
@@ -4267,8 +4536,8 @@
         </p:nvSpPr>
         <p:spPr>
           <a:xfrm>
-            <a:off x="932688" y="1719072"/>
-            <a:ext cx="2980944" cy="4517136"/>
+            <a:off x="932688" y="1609344"/>
+            <a:ext cx="2980944" cy="4645152"/>
           </a:xfrm>
           <a:prstGeom prst="rect">
             <a:avLst/>
@@ -4283,11 +4552,11 @@
           <a:p>
             <a:pPr>
               <a:spcAft>
-                <a:spcPts val="1000"/>
+                <a:spcPts val="800"/>
               </a:spcAft>
             </a:pPr>
             <a:r>
-              <a:rPr sz="1100" b="1">
+              <a:rPr sz="1050" b="1">
                 <a:solidFill>
                   <a:srgbClr val="38BDF8"/>
                 </a:solidFill>
@@ -4296,7 +4565,7 @@
               <a:t>[1. PROJECTION] </a:t>
             </a:r>
             <a:r>
-              <a:rPr sz="1600" b="1">
+              <a:rPr sz="1550" b="1">
                 <a:solidFill>
                   <a:srgbClr val="F8FAFC"/>
                 </a:solidFill>
@@ -4308,11 +4577,11 @@
           <a:p>
             <a:pPr>
               <a:spcAft>
-                <a:spcPts val="600"/>
+                <a:spcPts val="500"/>
               </a:spcAft>
             </a:pPr>
             <a:r>
-              <a:rPr sz="1250" b="1">
+              <a:rPr sz="1200" b="1">
                 <a:solidFill>
                   <a:srgbClr val="38BDF8"/>
                 </a:solidFill>
@@ -4321,23 +4590,23 @@
               <a:t>Identity Axis: </a:t>
             </a:r>
             <a:r>
-              <a:rPr sz="1250">
+              <a:rPr sz="1200">
                 <a:solidFill>
                   <a:srgbClr val="F8FAFC"/>
                 </a:solidFill>
                 <a:latin typeface="Segoe UI"/>
               </a:rPr>
-              <a:t>Normalised path (/init, /bin/systemd) — deterministic across boots.</a:t>
+              <a:t>Normalised path (/init, /bin/systemd) — deterministic across clean boots.</a:t>
             </a:r>
           </a:p>
           <a:p>
             <a:pPr>
               <a:spcAft>
-                <a:spcPts val="600"/>
+                <a:spcPts val="500"/>
               </a:spcAft>
             </a:pPr>
             <a:r>
-              <a:rPr sz="1250" b="1">
+              <a:rPr sz="1200" b="1">
                 <a:solidFill>
                   <a:srgbClr val="34D399"/>
                 </a:solidFill>
@@ -4346,7 +4615,7 @@
               <a:t>Content Axis: </a:t>
             </a:r>
             <a:r>
-              <a:rPr sz="1250">
+              <a:rPr sz="1200">
                 <a:solidFill>
                   <a:srgbClr val="F8FAFC"/>
                 </a:solidFill>
@@ -4358,51 +4627,51 @@
           <a:p>
             <a:pPr>
               <a:spcAft>
-                <a:spcPts val="600"/>
+                <a:spcPts val="500"/>
               </a:spcAft>
             </a:pPr>
             <a:r>
-              <a:rPr sz="1250" b="1">
+              <a:rPr sz="1200" b="1">
                 <a:solidFill>
                   <a:srgbClr val="94A3B8"/>
                 </a:solidFill>
                 <a:latin typeface="Segoe UI"/>
               </a:rPr>
-              <a:t>The Innovation: </a:t>
-            </a:r>
-            <a:r>
-              <a:rPr sz="1250">
+              <a:t>Why it matters: </a:t>
+            </a:r>
+            <a:r>
+              <a:rPr sz="1200">
                 <a:solidFill>
                   <a:srgbClr val="F8FAFC"/>
                 </a:solidFill>
                 <a:latin typeface="Segoe UI"/>
               </a:rPr>
-              <a:t>Projects continuous measurement streams into discrete tokens for sequence modeling.</a:t>
+              <a:t>Projects continuous measurement logs into discrete tokens for sequence anomaly analysis.</a:t>
             </a:r>
           </a:p>
           <a:p>
             <a:pPr>
               <a:spcAft>
-                <a:spcPts val="600"/>
+                <a:spcPts val="500"/>
               </a:spcAft>
             </a:pPr>
             <a:r>
-              <a:rPr sz="1250" b="1">
+              <a:rPr sz="1200" b="1">
                 <a:solidFill>
                   <a:srgbClr val="94A3B8"/>
                 </a:solidFill>
                 <a:latin typeface="Segoe UI"/>
               </a:rPr>
-              <a:t>Native IMA: </a:t>
-            </a:r>
-            <a:r>
-              <a:rPr sz="1250">
+              <a:t>Native Linux: </a:t>
+            </a:r>
+            <a:r>
+              <a:rPr sz="1200">
                 <a:solidFill>
                   <a:srgbClr val="F8FAFC"/>
                 </a:solidFill>
                 <a:latin typeface="Segoe UI"/>
               </a:rPr>
-              <a:t>Reads /sys/kernel/security/ima/ascii_runtime_measurements directly.</a:t>
+              <a:t>Reads securityfs /ima/ascii_runtime_measurements directly.</a:t>
             </a:r>
           </a:p>
         </p:txBody>
@@ -4415,8 +4684,8 @@
         </p:nvSpPr>
         <p:spPr>
           <a:xfrm>
-            <a:off x="4389120" y="1554480"/>
-            <a:ext cx="3383280" cy="4846320"/>
+            <a:off x="4389120" y="1463040"/>
+            <a:ext cx="3383280" cy="4937760"/>
           </a:xfrm>
           <a:prstGeom prst="roundRect">
             <a:avLst/>
@@ -4460,8 +4729,8 @@
         </p:nvSpPr>
         <p:spPr>
           <a:xfrm>
-            <a:off x="4590288" y="1719072"/>
-            <a:ext cx="2980944" cy="4517136"/>
+            <a:off x="4590288" y="1609344"/>
+            <a:ext cx="2980944" cy="4645152"/>
           </a:xfrm>
           <a:prstGeom prst="rect">
             <a:avLst/>
@@ -4476,11 +4745,11 @@
           <a:p>
             <a:pPr>
               <a:spcAft>
-                <a:spcPts val="1000"/>
+                <a:spcPts val="800"/>
               </a:spcAft>
             </a:pPr>
             <a:r>
-              <a:rPr sz="1100" b="1">
+              <a:rPr sz="1050" b="1">
                 <a:solidFill>
                   <a:srgbClr val="34D399"/>
                 </a:solidFill>
@@ -4489,7 +4758,7 @@
               <a:t>[2. LEARNING] </a:t>
             </a:r>
             <a:r>
-              <a:rPr sz="1600" b="1">
+              <a:rPr sz="1550" b="1">
                 <a:solidFill>
                   <a:srgbClr val="F8FAFC"/>
                 </a:solidFill>
@@ -4501,36 +4770,36 @@
           <a:p>
             <a:pPr>
               <a:spcAft>
-                <a:spcPts val="600"/>
+                <a:spcPts val="500"/>
               </a:spcAft>
             </a:pPr>
             <a:r>
-              <a:rPr sz="1250" b="1">
+              <a:rPr sz="1200" b="1">
                 <a:solidFill>
                   <a:srgbClr val="34D399"/>
                 </a:solidFill>
                 <a:latin typeface="Segoe UI"/>
               </a:rPr>
-              <a:t>Rapid Training: </a:t>
-            </a:r>
-            <a:r>
-              <a:rPr sz="1250">
+              <a:t>Rapid Convergence: </a:t>
+            </a:r>
+            <a:r>
+              <a:rPr sz="1200">
                 <a:solidFill>
                   <a:srgbClr val="F8FAFC"/>
                 </a:solidFill>
                 <a:latin typeface="Segoe UI"/>
               </a:rPr>
-              <a:t>Converges within 4-5 baseline boots on physical machines.</a:t>
+              <a:t>Learns baseline transitions in 4-5 boots on physical machines.</a:t>
             </a:r>
           </a:p>
           <a:p>
             <a:pPr>
               <a:spcAft>
-                <a:spcPts val="600"/>
+                <a:spcPts val="500"/>
               </a:spcAft>
             </a:pPr>
             <a:r>
-              <a:rPr sz="1250" b="1">
+              <a:rPr sz="1200" b="1">
                 <a:solidFill>
                   <a:srgbClr val="34D399"/>
                 </a:solidFill>
@@ -4539,7 +4808,7 @@
               <a:t>100% Inspectable: </a:t>
             </a:r>
             <a:r>
-              <a:rPr sz="1250">
+              <a:rPr sz="1200">
                 <a:solidFill>
                   <a:srgbClr val="F8FAFC"/>
                 </a:solidFill>
@@ -4551,11 +4820,11 @@
           <a:p>
             <a:pPr>
               <a:spcAft>
-                <a:spcPts val="600"/>
+                <a:spcPts val="500"/>
               </a:spcAft>
             </a:pPr>
             <a:r>
-              <a:rPr sz="1250" b="1">
+              <a:rPr sz="1200" b="1">
                 <a:solidFill>
                   <a:srgbClr val="FBBF24"/>
                 </a:solidFill>
@@ -4564,23 +4833,23 @@
               <a:t>Zero Black Box: </a:t>
             </a:r>
             <a:r>
-              <a:rPr sz="1250">
+              <a:rPr sz="1200">
                 <a:solidFill>
                   <a:srgbClr val="F8FAFC"/>
                 </a:solidFill>
                 <a:latin typeface="Segoe UI"/>
               </a:rPr>
-              <a:t>Avoids opaque neural weights (DeepLog/LogBERT) that require 10,000+ logs.</a:t>
+              <a:t>Avoids opaque neural weights (DeepLog/LogBERT) that require thousands of logs.</a:t>
             </a:r>
           </a:p>
           <a:p>
             <a:pPr>
               <a:spcAft>
-                <a:spcPts val="600"/>
+                <a:spcPts val="500"/>
               </a:spcAft>
             </a:pPr>
             <a:r>
-              <a:rPr sz="1250" b="1">
+              <a:rPr sz="1200" b="1">
                 <a:solidFill>
                   <a:srgbClr val="F8FAFC"/>
                 </a:solidFill>
@@ -4589,7 +4858,7 @@
               <a:t>Actionable: </a:t>
             </a:r>
             <a:r>
-              <a:rPr sz="1250">
+              <a:rPr sz="1200">
                 <a:solidFill>
                   <a:srgbClr val="F8FAFC"/>
                 </a:solidFill>
@@ -4608,8 +4877,8 @@
         </p:nvSpPr>
         <p:spPr>
           <a:xfrm>
-            <a:off x="8046720" y="1554480"/>
-            <a:ext cx="3383280" cy="4846320"/>
+            <a:off x="8046720" y="1463040"/>
+            <a:ext cx="3383280" cy="4937760"/>
           </a:xfrm>
           <a:prstGeom prst="roundRect">
             <a:avLst/>
@@ -4653,8 +4922,8 @@
         </p:nvSpPr>
         <p:spPr>
           <a:xfrm>
-            <a:off x="8247888" y="1719072"/>
-            <a:ext cx="2980944" cy="4517136"/>
+            <a:off x="8247888" y="1609344"/>
+            <a:ext cx="2980944" cy="4645152"/>
           </a:xfrm>
           <a:prstGeom prst="rect">
             <a:avLst/>
@@ -4669,11 +4938,11 @@
           <a:p>
             <a:pPr>
               <a:spcAft>
-                <a:spcPts val="1000"/>
+                <a:spcPts val="800"/>
               </a:spcAft>
             </a:pPr>
             <a:r>
-              <a:rPr sz="1100" b="1">
+              <a:rPr sz="1050" b="1">
                 <a:solidFill>
                   <a:srgbClr val="C084FC"/>
                 </a:solidFill>
@@ -4682,7 +4951,7 @@
               <a:t>[3. POST-QUANTUM] </a:t>
             </a:r>
             <a:r>
-              <a:rPr sz="1600" b="1">
+              <a:rPr sz="1550" b="1">
                 <a:solidFill>
                   <a:srgbClr val="F8FAFC"/>
                 </a:solidFill>
@@ -4694,11 +4963,11 @@
           <a:p>
             <a:pPr>
               <a:spcAft>
-                <a:spcPts val="600"/>
+                <a:spcPts val="500"/>
               </a:spcAft>
             </a:pPr>
             <a:r>
-              <a:rPr sz="1250" b="1">
+              <a:rPr sz="1200" b="1">
                 <a:solidFill>
                   <a:srgbClr val="C084FC"/>
                 </a:solidFill>
@@ -4707,23 +4976,23 @@
               <a:t>Dual Signatures: </a:t>
             </a:r>
             <a:r>
-              <a:rPr sz="1250">
+              <a:rPr sz="1200">
                 <a:solidFill>
                   <a:srgbClr val="F8FAFC"/>
                 </a:solidFill>
                 <a:latin typeface="Segoe UI"/>
               </a:rPr>
-              <a:t>ECDSA P-256 (today) + ML-DSA-65 (FIPS 204 quantum resistance).</a:t>
+              <a:t>ECDSA P-256 (classical) + ML-DSA-65 (FIPS 204 post-quantum).</a:t>
             </a:r>
           </a:p>
           <a:p>
             <a:pPr>
               <a:spcAft>
-                <a:spcPts val="600"/>
+                <a:spcPts val="500"/>
               </a:spcAft>
             </a:pPr>
             <a:r>
-              <a:rPr sz="1250" b="1">
+              <a:rPr sz="1200" b="1">
                 <a:solidFill>
                   <a:srgbClr val="C084FC"/>
                 </a:solidFill>
@@ -4732,7 +5001,7 @@
               <a:t>RFC 9019 Standard: </a:t>
             </a:r>
             <a:r>
-              <a:rPr sz="1250">
+              <a:rPr sz="1200">
                 <a:solidFill>
                   <a:srgbClr val="F8FAFC"/>
                 </a:solidFill>
@@ -4744,11 +5013,11 @@
           <a:p>
             <a:pPr>
               <a:spcAft>
-                <a:spcPts val="600"/>
+                <a:spcPts val="500"/>
               </a:spcAft>
             </a:pPr>
             <a:r>
-              <a:rPr sz="1250" b="1">
+              <a:rPr sz="1200" b="1">
                 <a:solidFill>
                   <a:srgbClr val="34D399"/>
                 </a:solidFill>
@@ -4757,23 +5026,23 @@
               <a:t>NSA CNSA 2.0: </a:t>
             </a:r>
             <a:r>
-              <a:rPr sz="1250">
+              <a:rPr sz="1200">
                 <a:solidFill>
                   <a:srgbClr val="F8FAFC"/>
                 </a:solidFill>
                 <a:latin typeface="Segoe UI"/>
               </a:rPr>
-              <a:t>Directly satisfies national priority for quantum-safe boot firmware.</a:t>
+              <a:t>Directly implements firmware/boot integrity quantum transition priority.</a:t>
             </a:r>
           </a:p>
           <a:p>
             <a:pPr>
               <a:spcAft>
-                <a:spcPts val="600"/>
+                <a:spcPts val="500"/>
               </a:spcAft>
             </a:pPr>
             <a:r>
-              <a:rPr sz="1250" b="1">
+              <a:rPr sz="1200" b="1">
                 <a:solidFill>
                   <a:srgbClr val="94A3B8"/>
                 </a:solidFill>
@@ -4782,7 +5051,7 @@
               <a:t>OpenSSL 3.5: </a:t>
             </a:r>
             <a:r>
-              <a:rPr sz="1250">
+              <a:rPr sz="1200">
                 <a:solidFill>
                   <a:srgbClr val="F8FAFC"/>
                 </a:solidFill>
@@ -4905,7 +5174,7 @@
         </p:nvSpPr>
         <p:spPr>
           <a:xfrm>
-            <a:off x="731520" y="365760"/>
+            <a:off x="731520" y="320040"/>
             <a:ext cx="10698480" cy="320040"/>
           </a:xfrm>
           <a:prstGeom prst="rect">
@@ -4939,7 +5208,7 @@
         </p:nvSpPr>
         <p:spPr>
           <a:xfrm>
-            <a:off x="731520" y="640080"/>
+            <a:off x="731520" y="594360"/>
             <a:ext cx="10698480" cy="548640"/>
           </a:xfrm>
           <a:prstGeom prst="rect">
@@ -4954,7 +5223,7 @@
           <a:lstStyle/>
           <a:p>
             <a:r>
-              <a:rPr sz="2400" b="1">
+              <a:rPr sz="2300" b="1">
                 <a:solidFill>
                   <a:srgbClr val="F8FAFC"/>
                 </a:solidFill>
@@ -4971,7 +5240,7 @@
                 </a:solidFill>
                 <a:latin typeface="Segoe UI"/>
               </a:rPr>
-              <a:t>Comprehensive evaluation across synthetic and hardware-captured Linux boot logs.</a:t>
+              <a:t>Evaluating tamper, insert, reorder, and substitute attacks on Linux IMA logs.</a:t>
             </a:r>
           </a:p>
         </p:txBody>
@@ -4984,8 +5253,8 @@
         </p:nvSpPr>
         <p:spPr>
           <a:xfrm>
-            <a:off x="731520" y="1554480"/>
-            <a:ext cx="10698480" cy="4846320"/>
+            <a:off x="731520" y="1463040"/>
+            <a:ext cx="10698480" cy="4937760"/>
           </a:xfrm>
           <a:prstGeom prst="roundRect">
             <a:avLst/>
@@ -5029,8 +5298,8 @@
         </p:nvSpPr>
         <p:spPr>
           <a:xfrm>
-            <a:off x="914400" y="1737360"/>
-            <a:ext cx="10332720" cy="4389120"/>
+            <a:off x="914400" y="1645920"/>
+            <a:ext cx="10332720" cy="4572000"/>
           </a:xfrm>
           <a:prstGeom prst="rect">
             <a:avLst/>
@@ -5416,7 +5685,7 @@
         </p:nvSpPr>
         <p:spPr>
           <a:xfrm>
-            <a:off x="731520" y="365760"/>
+            <a:off x="731520" y="320040"/>
             <a:ext cx="10698480" cy="320040"/>
           </a:xfrm>
           <a:prstGeom prst="rect">
@@ -5450,7 +5719,7 @@
         </p:nvSpPr>
         <p:spPr>
           <a:xfrm>
-            <a:off x="731520" y="640080"/>
+            <a:off x="731520" y="594360"/>
             <a:ext cx="10698480" cy="548640"/>
           </a:xfrm>
           <a:prstGeom prst="rect">
@@ -5465,7 +5734,7 @@
           <a:lstStyle/>
           <a:p>
             <a:r>
-              <a:rPr sz="2400" b="1">
+              <a:rPr sz="2300" b="1">
                 <a:solidFill>
                   <a:srgbClr val="F8FAFC"/>
                 </a:solidFill>
@@ -5495,8 +5764,8 @@
         </p:nvSpPr>
         <p:spPr>
           <a:xfrm>
-            <a:off x="731520" y="1463040"/>
-            <a:ext cx="10698480" cy="4937760"/>
+            <a:off x="731520" y="1417320"/>
+            <a:ext cx="10698480" cy="5029200"/>
           </a:xfrm>
           <a:prstGeom prst="roundRect">
             <a:avLst/>
@@ -5548,7 +5817,7 @@
         </p:blipFill>
         <p:spPr>
           <a:xfrm>
-            <a:off x="914400" y="1645920"/>
+            <a:off x="914400" y="1600200"/>
             <a:ext cx="10332720" cy="5175927"/>
           </a:xfrm>
           <a:prstGeom prst="rect">
@@ -5668,7 +5937,7 @@
         </p:nvSpPr>
         <p:spPr>
           <a:xfrm>
-            <a:off x="731520" y="365760"/>
+            <a:off x="731520" y="320040"/>
             <a:ext cx="10698480" cy="320040"/>
           </a:xfrm>
           <a:prstGeom prst="rect">
@@ -5702,7 +5971,7 @@
         </p:nvSpPr>
         <p:spPr>
           <a:xfrm>
-            <a:off x="731520" y="640080"/>
+            <a:off x="731520" y="594360"/>
             <a:ext cx="10698480" cy="548640"/>
           </a:xfrm>
           <a:prstGeom prst="rect">
@@ -5717,7 +5986,7 @@
           <a:lstStyle/>
           <a:p>
             <a:r>
-              <a:rPr sz="2400" b="1">
+              <a:rPr sz="2300" b="1">
                 <a:solidFill>
                   <a:srgbClr val="F8FAFC"/>
                 </a:solidFill>
@@ -5747,8 +6016,8 @@
         </p:nvSpPr>
         <p:spPr>
           <a:xfrm>
-            <a:off x="731520" y="1463040"/>
-            <a:ext cx="10698480" cy="4937760"/>
+            <a:off x="731520" y="1417320"/>
+            <a:ext cx="10698480" cy="5029200"/>
           </a:xfrm>
           <a:prstGeom prst="roundRect">
             <a:avLst/>
@@ -5800,7 +6069,7 @@
         </p:blipFill>
         <p:spPr>
           <a:xfrm>
-            <a:off x="1280160" y="1600200"/>
+            <a:off x="1280160" y="1554480"/>
             <a:ext cx="9601200" cy="6636124"/>
           </a:xfrm>
           <a:prstGeom prst="rect">
@@ -5920,7 +6189,7 @@
         </p:nvSpPr>
         <p:spPr>
           <a:xfrm>
-            <a:off x="731520" y="365760"/>
+            <a:off x="731520" y="320040"/>
             <a:ext cx="10698480" cy="320040"/>
           </a:xfrm>
           <a:prstGeom prst="rect">
@@ -5954,7 +6223,7 @@
         </p:nvSpPr>
         <p:spPr>
           <a:xfrm>
-            <a:off x="731520" y="640080"/>
+            <a:off x="731520" y="594360"/>
             <a:ext cx="10698480" cy="548640"/>
           </a:xfrm>
           <a:prstGeom prst="rect">
@@ -5969,7 +6238,7 @@
           <a:lstStyle/>
           <a:p>
             <a:r>
-              <a:rPr sz="2400" b="1">
+              <a:rPr sz="2300" b="1">
                 <a:solidFill>
                   <a:srgbClr val="F8FAFC"/>
                 </a:solidFill>
@@ -5999,8 +6268,8 @@
         </p:nvSpPr>
         <p:spPr>
           <a:xfrm>
-            <a:off x="731520" y="1554480"/>
-            <a:ext cx="5120640" cy="4846320"/>
+            <a:off x="731520" y="1463040"/>
+            <a:ext cx="5120640" cy="4937760"/>
           </a:xfrm>
           <a:prstGeom prst="roundRect">
             <a:avLst/>
@@ -6044,8 +6313,8 @@
         </p:nvSpPr>
         <p:spPr>
           <a:xfrm>
-            <a:off x="932688" y="1719072"/>
-            <a:ext cx="4718303" cy="4517136"/>
+            <a:off x="932688" y="1609344"/>
+            <a:ext cx="4718303" cy="4645152"/>
           </a:xfrm>
           <a:prstGeom prst="rect">
             <a:avLst/>
@@ -6060,11 +6329,11 @@
           <a:p>
             <a:pPr>
               <a:spcAft>
-                <a:spcPts val="1000"/>
+                <a:spcPts val="800"/>
               </a:spcAft>
             </a:pPr>
             <a:r>
-              <a:rPr sz="1100" b="1">
+              <a:rPr sz="1050" b="1">
                 <a:solidFill>
                   <a:srgbClr val="38BDF8"/>
                 </a:solidFill>
@@ -6073,7 +6342,7 @@
               <a:t>[OPEN SOURCE TECH STACK] </a:t>
             </a:r>
             <a:r>
-              <a:rPr sz="1600" b="1">
+              <a:rPr sz="1550" b="1">
                 <a:solidFill>
                   <a:srgbClr val="F8FAFC"/>
                 </a:solidFill>
@@ -6085,11 +6354,11 @@
           <a:p>
             <a:pPr>
               <a:spcAft>
-                <a:spcPts val="600"/>
+                <a:spcPts val="500"/>
               </a:spcAft>
             </a:pPr>
             <a:r>
-              <a:rPr sz="1250" b="1">
+              <a:rPr sz="1200" b="1">
                 <a:solidFill>
                   <a:srgbClr val="38BDF8"/>
                 </a:solidFill>
@@ -6098,7 +6367,7 @@
               <a:t>Language &amp; Package: </a:t>
             </a:r>
             <a:r>
-              <a:rPr sz="1250">
+              <a:rPr sz="1200">
                 <a:solidFill>
                   <a:srgbClr val="F8FAFC"/>
                 </a:solidFill>
@@ -6110,11 +6379,11 @@
           <a:p>
             <a:pPr>
               <a:spcAft>
-                <a:spcPts val="600"/>
+                <a:spcPts val="500"/>
               </a:spcAft>
             </a:pPr>
             <a:r>
-              <a:rPr sz="1250" b="1">
+              <a:rPr sz="1200" b="1">
                 <a:solidFill>
                   <a:srgbClr val="C084FC"/>
                 </a:solidFill>
@@ -6123,7 +6392,7 @@
               <a:t>Post-Quantum Cryptography: </a:t>
             </a:r>
             <a:r>
-              <a:rPr sz="1250">
+              <a:rPr sz="1200">
                 <a:solidFill>
                   <a:srgbClr val="F8FAFC"/>
                 </a:solidFill>
@@ -6135,11 +6404,11 @@
           <a:p>
             <a:pPr>
               <a:spcAft>
-                <a:spcPts val="600"/>
+                <a:spcPts val="500"/>
               </a:spcAft>
             </a:pPr>
             <a:r>
-              <a:rPr sz="1250" b="1">
+              <a:rPr sz="1200" b="1">
                 <a:solidFill>
                   <a:srgbClr val="F8FAFC"/>
                 </a:solidFill>
@@ -6148,7 +6417,7 @@
               <a:t>Operator Interface: </a:t>
             </a:r>
             <a:r>
-              <a:rPr sz="1250">
+              <a:rPr sz="1200">
                 <a:solidFill>
                   <a:srgbClr val="F8FAFC"/>
                 </a:solidFill>
@@ -6160,11 +6429,11 @@
           <a:p>
             <a:pPr>
               <a:spcAft>
-                <a:spcPts val="600"/>
+                <a:spcPts val="500"/>
               </a:spcAft>
             </a:pPr>
             <a:r>
-              <a:rPr sz="1250" b="1">
+              <a:rPr sz="1200" b="1">
                 <a:solidFill>
                   <a:srgbClr val="94A3B8"/>
                 </a:solidFill>
@@ -6173,7 +6442,7 @@
               <a:t>HTML Dashboard: </a:t>
             </a:r>
             <a:r>
-              <a:rPr sz="1250">
+              <a:rPr sz="1200">
                 <a:solidFill>
                   <a:srgbClr val="F8FAFC"/>
                 </a:solidFill>
@@ -6185,11 +6454,11 @@
           <a:p>
             <a:pPr>
               <a:spcAft>
-                <a:spcPts val="600"/>
+                <a:spcPts val="500"/>
               </a:spcAft>
             </a:pPr>
             <a:r>
-              <a:rPr sz="1250" b="1">
+              <a:rPr sz="1200" b="1">
                 <a:solidFill>
                   <a:srgbClr val="34D399"/>
                 </a:solidFill>
@@ -6198,7 +6467,7 @@
               <a:t>Automated Tests: </a:t>
             </a:r>
             <a:r>
-              <a:rPr sz="1250">
+              <a:rPr sz="1200">
                 <a:solidFill>
                   <a:srgbClr val="F8FAFC"/>
                 </a:solidFill>
@@ -6210,11 +6479,11 @@
           <a:p>
             <a:pPr>
               <a:spcAft>
-                <a:spcPts val="600"/>
+                <a:spcPts val="500"/>
               </a:spcAft>
             </a:pPr>
             <a:r>
-              <a:rPr sz="1250" b="1">
+              <a:rPr sz="1200" b="1">
                 <a:solidFill>
                   <a:srgbClr val="34D399"/>
                 </a:solidFill>
@@ -6223,7 +6492,7 @@
               <a:t>Licensing: </a:t>
             </a:r>
             <a:r>
-              <a:rPr sz="1250">
+              <a:rPr sz="1200">
                 <a:solidFill>
                   <a:srgbClr val="F8FAFC"/>
                 </a:solidFill>
@@ -6242,8 +6511,8 @@
         </p:nvSpPr>
         <p:spPr>
           <a:xfrm>
-            <a:off x="6217920" y="1554480"/>
-            <a:ext cx="5120640" cy="4846320"/>
+            <a:off x="6217920" y="1463040"/>
+            <a:ext cx="5120640" cy="4937760"/>
           </a:xfrm>
           <a:prstGeom prst="roundRect">
             <a:avLst/>
@@ -6287,8 +6556,8 @@
         </p:nvSpPr>
         <p:spPr>
           <a:xfrm>
-            <a:off x="6419088" y="1719072"/>
-            <a:ext cx="4718303" cy="4517136"/>
+            <a:off x="6419088" y="1609344"/>
+            <a:ext cx="4718303" cy="4645152"/>
           </a:xfrm>
           <a:prstGeom prst="rect">
             <a:avLst/>
@@ -6303,11 +6572,11 @@
           <a:p>
             <a:pPr>
               <a:spcAft>
-                <a:spcPts val="1000"/>
+                <a:spcPts val="800"/>
               </a:spcAft>
             </a:pPr>
             <a:r>
-              <a:rPr sz="1100" b="1">
+              <a:rPr sz="1050" b="1">
                 <a:solidFill>
                   <a:srgbClr val="34D399"/>
                 </a:solidFill>
@@ -6316,7 +6585,7 @@
               <a:t>[COMPLIANCE &amp; IMPACT] </a:t>
             </a:r>
             <a:r>
-              <a:rPr sz="1600" b="1">
+              <a:rPr sz="1550" b="1">
                 <a:solidFill>
                   <a:srgbClr val="F8FAFC"/>
                 </a:solidFill>
@@ -6328,11 +6597,11 @@
           <a:p>
             <a:pPr>
               <a:spcAft>
-                <a:spcPts val="600"/>
+                <a:spcPts val="500"/>
               </a:spcAft>
             </a:pPr>
             <a:r>
-              <a:rPr sz="1250" b="1">
+              <a:rPr sz="1200" b="1">
                 <a:solidFill>
                   <a:srgbClr val="34D399"/>
                 </a:solidFill>
@@ -6341,7 +6610,7 @@
               <a:t>DPDP Act 2023 Compliance: </a:t>
             </a:r>
             <a:r>
-              <a:rPr sz="1250">
+              <a:rPr sz="1200">
                 <a:solidFill>
                   <a:srgbClr val="F8FAFC"/>
                 </a:solidFill>
@@ -6353,11 +6622,11 @@
           <a:p>
             <a:pPr>
               <a:spcAft>
-                <a:spcPts val="600"/>
+                <a:spcPts val="500"/>
               </a:spcAft>
             </a:pPr>
             <a:r>
-              <a:rPr sz="1250" b="1">
+              <a:rPr sz="1200" b="1">
                 <a:solidFill>
                   <a:srgbClr val="C084FC"/>
                 </a:solidFill>
@@ -6366,7 +6635,7 @@
               <a:t>RFC 9019 Compliance: </a:t>
             </a:r>
             <a:r>
-              <a:rPr sz="1250">
+              <a:rPr sz="1200">
                 <a:solidFill>
                   <a:srgbClr val="F8FAFC"/>
                 </a:solidFill>
@@ -6378,11 +6647,11 @@
           <a:p>
             <a:pPr>
               <a:spcAft>
-                <a:spcPts val="600"/>
+                <a:spcPts val="500"/>
               </a:spcAft>
             </a:pPr>
             <a:r>
-              <a:rPr sz="1250" b="1">
+              <a:rPr sz="1200" b="1">
                 <a:solidFill>
                   <a:srgbClr val="C084FC"/>
                 </a:solidFill>
@@ -6391,7 +6660,7 @@
               <a:t>NSA CNSA 2.0 Alignment: </a:t>
             </a:r>
             <a:r>
-              <a:rPr sz="1250">
+              <a:rPr sz="1200">
                 <a:solidFill>
                   <a:srgbClr val="F8FAFC"/>
                 </a:solidFill>
@@ -6403,11 +6672,11 @@
           <a:p>
             <a:pPr>
               <a:spcAft>
-                <a:spcPts val="600"/>
+                <a:spcPts val="500"/>
               </a:spcAft>
             </a:pPr>
             <a:r>
-              <a:rPr sz="1250" b="1">
+              <a:rPr sz="1200" b="1">
                 <a:solidFill>
                   <a:srgbClr val="34D399"/>
                 </a:solidFill>
@@ -6416,7 +6685,7 @@
               <a:t>National Self-Reliance: </a:t>
             </a:r>
             <a:r>
-              <a:rPr sz="1250">
+              <a:rPr sz="1200">
                 <a:solidFill>
                   <a:srgbClr val="F8FAFC"/>
                 </a:solidFill>

</xml_diff>